<commit_message>
Launch deck: every artifact linked
</commit_message>
<xml_diff>
--- a/launch/Gengo-Marketing-Glance.pptx
+++ b/launch/Gengo-Marketing-Glance.pptx
@@ -1870,7 +1870,7 @@
         </p:blipFill>
         <p:spPr>
           <a:xfrm>
-            <a:off x="5852160" y="731520"/>
+            <a:off x="5852160" y="640080"/>
             <a:ext cx="2926080" cy="2926080"/>
           </a:xfrm>
           <a:prstGeom prst="rect">
@@ -1886,7 +1886,7 @@
         </p:nvSpPr>
         <p:spPr>
           <a:xfrm>
-            <a:off x="548640" y="1280160"/>
+            <a:off x="548640" y="1097280"/>
             <a:ext cx="5486400" cy="1005840"/>
           </a:xfrm>
           <a:prstGeom prst="rect">
@@ -1925,7 +1925,7 @@
         </p:nvSpPr>
         <p:spPr>
           <a:xfrm>
-            <a:off x="548640" y="2286000"/>
+            <a:off x="548640" y="2103120"/>
             <a:ext cx="5486400" cy="548640"/>
           </a:xfrm>
           <a:prstGeom prst="rect">
@@ -1950,7 +1950,7 @@
                 <a:ea typeface="Calibri" pitchFamily="34" charset="-122"/>
                 <a:cs typeface="Calibri" pitchFamily="34" charset="-120"/>
               </a:rPr>
-              <a:t>Marketing, at a glance</a:t>
+              <a:t>Everything we made, with links</a:t>
             </a:r>
             <a:endParaRPr lang="en-US" sz="2600" dirty="0"/>
           </a:p>
@@ -1964,7 +1964,7 @@
         </p:nvSpPr>
         <p:spPr>
           <a:xfrm>
-            <a:off x="548640" y="3017520"/>
+            <a:off x="548640" y="2834640"/>
             <a:ext cx="5486400" cy="457200"/>
           </a:xfrm>
           <a:prstGeom prst="rect">
@@ -1992,6 +1992,160 @@
               <a:t>Free · no account · budget ₹0</a:t>
             </a:r>
             <a:endParaRPr lang="en-US" sz="1600" dirty="0"/>
+          </a:p>
+        </p:txBody>
+      </p:sp>
+      <p:sp>
+        <p:nvSpPr>
+          <p:cNvPr id="6" name="Shape 3">
+            <a:hlinkClick r:id="rId2" tooltip=""/>
+          </p:cNvPr>
+          <p:cNvSpPr/>
+          <p:nvPr/>
+        </p:nvSpPr>
+        <p:spPr>
+          <a:xfrm>
+            <a:off x="457200" y="4114800"/>
+            <a:ext cx="1267358" cy="347472"/>
+          </a:xfrm>
+          <a:prstGeom prst="roundRect">
+            <a:avLst>
+              <a:gd name="adj" fmla="val 50000"/>
+            </a:avLst>
+          </a:prstGeom>
+          <a:solidFill>
+            <a:srgbClr val="FFD233"/>
+          </a:solidFill>
+          <a:ln w="12700">
+            <a:solidFill>
+              <a:srgbClr val="FFD233"/>
+            </a:solidFill>
+            <a:prstDash val="solid"/>
+          </a:ln>
+        </p:spPr>
+      </p:sp>
+      <p:sp>
+        <p:nvSpPr>
+          <p:cNvPr id="7" name="Text 4">
+            <a:hlinkClick r:id="rId3" tooltip=""/>
+          </p:cNvPr>
+          <p:cNvSpPr txBox="1"/>
+          <p:nvPr/>
+        </p:nvSpPr>
+        <p:spPr>
+          <a:xfrm>
+            <a:off x="457200" y="4114800"/>
+            <a:ext cx="1267358" cy="347472"/>
+          </a:xfrm>
+          <a:prstGeom prst="rect">
+            <a:avLst/>
+          </a:prstGeom>
+          <a:noFill/>
+          <a:ln/>
+        </p:spPr>
+        <p:txBody>
+          <a:bodyPr wrap="square" lIns="0" tIns="0" rIns="0" bIns="0" rtlCol="0" anchor="ctr"/>
+          <a:lstStyle/>
+          <a:p>
+            <a:pPr algn="ctr" indent="0" marL="0">
+              <a:buNone/>
+            </a:pPr>
+            <a:r>
+              <a:rPr lang="en-US" sz="1100" b="1" u="sng" dirty="0">
+                <a:solidFill>
+                  <a:srgbClr val="23155C"/>
+                </a:solidFill>
+                <a:latin typeface="Calibri" pitchFamily="34" charset="0"/>
+                <a:ea typeface="Calibri" pitchFamily="34" charset="-122"/>
+                <a:cs typeface="Calibri" pitchFamily="34" charset="-120"/>
+                <a:hlinkClick r:id="rId3" invalidUrl="" action="" tgtFrame="" tooltip="" history="1" highlightClick="0" endSnd="0">
+                  <a:extLst>
+                    <a:ext uri="{A12FA001-AC4F-418D-AE19-62706E023703}">
+                      <ahyp:hlinkClr xmlns:ahyp="http://schemas.microsoft.com/office/drawing/2018/hyperlinkcolor" val="tx"/>
+                    </a:ext>
+                  </a:extLst>
+                </a:hlinkClick>
+              </a:rPr>
+              <a:t>🔗 Open the app</a:t>
+            </a:r>
+            <a:endParaRPr lang="en-US" sz="1100" dirty="0"/>
+          </a:p>
+        </p:txBody>
+      </p:sp>
+      <p:sp>
+        <p:nvSpPr>
+          <p:cNvPr id="8" name="Shape 5">
+            <a:hlinkClick r:id="rId4" tooltip=""/>
+          </p:cNvPr>
+          <p:cNvSpPr/>
+          <p:nvPr/>
+        </p:nvSpPr>
+        <p:spPr>
+          <a:xfrm>
+            <a:off x="1861718" y="4114800"/>
+            <a:ext cx="1196035" cy="347472"/>
+          </a:xfrm>
+          <a:prstGeom prst="roundRect">
+            <a:avLst>
+              <a:gd name="adj" fmla="val 50000"/>
+            </a:avLst>
+          </a:prstGeom>
+          <a:solidFill>
+            <a:srgbClr val="FFD233"/>
+          </a:solidFill>
+          <a:ln w="12700">
+            <a:solidFill>
+              <a:srgbClr val="FFD233"/>
+            </a:solidFill>
+            <a:prstDash val="solid"/>
+          </a:ln>
+        </p:spPr>
+      </p:sp>
+      <p:sp>
+        <p:nvSpPr>
+          <p:cNvPr id="9" name="Text 6">
+            <a:hlinkClick r:id="rId5" tooltip=""/>
+          </p:cNvPr>
+          <p:cNvSpPr txBox="1"/>
+          <p:nvPr/>
+        </p:nvSpPr>
+        <p:spPr>
+          <a:xfrm>
+            <a:off x="1861718" y="4114800"/>
+            <a:ext cx="1196035" cy="347472"/>
+          </a:xfrm>
+          <a:prstGeom prst="rect">
+            <a:avLst/>
+          </a:prstGeom>
+          <a:noFill/>
+          <a:ln/>
+        </p:spPr>
+        <p:txBody>
+          <a:bodyPr wrap="square" lIns="0" tIns="0" rIns="0" bIns="0" rtlCol="0" anchor="ctr"/>
+          <a:lstStyle/>
+          <a:p>
+            <a:pPr algn="ctr" indent="0" marL="0">
+              <a:buNone/>
+            </a:pPr>
+            <a:r>
+              <a:rPr lang="en-US" sz="1100" b="1" u="sng" dirty="0">
+                <a:solidFill>
+                  <a:srgbClr val="23155C"/>
+                </a:solidFill>
+                <a:latin typeface="Calibri" pitchFamily="34" charset="0"/>
+                <a:ea typeface="Calibri" pitchFamily="34" charset="-122"/>
+                <a:cs typeface="Calibri" pitchFamily="34" charset="-120"/>
+                <a:hlinkClick r:id="rId5" invalidUrl="" action="" tgtFrame="" tooltip="" history="1" highlightClick="0" endSnd="0">
+                  <a:extLst>
+                    <a:ext uri="{A12FA001-AC4F-418D-AE19-62706E023703}">
+                      <ahyp:hlinkClr xmlns:ahyp="http://schemas.microsoft.com/office/drawing/2018/hyperlinkcolor" val="tx"/>
+                    </a:ext>
+                  </a:extLst>
+                </a:hlinkClick>
+              </a:rPr>
+              <a:t>🔗 GitHub repo</a:t>
+            </a:r>
+            <a:endParaRPr lang="en-US" sz="1100" dirty="0"/>
           </a:p>
         </p:txBody>
       </p:sp>
@@ -2081,8 +2235,8 @@
         </p:blipFill>
         <p:spPr>
           <a:xfrm>
-            <a:off x="457200" y="1188720"/>
-            <a:ext cx="4754880" cy="3291840"/>
+            <a:off x="457200" y="1051560"/>
+            <a:ext cx="4754880" cy="3017520"/>
           </a:xfrm>
           <a:prstGeom prst="rect">
             <a:avLst/>
@@ -2104,7 +2258,7 @@
         </p:blipFill>
         <p:spPr>
           <a:xfrm>
-            <a:off x="5486400" y="1188720"/>
+            <a:off x="5486400" y="1051560"/>
             <a:ext cx="3200400" cy="1801368"/>
           </a:xfrm>
           <a:prstGeom prst="rect">
@@ -2120,7 +2274,7 @@
         </p:nvSpPr>
         <p:spPr>
           <a:xfrm>
-            <a:off x="5486400" y="3108960"/>
+            <a:off x="5486400" y="2926080"/>
             <a:ext cx="3200400" cy="1097280"/>
           </a:xfrm>
           <a:prstGeom prst="rect">
@@ -2137,7 +2291,7 @@
               <a:buNone/>
             </a:pPr>
             <a:r>
-              <a:rPr lang="en-US" sz="1300" dirty="0">
+              <a:rPr lang="en-US" sz="1200" dirty="0">
                 <a:solidFill>
                   <a:srgbClr val="3F3866"/>
                 </a:solidFill>
@@ -2145,15 +2299,323 @@
                 <a:ea typeface="Calibri" pitchFamily="34" charset="-122"/>
                 <a:cs typeface="Calibri" pitchFamily="34" charset="-120"/>
               </a:rPr>
-              <a:t>Medium: “Meet Gengo: Turn One New Word Into a Superpower”</a:t>
-            </a:r>
-            <a:endParaRPr lang="en-US" sz="1300" dirty="0"/>
-          </a:p>
-        </p:txBody>
-      </p:sp>
-      <p:sp>
-        <p:nvSpPr>
-          <p:cNvPr id="6" name="Text 2"/>
+              <a:t>Medium: “Meet Gengo: Turn One New Word Into a Superpower” (draft, publishing next)</a:t>
+            </a:r>
+            <a:endParaRPr lang="en-US" sz="1200" dirty="0"/>
+          </a:p>
+        </p:txBody>
+      </p:sp>
+      <p:sp>
+        <p:nvSpPr>
+          <p:cNvPr id="6" name="Shape 2">
+            <a:hlinkClick r:id="rId3" tooltip=""/>
+          </p:cNvPr>
+          <p:cNvSpPr/>
+          <p:nvPr/>
+        </p:nvSpPr>
+        <p:spPr>
+          <a:xfrm>
+            <a:off x="457200" y="4206240"/>
+            <a:ext cx="1338682" cy="347472"/>
+          </a:xfrm>
+          <a:prstGeom prst="roundRect">
+            <a:avLst>
+              <a:gd name="adj" fmla="val 50000"/>
+            </a:avLst>
+          </a:prstGeom>
+          <a:solidFill>
+            <a:srgbClr val="23155C"/>
+          </a:solidFill>
+          <a:ln w="12700">
+            <a:solidFill>
+              <a:srgbClr val="23155C"/>
+            </a:solidFill>
+            <a:prstDash val="solid"/>
+          </a:ln>
+        </p:spPr>
+      </p:sp>
+      <p:sp>
+        <p:nvSpPr>
+          <p:cNvPr id="7" name="Text 3">
+            <a:hlinkClick r:id="rId4" tooltip=""/>
+          </p:cNvPr>
+          <p:cNvSpPr txBox="1"/>
+          <p:nvPr/>
+        </p:nvSpPr>
+        <p:spPr>
+          <a:xfrm>
+            <a:off x="457200" y="4206240"/>
+            <a:ext cx="1338682" cy="347472"/>
+          </a:xfrm>
+          <a:prstGeom prst="rect">
+            <a:avLst/>
+          </a:prstGeom>
+          <a:noFill/>
+          <a:ln/>
+        </p:spPr>
+        <p:txBody>
+          <a:bodyPr wrap="square" lIns="0" tIns="0" rIns="0" bIns="0" rtlCol="0" anchor="ctr"/>
+          <a:lstStyle/>
+          <a:p>
+            <a:pPr algn="ctr" indent="0" marL="0">
+              <a:buNone/>
+            </a:pPr>
+            <a:r>
+              <a:rPr lang="en-US" sz="1100" b="1" u="sng" dirty="0">
+                <a:solidFill>
+                  <a:srgbClr val="FFFFFF"/>
+                </a:solidFill>
+                <a:latin typeface="Calibri" pitchFamily="34" charset="0"/>
+                <a:ea typeface="Calibri" pitchFamily="34" charset="-122"/>
+                <a:cs typeface="Calibri" pitchFamily="34" charset="-120"/>
+                <a:hlinkClick r:id="rId4" invalidUrl="" action="" tgtFrame="" tooltip="" history="1" highlightClick="0" endSnd="0">
+                  <a:extLst>
+                    <a:ext uri="{A12FA001-AC4F-418D-AE19-62706E023703}">
+                      <ahyp:hlinkClr xmlns:ahyp="http://schemas.microsoft.com/office/drawing/2018/hyperlinkcolor" val="tx"/>
+                    </a:ext>
+                  </a:extLst>
+                </a:hlinkClick>
+              </a:rPr>
+              <a:t>🔗 Meet Gen post</a:t>
+            </a:r>
+            <a:endParaRPr lang="en-US" sz="1100" dirty="0"/>
+          </a:p>
+        </p:txBody>
+      </p:sp>
+      <p:sp>
+        <p:nvSpPr>
+          <p:cNvPr id="8" name="Shape 4">
+            <a:hlinkClick r:id="rId5" tooltip=""/>
+          </p:cNvPr>
+          <p:cNvSpPr/>
+          <p:nvPr/>
+        </p:nvSpPr>
+        <p:spPr>
+          <a:xfrm>
+            <a:off x="1933042" y="4206240"/>
+            <a:ext cx="1267358" cy="347472"/>
+          </a:xfrm>
+          <a:prstGeom prst="roundRect">
+            <a:avLst>
+              <a:gd name="adj" fmla="val 50000"/>
+            </a:avLst>
+          </a:prstGeom>
+          <a:solidFill>
+            <a:srgbClr val="23155C"/>
+          </a:solidFill>
+          <a:ln w="12700">
+            <a:solidFill>
+              <a:srgbClr val="23155C"/>
+            </a:solidFill>
+            <a:prstDash val="solid"/>
+          </a:ln>
+        </p:spPr>
+      </p:sp>
+      <p:sp>
+        <p:nvSpPr>
+          <p:cNvPr id="9" name="Text 5">
+            <a:hlinkClick r:id="rId6" tooltip=""/>
+          </p:cNvPr>
+          <p:cNvSpPr txBox="1"/>
+          <p:nvPr/>
+        </p:nvSpPr>
+        <p:spPr>
+          <a:xfrm>
+            <a:off x="1933042" y="4206240"/>
+            <a:ext cx="1267358" cy="347472"/>
+          </a:xfrm>
+          <a:prstGeom prst="rect">
+            <a:avLst/>
+          </a:prstGeom>
+          <a:noFill/>
+          <a:ln/>
+        </p:spPr>
+        <p:txBody>
+          <a:bodyPr wrap="square" lIns="0" tIns="0" rIns="0" bIns="0" rtlCol="0" anchor="ctr"/>
+          <a:lstStyle/>
+          <a:p>
+            <a:pPr algn="ctr" indent="0" marL="0">
+              <a:buNone/>
+            </a:pPr>
+            <a:r>
+              <a:rPr lang="en-US" sz="1100" b="1" u="sng" dirty="0">
+                <a:solidFill>
+                  <a:srgbClr val="FFFFFF"/>
+                </a:solidFill>
+                <a:latin typeface="Calibri" pitchFamily="34" charset="0"/>
+                <a:ea typeface="Calibri" pitchFamily="34" charset="-122"/>
+                <a:cs typeface="Calibri" pitchFamily="34" charset="-120"/>
+                <a:hlinkClick r:id="rId6" invalidUrl="" action="" tgtFrame="" tooltip="" history="1" highlightClick="0" endSnd="0">
+                  <a:extLst>
+                    <a:ext uri="{A12FA001-AC4F-418D-AE19-62706E023703}">
+                      <ahyp:hlinkClr xmlns:ahyp="http://schemas.microsoft.com/office/drawing/2018/hyperlinkcolor" val="tx"/>
+                    </a:ext>
+                  </a:extLst>
+                </a:hlinkClick>
+              </a:rPr>
+              <a:t>🔗 Medium draft</a:t>
+            </a:r>
+            <a:endParaRPr lang="en-US" sz="1100" dirty="0"/>
+          </a:p>
+        </p:txBody>
+      </p:sp>
+      <p:sp>
+        <p:nvSpPr>
+          <p:cNvPr id="10" name="Shape 6">
+            <a:hlinkClick r:id="rId7" tooltip=""/>
+          </p:cNvPr>
+          <p:cNvSpPr/>
+          <p:nvPr/>
+        </p:nvSpPr>
+        <p:spPr>
+          <a:xfrm>
+            <a:off x="3337560" y="4206240"/>
+            <a:ext cx="1053389" cy="347472"/>
+          </a:xfrm>
+          <a:prstGeom prst="roundRect">
+            <a:avLst>
+              <a:gd name="adj" fmla="val 50000"/>
+            </a:avLst>
+          </a:prstGeom>
+          <a:solidFill>
+            <a:srgbClr val="23155C"/>
+          </a:solidFill>
+          <a:ln w="12700">
+            <a:solidFill>
+              <a:srgbClr val="23155C"/>
+            </a:solidFill>
+            <a:prstDash val="solid"/>
+          </a:ln>
+        </p:spPr>
+      </p:sp>
+      <p:sp>
+        <p:nvSpPr>
+          <p:cNvPr id="11" name="Text 7">
+            <a:hlinkClick r:id="rId8" tooltip=""/>
+          </p:cNvPr>
+          <p:cNvSpPr txBox="1"/>
+          <p:nvPr/>
+        </p:nvSpPr>
+        <p:spPr>
+          <a:xfrm>
+            <a:off x="3337560" y="4206240"/>
+            <a:ext cx="1053389" cy="347472"/>
+          </a:xfrm>
+          <a:prstGeom prst="rect">
+            <a:avLst/>
+          </a:prstGeom>
+          <a:noFill/>
+          <a:ln/>
+        </p:spPr>
+        <p:txBody>
+          <a:bodyPr wrap="square" lIns="0" tIns="0" rIns="0" bIns="0" rtlCol="0" anchor="ctr"/>
+          <a:lstStyle/>
+          <a:p>
+            <a:pPr algn="ctr" indent="0" marL="0">
+              <a:buNone/>
+            </a:pPr>
+            <a:r>
+              <a:rPr lang="en-US" sz="1100" b="1" u="sng" dirty="0">
+                <a:solidFill>
+                  <a:srgbClr val="FFFFFF"/>
+                </a:solidFill>
+                <a:latin typeface="Calibri" pitchFamily="34" charset="0"/>
+                <a:ea typeface="Calibri" pitchFamily="34" charset="-122"/>
+                <a:cs typeface="Calibri" pitchFamily="34" charset="-120"/>
+                <a:hlinkClick r:id="rId8" invalidUrl="" action="" tgtFrame="" tooltip="" history="1" highlightClick="0" endSnd="0">
+                  <a:extLst>
+                    <a:ext uri="{A12FA001-AC4F-418D-AE19-62706E023703}">
+                      <ahyp:hlinkClr xmlns:ahyp="http://schemas.microsoft.com/office/drawing/2018/hyperlinkcolor" val="tx"/>
+                    </a:ext>
+                  </a:extLst>
+                </a:hlinkClick>
+              </a:rPr>
+              <a:t>🔗 Blog text</a:t>
+            </a:r>
+            <a:endParaRPr lang="en-US" sz="1100" dirty="0"/>
+          </a:p>
+        </p:txBody>
+      </p:sp>
+      <p:sp>
+        <p:nvSpPr>
+          <p:cNvPr id="12" name="Shape 8">
+            <a:hlinkClick r:id="rId9" tooltip=""/>
+          </p:cNvPr>
+          <p:cNvSpPr/>
+          <p:nvPr/>
+        </p:nvSpPr>
+        <p:spPr>
+          <a:xfrm>
+            <a:off x="4528109" y="4206240"/>
+            <a:ext cx="1481328" cy="347472"/>
+          </a:xfrm>
+          <a:prstGeom prst="roundRect">
+            <a:avLst>
+              <a:gd name="adj" fmla="val 50000"/>
+            </a:avLst>
+          </a:prstGeom>
+          <a:solidFill>
+            <a:srgbClr val="23155C"/>
+          </a:solidFill>
+          <a:ln w="12700">
+            <a:solidFill>
+              <a:srgbClr val="23155C"/>
+            </a:solidFill>
+            <a:prstDash val="solid"/>
+          </a:ln>
+        </p:spPr>
+      </p:sp>
+      <p:sp>
+        <p:nvSpPr>
+          <p:cNvPr id="13" name="Text 9">
+            <a:hlinkClick r:id="rId10" tooltip=""/>
+          </p:cNvPr>
+          <p:cNvSpPr txBox="1"/>
+          <p:nvPr/>
+        </p:nvSpPr>
+        <p:spPr>
+          <a:xfrm>
+            <a:off x="4528109" y="4206240"/>
+            <a:ext cx="1481328" cy="347472"/>
+          </a:xfrm>
+          <a:prstGeom prst="rect">
+            <a:avLst/>
+          </a:prstGeom>
+          <a:noFill/>
+          <a:ln/>
+        </p:spPr>
+        <p:txBody>
+          <a:bodyPr wrap="square" lIns="0" tIns="0" rIns="0" bIns="0" rtlCol="0" anchor="ctr"/>
+          <a:lstStyle/>
+          <a:p>
+            <a:pPr algn="ctr" indent="0" marL="0">
+              <a:buNone/>
+            </a:pPr>
+            <a:r>
+              <a:rPr lang="en-US" sz="1100" b="1" u="sng" dirty="0">
+                <a:solidFill>
+                  <a:srgbClr val="FFFFFF"/>
+                </a:solidFill>
+                <a:latin typeface="Calibri" pitchFamily="34" charset="0"/>
+                <a:ea typeface="Calibri" pitchFamily="34" charset="-122"/>
+                <a:cs typeface="Calibri" pitchFamily="34" charset="-120"/>
+                <a:hlinkClick r:id="rId10" invalidUrl="" action="" tgtFrame="" tooltip="" history="1" highlightClick="0" endSnd="0">
+                  <a:extLst>
+                    <a:ext uri="{A12FA001-AC4F-418D-AE19-62706E023703}">
+                      <ahyp:hlinkClr xmlns:ahyp="http://schemas.microsoft.com/office/drawing/2018/hyperlinkcolor" val="tx"/>
+                    </a:ext>
+                  </a:extLst>
+                </a:hlinkClick>
+              </a:rPr>
+              <a:t>🔗 Campaign images</a:t>
+            </a:r>
+            <a:endParaRPr lang="en-US" sz="1100" dirty="0"/>
+          </a:p>
+        </p:txBody>
+      </p:sp>
+      <p:sp>
+        <p:nvSpPr>
+          <p:cNvPr id="14" name="Text 10"/>
           <p:cNvSpPr txBox="1"/>
           <p:nvPr/>
         </p:nvSpPr>
@@ -2277,8 +2739,8 @@
         </p:blipFill>
         <p:spPr>
           <a:xfrm>
-            <a:off x="457200" y="1188720"/>
-            <a:ext cx="2926080" cy="2926080"/>
+            <a:off x="457200" y="1051560"/>
+            <a:ext cx="2743200" cy="2743200"/>
           </a:xfrm>
           <a:prstGeom prst="rect">
             <a:avLst/>
@@ -2300,7 +2762,7 @@
         </p:blipFill>
         <p:spPr>
           <a:xfrm>
-            <a:off x="3749040" y="1188720"/>
+            <a:off x="3749040" y="1051560"/>
             <a:ext cx="4937760" cy="2779776"/>
           </a:xfrm>
           <a:prstGeom prst="rect">
@@ -2316,12 +2778,12 @@
         </p:nvSpPr>
         <p:spPr>
           <a:xfrm>
-            <a:off x="3749040" y="4114800"/>
-            <a:ext cx="914400" cy="411480"/>
+            <a:off x="457200" y="3703320"/>
+            <a:ext cx="502920" cy="320040"/>
           </a:xfrm>
           <a:prstGeom prst="roundRect">
             <a:avLst>
-              <a:gd name="adj" fmla="val 22222"/>
+              <a:gd name="adj" fmla="val 28571"/>
             </a:avLst>
           </a:prstGeom>
           <a:solidFill>
@@ -2343,12 +2805,12 @@
         </p:nvSpPr>
         <p:spPr>
           <a:xfrm>
-            <a:off x="4754880" y="4114800"/>
-            <a:ext cx="914400" cy="411480"/>
+            <a:off x="1024128" y="3703320"/>
+            <a:ext cx="502920" cy="320040"/>
           </a:xfrm>
           <a:prstGeom prst="roundRect">
             <a:avLst>
-              <a:gd name="adj" fmla="val 22222"/>
+              <a:gd name="adj" fmla="val 28571"/>
             </a:avLst>
           </a:prstGeom>
           <a:solidFill>
@@ -2370,12 +2832,12 @@
         </p:nvSpPr>
         <p:spPr>
           <a:xfrm>
-            <a:off x="5760720" y="4114800"/>
-            <a:ext cx="914400" cy="411480"/>
+            <a:off x="1591056" y="3703320"/>
+            <a:ext cx="502920" cy="320040"/>
           </a:xfrm>
           <a:prstGeom prst="roundRect">
             <a:avLst>
-              <a:gd name="adj" fmla="val 22222"/>
+              <a:gd name="adj" fmla="val 28571"/>
             </a:avLst>
           </a:prstGeom>
           <a:solidFill>
@@ -2397,12 +2859,12 @@
         </p:nvSpPr>
         <p:spPr>
           <a:xfrm>
-            <a:off x="6766560" y="4114800"/>
-            <a:ext cx="914400" cy="411480"/>
+            <a:off x="2157984" y="3703320"/>
+            <a:ext cx="502920" cy="320040"/>
           </a:xfrm>
           <a:prstGeom prst="roundRect">
             <a:avLst>
-              <a:gd name="adj" fmla="val 22222"/>
+              <a:gd name="adj" fmla="val 28571"/>
             </a:avLst>
           </a:prstGeom>
           <a:solidFill>
@@ -2424,12 +2886,12 @@
         </p:nvSpPr>
         <p:spPr>
           <a:xfrm>
-            <a:off x="7772400" y="4114800"/>
-            <a:ext cx="914400" cy="411480"/>
+            <a:off x="2724912" y="3703320"/>
+            <a:ext cx="502920" cy="320040"/>
           </a:xfrm>
           <a:prstGeom prst="roundRect">
             <a:avLst>
-              <a:gd name="adj" fmla="val 22222"/>
+              <a:gd name="adj" fmla="val 28571"/>
             </a:avLst>
           </a:prstGeom>
           <a:solidFill>
@@ -2445,7 +2907,161 @@
       </p:sp>
       <p:sp>
         <p:nvSpPr>
-          <p:cNvPr id="10" name="Text 6"/>
+          <p:cNvPr id="10" name="Shape 6">
+            <a:hlinkClick r:id="rId3" tooltip=""/>
+          </p:cNvPr>
+          <p:cNvSpPr/>
+          <p:nvPr/>
+        </p:nvSpPr>
+        <p:spPr>
+          <a:xfrm>
+            <a:off x="457200" y="4206240"/>
+            <a:ext cx="1766621" cy="347472"/>
+          </a:xfrm>
+          <a:prstGeom prst="roundRect">
+            <a:avLst>
+              <a:gd name="adj" fmla="val 50000"/>
+            </a:avLst>
+          </a:prstGeom>
+          <a:solidFill>
+            <a:srgbClr val="23155C"/>
+          </a:solidFill>
+          <a:ln w="12700">
+            <a:solidFill>
+              <a:srgbClr val="23155C"/>
+            </a:solidFill>
+            <a:prstDash val="solid"/>
+          </a:ln>
+        </p:spPr>
+      </p:sp>
+      <p:sp>
+        <p:nvSpPr>
+          <p:cNvPr id="11" name="Text 7">
+            <a:hlinkClick r:id="rId4" tooltip=""/>
+          </p:cNvPr>
+          <p:cNvSpPr txBox="1"/>
+          <p:nvPr/>
+        </p:nvSpPr>
+        <p:spPr>
+          <a:xfrm>
+            <a:off x="457200" y="4206240"/>
+            <a:ext cx="1766621" cy="347472"/>
+          </a:xfrm>
+          <a:prstGeom prst="rect">
+            <a:avLst/>
+          </a:prstGeom>
+          <a:noFill/>
+          <a:ln/>
+        </p:spPr>
+        <p:txBody>
+          <a:bodyPr wrap="square" lIns="0" tIns="0" rIns="0" bIns="0" rtlCol="0" anchor="ctr"/>
+          <a:lstStyle/>
+          <a:p>
+            <a:pPr algn="ctr" indent="0" marL="0">
+              <a:buNone/>
+            </a:pPr>
+            <a:r>
+              <a:rPr lang="en-US" sz="1100" b="1" u="sng" dirty="0">
+                <a:solidFill>
+                  <a:srgbClr val="FFFFFF"/>
+                </a:solidFill>
+                <a:latin typeface="Calibri" pitchFamily="34" charset="0"/>
+                <a:ea typeface="Calibri" pitchFamily="34" charset="-122"/>
+                <a:cs typeface="Calibri" pitchFamily="34" charset="-120"/>
+                <a:hlinkClick r:id="rId4" invalidUrl="" action="" tgtFrame="" tooltip="" history="1" highlightClick="0" endSnd="0">
+                  <a:extLst>
+                    <a:ext uri="{A12FA001-AC4F-418D-AE19-62706E023703}">
+                      <ahyp:hlinkClr xmlns:ahyp="http://schemas.microsoft.com/office/drawing/2018/hyperlinkcolor" val="tx"/>
+                    </a:ext>
+                  </a:extLst>
+                </a:hlinkClick>
+              </a:rPr>
+              <a:t>🔗 Gen artwork + icons</a:t>
+            </a:r>
+            <a:endParaRPr lang="en-US" sz="1100" dirty="0"/>
+          </a:p>
+        </p:txBody>
+      </p:sp>
+      <p:sp>
+        <p:nvSpPr>
+          <p:cNvPr id="12" name="Shape 8">
+            <a:hlinkClick r:id="rId5" tooltip=""/>
+          </p:cNvPr>
+          <p:cNvSpPr/>
+          <p:nvPr/>
+        </p:nvSpPr>
+        <p:spPr>
+          <a:xfrm>
+            <a:off x="2360981" y="4206240"/>
+            <a:ext cx="2907792" cy="347472"/>
+          </a:xfrm>
+          <a:prstGeom prst="roundRect">
+            <a:avLst>
+              <a:gd name="adj" fmla="val 50000"/>
+            </a:avLst>
+          </a:prstGeom>
+          <a:solidFill>
+            <a:srgbClr val="23155C"/>
+          </a:solidFill>
+          <a:ln w="12700">
+            <a:solidFill>
+              <a:srgbClr val="23155C"/>
+            </a:solidFill>
+            <a:prstDash val="solid"/>
+          </a:ln>
+        </p:spPr>
+      </p:sp>
+      <p:sp>
+        <p:nvSpPr>
+          <p:cNvPr id="13" name="Text 9">
+            <a:hlinkClick r:id="rId6" tooltip=""/>
+          </p:cNvPr>
+          <p:cNvSpPr txBox="1"/>
+          <p:nvPr/>
+        </p:nvSpPr>
+        <p:spPr>
+          <a:xfrm>
+            <a:off x="2360981" y="4206240"/>
+            <a:ext cx="2907792" cy="347472"/>
+          </a:xfrm>
+          <a:prstGeom prst="rect">
+            <a:avLst/>
+          </a:prstGeom>
+          <a:noFill/>
+          <a:ln/>
+        </p:spPr>
+        <p:txBody>
+          <a:bodyPr wrap="square" lIns="0" tIns="0" rIns="0" bIns="0" rtlCol="0" anchor="ctr"/>
+          <a:lstStyle/>
+          <a:p>
+            <a:pPr algn="ctr" indent="0" marL="0">
+              <a:buNone/>
+            </a:pPr>
+            <a:r>
+              <a:rPr lang="en-US" sz="1100" b="1" u="sng" dirty="0">
+                <a:solidFill>
+                  <a:srgbClr val="FFFFFF"/>
+                </a:solidFill>
+                <a:latin typeface="Calibri" pitchFamily="34" charset="0"/>
+                <a:ea typeface="Calibri" pitchFamily="34" charset="-122"/>
+                <a:cs typeface="Calibri" pitchFamily="34" charset="-120"/>
+                <a:hlinkClick r:id="rId6" invalidUrl="" action="" tgtFrame="" tooltip="" history="1" highlightClick="0" endSnd="0">
+                  <a:extLst>
+                    <a:ext uri="{A12FA001-AC4F-418D-AE19-62706E023703}">
+                      <ahyp:hlinkClr xmlns:ahyp="http://schemas.microsoft.com/office/drawing/2018/hyperlinkcolor" val="tx"/>
+                    </a:ext>
+                  </a:extLst>
+                </a:hlinkClick>
+              </a:rPr>
+              <a:t>🔗 Design assets (logo, flyer, banner)</a:t>
+            </a:r>
+            <a:endParaRPr lang="en-US" sz="1100" dirty="0"/>
+          </a:p>
+        </p:txBody>
+      </p:sp>
+      <p:sp>
+        <p:nvSpPr>
+          <p:cNvPr id="14" name="Text 10"/>
           <p:cNvSpPr txBox="1"/>
           <p:nvPr/>
         </p:nvSpPr>
@@ -2561,12 +3177,12 @@
         </p:nvSpPr>
         <p:spPr>
           <a:xfrm>
-            <a:off x="457200" y="1280160"/>
-            <a:ext cx="2651760" cy="2194560"/>
+            <a:off x="457200" y="1097280"/>
+            <a:ext cx="2651760" cy="2103120"/>
           </a:xfrm>
           <a:prstGeom prst="roundRect">
             <a:avLst>
-              <a:gd name="adj" fmla="val 6250"/>
+              <a:gd name="adj" fmla="val 6522"/>
             </a:avLst>
           </a:prstGeom>
           <a:solidFill>
@@ -2588,8 +3204,8 @@
         </p:nvSpPr>
         <p:spPr>
           <a:xfrm>
-            <a:off x="457200" y="1371600"/>
-            <a:ext cx="2651760" cy="1280160"/>
+            <a:off x="457200" y="1188720"/>
+            <a:ext cx="2651760" cy="1188720"/>
           </a:xfrm>
           <a:prstGeom prst="rect">
             <a:avLst/>
@@ -2627,7 +3243,7 @@
         </p:nvSpPr>
         <p:spPr>
           <a:xfrm>
-            <a:off x="457200" y="2697480"/>
+            <a:off x="457200" y="2468880"/>
             <a:ext cx="2651760" cy="548640"/>
           </a:xfrm>
           <a:prstGeom prst="rect">
@@ -2666,12 +3282,12 @@
         </p:nvSpPr>
         <p:spPr>
           <a:xfrm>
-            <a:off x="3246120" y="1280160"/>
-            <a:ext cx="2651760" cy="2194560"/>
+            <a:off x="3246120" y="1097280"/>
+            <a:ext cx="2651760" cy="2103120"/>
           </a:xfrm>
           <a:prstGeom prst="roundRect">
             <a:avLst>
-              <a:gd name="adj" fmla="val 6250"/>
+              <a:gd name="adj" fmla="val 6522"/>
             </a:avLst>
           </a:prstGeom>
           <a:solidFill>
@@ -2693,8 +3309,8 @@
         </p:nvSpPr>
         <p:spPr>
           <a:xfrm>
-            <a:off x="3246120" y="1371600"/>
-            <a:ext cx="2651760" cy="1280160"/>
+            <a:off x="3246120" y="1188720"/>
+            <a:ext cx="2651760" cy="1188720"/>
           </a:xfrm>
           <a:prstGeom prst="rect">
             <a:avLst/>
@@ -2732,7 +3348,7 @@
         </p:nvSpPr>
         <p:spPr>
           <a:xfrm>
-            <a:off x="3246120" y="2697480"/>
+            <a:off x="3246120" y="2468880"/>
             <a:ext cx="2651760" cy="548640"/>
           </a:xfrm>
           <a:prstGeom prst="rect">
@@ -2771,12 +3387,12 @@
         </p:nvSpPr>
         <p:spPr>
           <a:xfrm>
-            <a:off x="6035040" y="1280160"/>
-            <a:ext cx="2651760" cy="2194560"/>
+            <a:off x="6035040" y="1097280"/>
+            <a:ext cx="2651760" cy="2103120"/>
           </a:xfrm>
           <a:prstGeom prst="roundRect">
             <a:avLst>
-              <a:gd name="adj" fmla="val 6250"/>
+              <a:gd name="adj" fmla="val 6522"/>
             </a:avLst>
           </a:prstGeom>
           <a:solidFill>
@@ -2798,8 +3414,8 @@
         </p:nvSpPr>
         <p:spPr>
           <a:xfrm>
-            <a:off x="6035040" y="1371600"/>
-            <a:ext cx="2651760" cy="1280160"/>
+            <a:off x="6035040" y="1188720"/>
+            <a:ext cx="2651760" cy="1188720"/>
           </a:xfrm>
           <a:prstGeom prst="rect">
             <a:avLst/>
@@ -2837,7 +3453,7 @@
         </p:nvSpPr>
         <p:spPr>
           <a:xfrm>
-            <a:off x="6035040" y="2697480"/>
+            <a:off x="6035040" y="2468880"/>
             <a:ext cx="2651760" cy="548640"/>
           </a:xfrm>
           <a:prstGeom prst="rect">
@@ -2876,7 +3492,7 @@
         </p:nvSpPr>
         <p:spPr>
           <a:xfrm>
-            <a:off x="457200" y="3840480"/>
+            <a:off x="457200" y="3429000"/>
             <a:ext cx="8229600" cy="457200"/>
           </a:xfrm>
           <a:prstGeom prst="rect">
@@ -2909,7 +3525,238 @@
       </p:sp>
       <p:sp>
         <p:nvSpPr>
-          <p:cNvPr id="13" name="Text 11"/>
+          <p:cNvPr id="13" name="Shape 11">
+            <a:hlinkClick r:id="rId1" tooltip=""/>
+          </p:cNvPr>
+          <p:cNvSpPr/>
+          <p:nvPr/>
+        </p:nvSpPr>
+        <p:spPr>
+          <a:xfrm>
+            <a:off x="457200" y="4206240"/>
+            <a:ext cx="1267358" cy="347472"/>
+          </a:xfrm>
+          <a:prstGeom prst="roundRect">
+            <a:avLst>
+              <a:gd name="adj" fmla="val 50000"/>
+            </a:avLst>
+          </a:prstGeom>
+          <a:solidFill>
+            <a:srgbClr val="FFD233"/>
+          </a:solidFill>
+          <a:ln w="12700">
+            <a:solidFill>
+              <a:srgbClr val="FFD233"/>
+            </a:solidFill>
+            <a:prstDash val="solid"/>
+          </a:ln>
+        </p:spPr>
+      </p:sp>
+      <p:sp>
+        <p:nvSpPr>
+          <p:cNvPr id="14" name="Text 12">
+            <a:hlinkClick r:id="rId2" tooltip=""/>
+          </p:cNvPr>
+          <p:cNvSpPr txBox="1"/>
+          <p:nvPr/>
+        </p:nvSpPr>
+        <p:spPr>
+          <a:xfrm>
+            <a:off x="457200" y="4206240"/>
+            <a:ext cx="1267358" cy="347472"/>
+          </a:xfrm>
+          <a:prstGeom prst="rect">
+            <a:avLst/>
+          </a:prstGeom>
+          <a:noFill/>
+          <a:ln/>
+        </p:spPr>
+        <p:txBody>
+          <a:bodyPr wrap="square" lIns="0" tIns="0" rIns="0" bIns="0" rtlCol="0" anchor="ctr"/>
+          <a:lstStyle/>
+          <a:p>
+            <a:pPr algn="ctr" indent="0" marL="0">
+              <a:buNone/>
+            </a:pPr>
+            <a:r>
+              <a:rPr lang="en-US" sz="1100" b="1" u="sng" dirty="0">
+                <a:solidFill>
+                  <a:srgbClr val="23155C"/>
+                </a:solidFill>
+                <a:latin typeface="Calibri" pitchFamily="34" charset="0"/>
+                <a:ea typeface="Calibri" pitchFamily="34" charset="-122"/>
+                <a:cs typeface="Calibri" pitchFamily="34" charset="-120"/>
+                <a:hlinkClick r:id="rId2" invalidUrl="" action="" tgtFrame="" tooltip="" history="1" highlightClick="0" endSnd="0">
+                  <a:extLst>
+                    <a:ext uri="{A12FA001-AC4F-418D-AE19-62706E023703}">
+                      <ahyp:hlinkClr xmlns:ahyp="http://schemas.microsoft.com/office/drawing/2018/hyperlinkcolor" val="tx"/>
+                    </a:ext>
+                  </a:extLst>
+                </a:hlinkClick>
+              </a:rPr>
+              <a:t>🔗 Open the app</a:t>
+            </a:r>
+            <a:endParaRPr lang="en-US" sz="1100" dirty="0"/>
+          </a:p>
+        </p:txBody>
+      </p:sp>
+      <p:sp>
+        <p:nvSpPr>
+          <p:cNvPr id="15" name="Shape 13">
+            <a:hlinkClick r:id="rId3" tooltip=""/>
+          </p:cNvPr>
+          <p:cNvSpPr/>
+          <p:nvPr/>
+        </p:nvSpPr>
+        <p:spPr>
+          <a:xfrm>
+            <a:off x="1861718" y="4206240"/>
+            <a:ext cx="1053389" cy="347472"/>
+          </a:xfrm>
+          <a:prstGeom prst="roundRect">
+            <a:avLst>
+              <a:gd name="adj" fmla="val 50000"/>
+            </a:avLst>
+          </a:prstGeom>
+          <a:solidFill>
+            <a:srgbClr val="FFD233"/>
+          </a:solidFill>
+          <a:ln w="12700">
+            <a:solidFill>
+              <a:srgbClr val="FFD233"/>
+            </a:solidFill>
+            <a:prstDash val="solid"/>
+          </a:ln>
+        </p:spPr>
+      </p:sp>
+      <p:sp>
+        <p:nvSpPr>
+          <p:cNvPr id="16" name="Text 14">
+            <a:hlinkClick r:id="rId4" tooltip=""/>
+          </p:cNvPr>
+          <p:cNvSpPr txBox="1"/>
+          <p:nvPr/>
+        </p:nvSpPr>
+        <p:spPr>
+          <a:xfrm>
+            <a:off x="1861718" y="4206240"/>
+            <a:ext cx="1053389" cy="347472"/>
+          </a:xfrm>
+          <a:prstGeom prst="rect">
+            <a:avLst/>
+          </a:prstGeom>
+          <a:noFill/>
+          <a:ln/>
+        </p:spPr>
+        <p:txBody>
+          <a:bodyPr wrap="square" lIns="0" tIns="0" rIns="0" bIns="0" rtlCol="0" anchor="ctr"/>
+          <a:lstStyle/>
+          <a:p>
+            <a:pPr algn="ctr" indent="0" marL="0">
+              <a:buNone/>
+            </a:pPr>
+            <a:r>
+              <a:rPr lang="en-US" sz="1100" b="1" u="sng" dirty="0">
+                <a:solidFill>
+                  <a:srgbClr val="23155C"/>
+                </a:solidFill>
+                <a:latin typeface="Calibri" pitchFamily="34" charset="0"/>
+                <a:ea typeface="Calibri" pitchFamily="34" charset="-122"/>
+                <a:cs typeface="Calibri" pitchFamily="34" charset="-120"/>
+                <a:hlinkClick r:id="rId4" invalidUrl="" action="" tgtFrame="" tooltip="" history="1" highlightClick="0" endSnd="0">
+                  <a:extLst>
+                    <a:ext uri="{A12FA001-AC4F-418D-AE19-62706E023703}">
+                      <ahyp:hlinkClr xmlns:ahyp="http://schemas.microsoft.com/office/drawing/2018/hyperlinkcolor" val="tx"/>
+                    </a:ext>
+                  </a:extLst>
+                </a:hlinkClick>
+              </a:rPr>
+              <a:t>🔗 Instagram</a:t>
+            </a:r>
+            <a:endParaRPr lang="en-US" sz="1100" dirty="0"/>
+          </a:p>
+        </p:txBody>
+      </p:sp>
+      <p:sp>
+        <p:nvSpPr>
+          <p:cNvPr id="17" name="Shape 15">
+            <a:hlinkClick r:id="rId5" tooltip=""/>
+          </p:cNvPr>
+          <p:cNvSpPr/>
+          <p:nvPr/>
+        </p:nvSpPr>
+        <p:spPr>
+          <a:xfrm>
+            <a:off x="3052267" y="4206240"/>
+            <a:ext cx="839419" cy="347472"/>
+          </a:xfrm>
+          <a:prstGeom prst="roundRect">
+            <a:avLst>
+              <a:gd name="adj" fmla="val 50000"/>
+            </a:avLst>
+          </a:prstGeom>
+          <a:solidFill>
+            <a:srgbClr val="FFD233"/>
+          </a:solidFill>
+          <a:ln w="12700">
+            <a:solidFill>
+              <a:srgbClr val="FFD233"/>
+            </a:solidFill>
+            <a:prstDash val="solid"/>
+          </a:ln>
+        </p:spPr>
+      </p:sp>
+      <p:sp>
+        <p:nvSpPr>
+          <p:cNvPr id="18" name="Text 16">
+            <a:hlinkClick r:id="rId6" tooltip=""/>
+          </p:cNvPr>
+          <p:cNvSpPr txBox="1"/>
+          <p:nvPr/>
+        </p:nvSpPr>
+        <p:spPr>
+          <a:xfrm>
+            <a:off x="3052267" y="4206240"/>
+            <a:ext cx="839419" cy="347472"/>
+          </a:xfrm>
+          <a:prstGeom prst="rect">
+            <a:avLst/>
+          </a:prstGeom>
+          <a:noFill/>
+          <a:ln/>
+        </p:spPr>
+        <p:txBody>
+          <a:bodyPr wrap="square" lIns="0" tIns="0" rIns="0" bIns="0" rtlCol="0" anchor="ctr"/>
+          <a:lstStyle/>
+          <a:p>
+            <a:pPr algn="ctr" indent="0" marL="0">
+              <a:buNone/>
+            </a:pPr>
+            <a:r>
+              <a:rPr lang="en-US" sz="1100" b="1" u="sng" dirty="0">
+                <a:solidFill>
+                  <a:srgbClr val="23155C"/>
+                </a:solidFill>
+                <a:latin typeface="Calibri" pitchFamily="34" charset="0"/>
+                <a:ea typeface="Calibri" pitchFamily="34" charset="-122"/>
+                <a:cs typeface="Calibri" pitchFamily="34" charset="-120"/>
+                <a:hlinkClick r:id="rId6" invalidUrl="" action="" tgtFrame="" tooltip="" history="1" highlightClick="0" endSnd="0">
+                  <a:extLst>
+                    <a:ext uri="{A12FA001-AC4F-418D-AE19-62706E023703}">
+                      <ahyp:hlinkClr xmlns:ahyp="http://schemas.microsoft.com/office/drawing/2018/hyperlinkcolor" val="tx"/>
+                    </a:ext>
+                  </a:extLst>
+                </a:hlinkClick>
+              </a:rPr>
+              <a:t>🔗 GitHub</a:t>
+            </a:r>
+            <a:endParaRPr lang="en-US" sz="1100" dirty="0"/>
+          </a:p>
+        </p:txBody>
+      </p:sp>
+      <p:sp>
+        <p:nvSpPr>
+          <p:cNvPr id="19" name="Text 17"/>
           <p:cNvSpPr txBox="1"/>
           <p:nvPr/>
         </p:nvSpPr>
@@ -2986,8 +3833,8 @@
         </p:nvSpPr>
         <p:spPr>
           <a:xfrm>
-            <a:off x="640080" y="822960"/>
-            <a:ext cx="7863840" cy="2194560"/>
+            <a:off x="640080" y="731520"/>
+            <a:ext cx="7863840" cy="2103120"/>
           </a:xfrm>
           <a:prstGeom prst="rect">
             <a:avLst/>
@@ -3059,7 +3906,7 @@
         </p:nvSpPr>
         <p:spPr>
           <a:xfrm>
-            <a:off x="640080" y="3108960"/>
+            <a:off x="640080" y="2926080"/>
             <a:ext cx="7863840" cy="822960"/>
           </a:xfrm>
           <a:prstGeom prst="rect">
@@ -3098,8 +3945,8 @@
         </p:nvSpPr>
         <p:spPr>
           <a:xfrm>
-            <a:off x="640080" y="4023360"/>
-            <a:ext cx="7863840" cy="457200"/>
+            <a:off x="640080" y="3749040"/>
+            <a:ext cx="7863840" cy="365760"/>
           </a:xfrm>
           <a:prstGeom prst="rect">
             <a:avLst/>
@@ -3131,7 +3978,84 @@
       </p:sp>
       <p:sp>
         <p:nvSpPr>
-          <p:cNvPr id="5" name="Text 3"/>
+          <p:cNvPr id="5" name="Shape 3">
+            <a:hlinkClick r:id="rId1" tooltip=""/>
+          </p:cNvPr>
+          <p:cNvSpPr/>
+          <p:nvPr/>
+        </p:nvSpPr>
+        <p:spPr>
+          <a:xfrm>
+            <a:off x="457200" y="4206240"/>
+            <a:ext cx="2265883" cy="347472"/>
+          </a:xfrm>
+          <a:prstGeom prst="roundRect">
+            <a:avLst>
+              <a:gd name="adj" fmla="val 50000"/>
+            </a:avLst>
+          </a:prstGeom>
+          <a:solidFill>
+            <a:srgbClr val="FFD233"/>
+          </a:solidFill>
+          <a:ln w="12700">
+            <a:solidFill>
+              <a:srgbClr val="FFD233"/>
+            </a:solidFill>
+            <a:prstDash val="solid"/>
+          </a:ln>
+        </p:spPr>
+      </p:sp>
+      <p:sp>
+        <p:nvSpPr>
+          <p:cNvPr id="6" name="Text 4">
+            <a:hlinkClick r:id="rId2" tooltip=""/>
+          </p:cNvPr>
+          <p:cNvSpPr txBox="1"/>
+          <p:nvPr/>
+        </p:nvSpPr>
+        <p:spPr>
+          <a:xfrm>
+            <a:off x="457200" y="4206240"/>
+            <a:ext cx="2265883" cy="347472"/>
+          </a:xfrm>
+          <a:prstGeom prst="rect">
+            <a:avLst/>
+          </a:prstGeom>
+          <a:noFill/>
+          <a:ln/>
+        </p:spPr>
+        <p:txBody>
+          <a:bodyPr wrap="square" lIns="0" tIns="0" rIns="0" bIns="0" rtlCol="0" anchor="ctr"/>
+          <a:lstStyle/>
+          <a:p>
+            <a:pPr algn="ctr" indent="0" marL="0">
+              <a:buNone/>
+            </a:pPr>
+            <a:r>
+              <a:rPr lang="en-US" sz="1100" b="1" u="sng" dirty="0">
+                <a:solidFill>
+                  <a:srgbClr val="23155C"/>
+                </a:solidFill>
+                <a:latin typeface="Calibri" pitchFamily="34" charset="0"/>
+                <a:ea typeface="Calibri" pitchFamily="34" charset="-122"/>
+                <a:cs typeface="Calibri" pitchFamily="34" charset="-120"/>
+                <a:hlinkClick r:id="rId2" invalidUrl="" action="" tgtFrame="" tooltip="" history="1" highlightClick="0" endSnd="0">
+                  <a:extLst>
+                    <a:ext uri="{A12FA001-AC4F-418D-AE19-62706E023703}">
+                      <ahyp:hlinkClr xmlns:ahyp="http://schemas.microsoft.com/office/drawing/2018/hyperlinkcolor" val="tx"/>
+                    </a:ext>
+                  </a:extLst>
+                </a:hlinkClick>
+              </a:rPr>
+              <a:t>🔗 Launch note: who it is for</a:t>
+            </a:r>
+            <a:endParaRPr lang="en-US" sz="1100" dirty="0"/>
+          </a:p>
+        </p:txBody>
+      </p:sp>
+      <p:sp>
+        <p:nvSpPr>
+          <p:cNvPr id="7" name="Text 5"/>
           <p:cNvSpPr txBox="1"/>
           <p:nvPr/>
         </p:nvSpPr>
@@ -3254,8 +4178,8 @@
         </p:blipFill>
         <p:spPr>
           <a:xfrm>
-            <a:off x="777240" y="1097280"/>
-            <a:ext cx="1371600" cy="2834640"/>
+            <a:off x="777240" y="1051560"/>
+            <a:ext cx="1371600" cy="2468880"/>
           </a:xfrm>
           <a:prstGeom prst="rect">
             <a:avLst/>
@@ -3270,7 +4194,7 @@
         </p:nvSpPr>
         <p:spPr>
           <a:xfrm>
-            <a:off x="457200" y="4023360"/>
+            <a:off x="457200" y="3566160"/>
             <a:ext cx="2011680" cy="365760"/>
           </a:xfrm>
           <a:prstGeom prst="rect">
@@ -3316,8 +4240,8 @@
         </p:blipFill>
         <p:spPr>
           <a:xfrm>
-            <a:off x="2880360" y="1097280"/>
-            <a:ext cx="1371600" cy="2834640"/>
+            <a:off x="2880360" y="1051560"/>
+            <a:ext cx="1371600" cy="2468880"/>
           </a:xfrm>
           <a:prstGeom prst="rect">
             <a:avLst/>
@@ -3332,7 +4256,7 @@
         </p:nvSpPr>
         <p:spPr>
           <a:xfrm>
-            <a:off x="2560320" y="4023360"/>
+            <a:off x="2560320" y="3566160"/>
             <a:ext cx="2011680" cy="365760"/>
           </a:xfrm>
           <a:prstGeom prst="rect">
@@ -3378,8 +4302,8 @@
         </p:blipFill>
         <p:spPr>
           <a:xfrm>
-            <a:off x="4983480" y="1097280"/>
-            <a:ext cx="1371600" cy="2834640"/>
+            <a:off x="4983480" y="1051560"/>
+            <a:ext cx="1371600" cy="2468880"/>
           </a:xfrm>
           <a:prstGeom prst="rect">
             <a:avLst/>
@@ -3394,7 +4318,7 @@
         </p:nvSpPr>
         <p:spPr>
           <a:xfrm>
-            <a:off x="4663440" y="4023360"/>
+            <a:off x="4663440" y="3566160"/>
             <a:ext cx="2011680" cy="365760"/>
           </a:xfrm>
           <a:prstGeom prst="rect">
@@ -3440,8 +4364,8 @@
         </p:blipFill>
         <p:spPr>
           <a:xfrm>
-            <a:off x="7086600" y="1097280"/>
-            <a:ext cx="1371600" cy="2834640"/>
+            <a:off x="7086600" y="1051560"/>
+            <a:ext cx="1371600" cy="2468880"/>
           </a:xfrm>
           <a:prstGeom prst="rect">
             <a:avLst/>
@@ -3456,7 +4380,7 @@
         </p:nvSpPr>
         <p:spPr>
           <a:xfrm>
-            <a:off x="6766560" y="4023360"/>
+            <a:off x="6766560" y="3566160"/>
             <a:ext cx="2011680" cy="365760"/>
           </a:xfrm>
           <a:prstGeom prst="rect">
@@ -3489,7 +4413,315 @@
       </p:sp>
       <p:sp>
         <p:nvSpPr>
-          <p:cNvPr id="11" name="Text 5"/>
+          <p:cNvPr id="11" name="Shape 5">
+            <a:hlinkClick r:id="rId5" tooltip=""/>
+          </p:cNvPr>
+          <p:cNvSpPr/>
+          <p:nvPr/>
+        </p:nvSpPr>
+        <p:spPr>
+          <a:xfrm>
+            <a:off x="457200" y="4206240"/>
+            <a:ext cx="839419" cy="347472"/>
+          </a:xfrm>
+          <a:prstGeom prst="roundRect">
+            <a:avLst>
+              <a:gd name="adj" fmla="val 50000"/>
+            </a:avLst>
+          </a:prstGeom>
+          <a:solidFill>
+            <a:srgbClr val="23155C"/>
+          </a:solidFill>
+          <a:ln w="12700">
+            <a:solidFill>
+              <a:srgbClr val="23155C"/>
+            </a:solidFill>
+            <a:prstDash val="solid"/>
+          </a:ln>
+        </p:spPr>
+      </p:sp>
+      <p:sp>
+        <p:nvSpPr>
+          <p:cNvPr id="12" name="Text 6">
+            <a:hlinkClick r:id="rId6" tooltip=""/>
+          </p:cNvPr>
+          <p:cNvSpPr txBox="1"/>
+          <p:nvPr/>
+        </p:nvSpPr>
+        <p:spPr>
+          <a:xfrm>
+            <a:off x="457200" y="4206240"/>
+            <a:ext cx="839419" cy="347472"/>
+          </a:xfrm>
+          <a:prstGeom prst="rect">
+            <a:avLst/>
+          </a:prstGeom>
+          <a:noFill/>
+          <a:ln/>
+        </p:spPr>
+        <p:txBody>
+          <a:bodyPr wrap="square" lIns="0" tIns="0" rIns="0" bIns="0" rtlCol="0" anchor="ctr"/>
+          <a:lstStyle/>
+          <a:p>
+            <a:pPr algn="ctr" indent="0" marL="0">
+              <a:buNone/>
+            </a:pPr>
+            <a:r>
+              <a:rPr lang="en-US" sz="1100" b="1" u="sng" dirty="0">
+                <a:solidFill>
+                  <a:srgbClr val="FFFFFF"/>
+                </a:solidFill>
+                <a:latin typeface="Calibri" pitchFamily="34" charset="0"/>
+                <a:ea typeface="Calibri" pitchFamily="34" charset="-122"/>
+                <a:cs typeface="Calibri" pitchFamily="34" charset="-120"/>
+                <a:hlinkClick r:id="rId6" invalidUrl="" action="" tgtFrame="" tooltip="" history="1" highlightClick="0" endSnd="0">
+                  <a:extLst>
+                    <a:ext uri="{A12FA001-AC4F-418D-AE19-62706E023703}">
+                      <ahyp:hlinkClr xmlns:ahyp="http://schemas.microsoft.com/office/drawing/2018/hyperlinkcolor" val="tx"/>
+                    </a:ext>
+                  </a:extLst>
+                </a:hlinkClick>
+              </a:rPr>
+              <a:t>🔗 Try it</a:t>
+            </a:r>
+            <a:endParaRPr lang="en-US" sz="1100" dirty="0"/>
+          </a:p>
+        </p:txBody>
+      </p:sp>
+      <p:sp>
+        <p:nvSpPr>
+          <p:cNvPr id="13" name="Shape 7">
+            <a:hlinkClick r:id="rId7" tooltip=""/>
+          </p:cNvPr>
+          <p:cNvSpPr/>
+          <p:nvPr/>
+        </p:nvSpPr>
+        <p:spPr>
+          <a:xfrm>
+            <a:off x="1433779" y="4206240"/>
+            <a:ext cx="1124712" cy="347472"/>
+          </a:xfrm>
+          <a:prstGeom prst="roundRect">
+            <a:avLst>
+              <a:gd name="adj" fmla="val 50000"/>
+            </a:avLst>
+          </a:prstGeom>
+          <a:solidFill>
+            <a:srgbClr val="23155C"/>
+          </a:solidFill>
+          <a:ln w="12700">
+            <a:solidFill>
+              <a:srgbClr val="23155C"/>
+            </a:solidFill>
+            <a:prstDash val="solid"/>
+          </a:ln>
+        </p:spPr>
+      </p:sp>
+      <p:sp>
+        <p:nvSpPr>
+          <p:cNvPr id="14" name="Text 8">
+            <a:hlinkClick r:id="rId8" tooltip=""/>
+          </p:cNvPr>
+          <p:cNvSpPr txBox="1"/>
+          <p:nvPr/>
+        </p:nvSpPr>
+        <p:spPr>
+          <a:xfrm>
+            <a:off x="1433779" y="4206240"/>
+            <a:ext cx="1124712" cy="347472"/>
+          </a:xfrm>
+          <a:prstGeom prst="rect">
+            <a:avLst/>
+          </a:prstGeom>
+          <a:noFill/>
+          <a:ln/>
+        </p:spPr>
+        <p:txBody>
+          <a:bodyPr wrap="square" lIns="0" tIns="0" rIns="0" bIns="0" rtlCol="0" anchor="ctr"/>
+          <a:lstStyle/>
+          <a:p>
+            <a:pPr algn="ctr" indent="0" marL="0">
+              <a:buNone/>
+            </a:pPr>
+            <a:r>
+              <a:rPr lang="en-US" sz="1100" b="1" u="sng" dirty="0">
+                <a:solidFill>
+                  <a:srgbClr val="FFFFFF"/>
+                </a:solidFill>
+                <a:latin typeface="Calibri" pitchFamily="34" charset="0"/>
+                <a:ea typeface="Calibri" pitchFamily="34" charset="-122"/>
+                <a:cs typeface="Calibri" pitchFamily="34" charset="-120"/>
+                <a:hlinkClick r:id="rId8" invalidUrl="" action="" tgtFrame="" tooltip="" history="1" highlightClick="0" endSnd="0">
+                  <a:extLst>
+                    <a:ext uri="{A12FA001-AC4F-418D-AE19-62706E023703}">
+                      <ahyp:hlinkClr xmlns:ahyp="http://schemas.microsoft.com/office/drawing/2018/hyperlinkcolor" val="tx"/>
+                    </a:ext>
+                  </a:extLst>
+                </a:hlinkClick>
+              </a:rPr>
+              <a:t>🔗 User guide</a:t>
+            </a:r>
+            <a:endParaRPr lang="en-US" sz="1100" dirty="0"/>
+          </a:p>
+        </p:txBody>
+      </p:sp>
+      <p:sp>
+        <p:nvSpPr>
+          <p:cNvPr id="15" name="Shape 9">
+            <a:hlinkClick r:id="rId9" tooltip=""/>
+          </p:cNvPr>
+          <p:cNvSpPr/>
+          <p:nvPr/>
+        </p:nvSpPr>
+        <p:spPr>
+          <a:xfrm>
+            <a:off x="2695651" y="4206240"/>
+            <a:ext cx="1623974" cy="347472"/>
+          </a:xfrm>
+          <a:prstGeom prst="roundRect">
+            <a:avLst>
+              <a:gd name="adj" fmla="val 50000"/>
+            </a:avLst>
+          </a:prstGeom>
+          <a:solidFill>
+            <a:srgbClr val="23155C"/>
+          </a:solidFill>
+          <a:ln w="12700">
+            <a:solidFill>
+              <a:srgbClr val="23155C"/>
+            </a:solidFill>
+            <a:prstDash val="solid"/>
+          </a:ln>
+        </p:spPr>
+      </p:sp>
+      <p:sp>
+        <p:nvSpPr>
+          <p:cNvPr id="16" name="Text 10">
+            <a:hlinkClick r:id="rId10" tooltip=""/>
+          </p:cNvPr>
+          <p:cNvSpPr txBox="1"/>
+          <p:nvPr/>
+        </p:nvSpPr>
+        <p:spPr>
+          <a:xfrm>
+            <a:off x="2695651" y="4206240"/>
+            <a:ext cx="1623974" cy="347472"/>
+          </a:xfrm>
+          <a:prstGeom prst="rect">
+            <a:avLst/>
+          </a:prstGeom>
+          <a:noFill/>
+          <a:ln/>
+        </p:spPr>
+        <p:txBody>
+          <a:bodyPr wrap="square" lIns="0" tIns="0" rIns="0" bIns="0" rtlCol="0" anchor="ctr"/>
+          <a:lstStyle/>
+          <a:p>
+            <a:pPr algn="ctr" indent="0" marL="0">
+              <a:buNone/>
+            </a:pPr>
+            <a:r>
+              <a:rPr lang="en-US" sz="1100" b="1" u="sng" dirty="0">
+                <a:solidFill>
+                  <a:srgbClr val="FFFFFF"/>
+                </a:solidFill>
+                <a:latin typeface="Calibri" pitchFamily="34" charset="0"/>
+                <a:ea typeface="Calibri" pitchFamily="34" charset="-122"/>
+                <a:cs typeface="Calibri" pitchFamily="34" charset="-120"/>
+                <a:hlinkClick r:id="rId10" invalidUrl="" action="" tgtFrame="" tooltip="" history="1" highlightClick="0" endSnd="0">
+                  <a:extLst>
+                    <a:ext uri="{A12FA001-AC4F-418D-AE19-62706E023703}">
+                      <ahyp:hlinkClr xmlns:ahyp="http://schemas.microsoft.com/office/drawing/2018/hyperlinkcolor" val="tx"/>
+                    </a:ext>
+                  </a:extLst>
+                </a:hlinkClick>
+              </a:rPr>
+              <a:t>🔗 UI/UX walkthrough</a:t>
+            </a:r>
+            <a:endParaRPr lang="en-US" sz="1100" dirty="0"/>
+          </a:p>
+        </p:txBody>
+      </p:sp>
+      <p:sp>
+        <p:nvSpPr>
+          <p:cNvPr id="17" name="Shape 11">
+            <a:hlinkClick r:id="rId11" tooltip=""/>
+          </p:cNvPr>
+          <p:cNvSpPr/>
+          <p:nvPr/>
+        </p:nvSpPr>
+        <p:spPr>
+          <a:xfrm>
+            <a:off x="4456786" y="4206240"/>
+            <a:ext cx="839419" cy="347472"/>
+          </a:xfrm>
+          <a:prstGeom prst="roundRect">
+            <a:avLst>
+              <a:gd name="adj" fmla="val 50000"/>
+            </a:avLst>
+          </a:prstGeom>
+          <a:solidFill>
+            <a:srgbClr val="23155C"/>
+          </a:solidFill>
+          <a:ln w="12700">
+            <a:solidFill>
+              <a:srgbClr val="23155C"/>
+            </a:solidFill>
+            <a:prstDash val="solid"/>
+          </a:ln>
+        </p:spPr>
+      </p:sp>
+      <p:sp>
+        <p:nvSpPr>
+          <p:cNvPr id="18" name="Text 12">
+            <a:hlinkClick r:id="rId12" tooltip=""/>
+          </p:cNvPr>
+          <p:cNvSpPr txBox="1"/>
+          <p:nvPr/>
+        </p:nvSpPr>
+        <p:spPr>
+          <a:xfrm>
+            <a:off x="4456786" y="4206240"/>
+            <a:ext cx="839419" cy="347472"/>
+          </a:xfrm>
+          <a:prstGeom prst="rect">
+            <a:avLst/>
+          </a:prstGeom>
+          <a:noFill/>
+          <a:ln/>
+        </p:spPr>
+        <p:txBody>
+          <a:bodyPr wrap="square" lIns="0" tIns="0" rIns="0" bIns="0" rtlCol="0" anchor="ctr"/>
+          <a:lstStyle/>
+          <a:p>
+            <a:pPr algn="ctr" indent="0" marL="0">
+              <a:buNone/>
+            </a:pPr>
+            <a:r>
+              <a:rPr lang="en-US" sz="1100" b="1" u="sng" dirty="0">
+                <a:solidFill>
+                  <a:srgbClr val="FFFFFF"/>
+                </a:solidFill>
+                <a:latin typeface="Calibri" pitchFamily="34" charset="0"/>
+                <a:ea typeface="Calibri" pitchFamily="34" charset="-122"/>
+                <a:cs typeface="Calibri" pitchFamily="34" charset="-120"/>
+                <a:hlinkClick r:id="rId12" invalidUrl="" action="" tgtFrame="" tooltip="" history="1" highlightClick="0" endSnd="0">
+                  <a:extLst>
+                    <a:ext uri="{A12FA001-AC4F-418D-AE19-62706E023703}">
+                      <ahyp:hlinkClr xmlns:ahyp="http://schemas.microsoft.com/office/drawing/2018/hyperlinkcolor" val="tx"/>
+                    </a:ext>
+                  </a:extLst>
+                </a:hlinkClick>
+              </a:rPr>
+              <a:t>🔗 README</a:t>
+            </a:r>
+            <a:endParaRPr lang="en-US" sz="1100" dirty="0"/>
+          </a:p>
+        </p:txBody>
+      </p:sp>
+      <p:sp>
+        <p:nvSpPr>
+          <p:cNvPr id="19" name="Text 13"/>
           <p:cNvSpPr txBox="1"/>
           <p:nvPr/>
         </p:nvSpPr>
@@ -3605,8 +4837,8 @@
         </p:nvSpPr>
         <p:spPr>
           <a:xfrm>
-            <a:off x="457200" y="1280160"/>
-            <a:ext cx="2651760" cy="3108960"/>
+            <a:off x="457200" y="1143000"/>
+            <a:ext cx="2651760" cy="2743200"/>
           </a:xfrm>
           <a:prstGeom prst="roundRect">
             <a:avLst>
@@ -3632,7 +4864,7 @@
         </p:nvSpPr>
         <p:spPr>
           <a:xfrm>
-            <a:off x="1325880" y="1645920"/>
+            <a:off x="1325880" y="1417320"/>
             <a:ext cx="914400" cy="914400"/>
           </a:xfrm>
           <a:prstGeom prst="ellipse">
@@ -3657,7 +4889,7 @@
         </p:nvSpPr>
         <p:spPr>
           <a:xfrm>
-            <a:off x="1325880" y="1645920"/>
+            <a:off x="1325880" y="1417320"/>
             <a:ext cx="914400" cy="914400"/>
           </a:xfrm>
           <a:prstGeom prst="rect">
@@ -3696,7 +4928,7 @@
         </p:nvSpPr>
         <p:spPr>
           <a:xfrm>
-            <a:off x="457200" y="2743200"/>
+            <a:off x="457200" y="2468880"/>
             <a:ext cx="2651760" cy="457200"/>
           </a:xfrm>
           <a:prstGeom prst="rect">
@@ -3735,7 +4967,7 @@
         </p:nvSpPr>
         <p:spPr>
           <a:xfrm>
-            <a:off x="457200" y="3200400"/>
+            <a:off x="457200" y="2926080"/>
             <a:ext cx="2651760" cy="457200"/>
           </a:xfrm>
           <a:prstGeom prst="rect">
@@ -3774,8 +5006,8 @@
         </p:nvSpPr>
         <p:spPr>
           <a:xfrm>
-            <a:off x="3246120" y="1280160"/>
-            <a:ext cx="2651760" cy="3108960"/>
+            <a:off x="3246120" y="1143000"/>
+            <a:ext cx="2651760" cy="2743200"/>
           </a:xfrm>
           <a:prstGeom prst="roundRect">
             <a:avLst>
@@ -3801,7 +5033,7 @@
         </p:nvSpPr>
         <p:spPr>
           <a:xfrm>
-            <a:off x="4114800" y="1645920"/>
+            <a:off x="4114800" y="1417320"/>
             <a:ext cx="914400" cy="914400"/>
           </a:xfrm>
           <a:prstGeom prst="ellipse">
@@ -3826,7 +5058,7 @@
         </p:nvSpPr>
         <p:spPr>
           <a:xfrm>
-            <a:off x="4114800" y="1645920"/>
+            <a:off x="4114800" y="1417320"/>
             <a:ext cx="914400" cy="914400"/>
           </a:xfrm>
           <a:prstGeom prst="rect">
@@ -3865,7 +5097,7 @@
         </p:nvSpPr>
         <p:spPr>
           <a:xfrm>
-            <a:off x="3246120" y="2743200"/>
+            <a:off x="3246120" y="2468880"/>
             <a:ext cx="2651760" cy="457200"/>
           </a:xfrm>
           <a:prstGeom prst="rect">
@@ -3904,7 +5136,7 @@
         </p:nvSpPr>
         <p:spPr>
           <a:xfrm>
-            <a:off x="3246120" y="3200400"/>
+            <a:off x="3246120" y="2926080"/>
             <a:ext cx="2651760" cy="457200"/>
           </a:xfrm>
           <a:prstGeom prst="rect">
@@ -3943,8 +5175,8 @@
         </p:nvSpPr>
         <p:spPr>
           <a:xfrm>
-            <a:off x="6035040" y="1280160"/>
-            <a:ext cx="2651760" cy="3108960"/>
+            <a:off x="6035040" y="1143000"/>
+            <a:ext cx="2651760" cy="2743200"/>
           </a:xfrm>
           <a:prstGeom prst="roundRect">
             <a:avLst>
@@ -3970,7 +5202,7 @@
         </p:nvSpPr>
         <p:spPr>
           <a:xfrm>
-            <a:off x="6903720" y="1645920"/>
+            <a:off x="6903720" y="1417320"/>
             <a:ext cx="914400" cy="914400"/>
           </a:xfrm>
           <a:prstGeom prst="ellipse">
@@ -3995,7 +5227,7 @@
         </p:nvSpPr>
         <p:spPr>
           <a:xfrm>
-            <a:off x="6903720" y="1645920"/>
+            <a:off x="6903720" y="1417320"/>
             <a:ext cx="914400" cy="914400"/>
           </a:xfrm>
           <a:prstGeom prst="rect">
@@ -4034,7 +5266,7 @@
         </p:nvSpPr>
         <p:spPr>
           <a:xfrm>
-            <a:off x="6035040" y="2743200"/>
+            <a:off x="6035040" y="2468880"/>
             <a:ext cx="2651760" cy="457200"/>
           </a:xfrm>
           <a:prstGeom prst="rect">
@@ -4073,7 +5305,7 @@
         </p:nvSpPr>
         <p:spPr>
           <a:xfrm>
-            <a:off x="6035040" y="3200400"/>
+            <a:off x="6035040" y="2926080"/>
             <a:ext cx="2651760" cy="457200"/>
           </a:xfrm>
           <a:prstGeom prst="rect">
@@ -4106,7 +5338,315 @@
       </p:sp>
       <p:sp>
         <p:nvSpPr>
-          <p:cNvPr id="18" name="Text 16"/>
+          <p:cNvPr id="18" name="Shape 16">
+            <a:hlinkClick r:id="rId1" tooltip=""/>
+          </p:cNvPr>
+          <p:cNvSpPr/>
+          <p:nvPr/>
+        </p:nvSpPr>
+        <p:spPr>
+          <a:xfrm>
+            <a:off x="457200" y="4206240"/>
+            <a:ext cx="1196035" cy="347472"/>
+          </a:xfrm>
+          <a:prstGeom prst="roundRect">
+            <a:avLst>
+              <a:gd name="adj" fmla="val 50000"/>
+            </a:avLst>
+          </a:prstGeom>
+          <a:solidFill>
+            <a:srgbClr val="23155C"/>
+          </a:solidFill>
+          <a:ln w="12700">
+            <a:solidFill>
+              <a:srgbClr val="23155C"/>
+            </a:solidFill>
+            <a:prstDash val="solid"/>
+          </a:ln>
+        </p:spPr>
+      </p:sp>
+      <p:sp>
+        <p:nvSpPr>
+          <p:cNvPr id="19" name="Text 17">
+            <a:hlinkClick r:id="rId2" tooltip=""/>
+          </p:cNvPr>
+          <p:cNvSpPr txBox="1"/>
+          <p:nvPr/>
+        </p:nvSpPr>
+        <p:spPr>
+          <a:xfrm>
+            <a:off x="457200" y="4206240"/>
+            <a:ext cx="1196035" cy="347472"/>
+          </a:xfrm>
+          <a:prstGeom prst="rect">
+            <a:avLst/>
+          </a:prstGeom>
+          <a:noFill/>
+          <a:ln/>
+        </p:spPr>
+        <p:txBody>
+          <a:bodyPr wrap="square" lIns="0" tIns="0" rIns="0" bIns="0" rtlCol="0" anchor="ctr"/>
+          <a:lstStyle/>
+          <a:p>
+            <a:pPr algn="ctr" indent="0" marL="0">
+              <a:buNone/>
+            </a:pPr>
+            <a:r>
+              <a:rPr lang="en-US" sz="1100" b="1" u="sng" dirty="0">
+                <a:solidFill>
+                  <a:srgbClr val="FFFFFF"/>
+                </a:solidFill>
+                <a:latin typeface="Calibri" pitchFamily="34" charset="0"/>
+                <a:ea typeface="Calibri" pitchFamily="34" charset="-122"/>
+                <a:cs typeface="Calibri" pitchFamily="34" charset="-120"/>
+                <a:hlinkClick r:id="rId2" invalidUrl="" action="" tgtFrame="" tooltip="" history="1" highlightClick="0" endSnd="0">
+                  <a:extLst>
+                    <a:ext uri="{A12FA001-AC4F-418D-AE19-62706E023703}">
+                      <ahyp:hlinkClr xmlns:ahyp="http://schemas.microsoft.com/office/drawing/2018/hyperlinkcolor" val="tx"/>
+                    </a:ext>
+                  </a:extLst>
+                </a:hlinkClick>
+              </a:rPr>
+              <a:t>🔗 Launch note</a:t>
+            </a:r>
+            <a:endParaRPr lang="en-US" sz="1100" dirty="0"/>
+          </a:p>
+        </p:txBody>
+      </p:sp>
+      <p:sp>
+        <p:nvSpPr>
+          <p:cNvPr id="20" name="Shape 18">
+            <a:hlinkClick r:id="rId3" tooltip=""/>
+          </p:cNvPr>
+          <p:cNvSpPr/>
+          <p:nvPr/>
+        </p:nvSpPr>
+        <p:spPr>
+          <a:xfrm>
+            <a:off x="1790395" y="4206240"/>
+            <a:ext cx="982066" cy="347472"/>
+          </a:xfrm>
+          <a:prstGeom prst="roundRect">
+            <a:avLst>
+              <a:gd name="adj" fmla="val 50000"/>
+            </a:avLst>
+          </a:prstGeom>
+          <a:solidFill>
+            <a:srgbClr val="23155C"/>
+          </a:solidFill>
+          <a:ln w="12700">
+            <a:solidFill>
+              <a:srgbClr val="23155C"/>
+            </a:solidFill>
+            <a:prstDash val="solid"/>
+          </a:ln>
+        </p:spPr>
+      </p:sp>
+      <p:sp>
+        <p:nvSpPr>
+          <p:cNvPr id="21" name="Text 19">
+            <a:hlinkClick r:id="rId4" tooltip=""/>
+          </p:cNvPr>
+          <p:cNvSpPr txBox="1"/>
+          <p:nvPr/>
+        </p:nvSpPr>
+        <p:spPr>
+          <a:xfrm>
+            <a:off x="1790395" y="4206240"/>
+            <a:ext cx="982066" cy="347472"/>
+          </a:xfrm>
+          <a:prstGeom prst="rect">
+            <a:avLst/>
+          </a:prstGeom>
+          <a:noFill/>
+          <a:ln/>
+        </p:spPr>
+        <p:txBody>
+          <a:bodyPr wrap="square" lIns="0" tIns="0" rIns="0" bIns="0" rtlCol="0" anchor="ctr"/>
+          <a:lstStyle/>
+          <a:p>
+            <a:pPr algn="ctr" indent="0" marL="0">
+              <a:buNone/>
+            </a:pPr>
+            <a:r>
+              <a:rPr lang="en-US" sz="1100" b="1" u="sng" dirty="0">
+                <a:solidFill>
+                  <a:srgbClr val="FFFFFF"/>
+                </a:solidFill>
+                <a:latin typeface="Calibri" pitchFamily="34" charset="0"/>
+                <a:ea typeface="Calibri" pitchFamily="34" charset="-122"/>
+                <a:cs typeface="Calibri" pitchFamily="34" charset="-120"/>
+                <a:hlinkClick r:id="rId4" invalidUrl="" action="" tgtFrame="" tooltip="" history="1" highlightClick="0" endSnd="0">
+                  <a:extLst>
+                    <a:ext uri="{A12FA001-AC4F-418D-AE19-62706E023703}">
+                      <ahyp:hlinkClr xmlns:ahyp="http://schemas.microsoft.com/office/drawing/2018/hyperlinkcolor" val="tx"/>
+                    </a:ext>
+                  </a:extLst>
+                </a:hlinkClick>
+              </a:rPr>
+              <a:t>🔗 Post kit</a:t>
+            </a:r>
+            <a:endParaRPr lang="en-US" sz="1100" dirty="0"/>
+          </a:p>
+        </p:txBody>
+      </p:sp>
+      <p:sp>
+        <p:nvSpPr>
+          <p:cNvPr id="22" name="Shape 20">
+            <a:hlinkClick r:id="rId5" tooltip=""/>
+          </p:cNvPr>
+          <p:cNvSpPr/>
+          <p:nvPr/>
+        </p:nvSpPr>
+        <p:spPr>
+          <a:xfrm>
+            <a:off x="2909621" y="4206240"/>
+            <a:ext cx="1410005" cy="347472"/>
+          </a:xfrm>
+          <a:prstGeom prst="roundRect">
+            <a:avLst>
+              <a:gd name="adj" fmla="val 50000"/>
+            </a:avLst>
+          </a:prstGeom>
+          <a:solidFill>
+            <a:srgbClr val="23155C"/>
+          </a:solidFill>
+          <a:ln w="12700">
+            <a:solidFill>
+              <a:srgbClr val="23155C"/>
+            </a:solidFill>
+            <a:prstDash val="solid"/>
+          </a:ln>
+        </p:spPr>
+      </p:sp>
+      <p:sp>
+        <p:nvSpPr>
+          <p:cNvPr id="23" name="Text 21">
+            <a:hlinkClick r:id="rId6" tooltip=""/>
+          </p:cNvPr>
+          <p:cNvSpPr txBox="1"/>
+          <p:nvPr/>
+        </p:nvSpPr>
+        <p:spPr>
+          <a:xfrm>
+            <a:off x="2909621" y="4206240"/>
+            <a:ext cx="1410005" cy="347472"/>
+          </a:xfrm>
+          <a:prstGeom prst="rect">
+            <a:avLst/>
+          </a:prstGeom>
+          <a:noFill/>
+          <a:ln/>
+        </p:spPr>
+        <p:txBody>
+          <a:bodyPr wrap="square" lIns="0" tIns="0" rIns="0" bIns="0" rtlCol="0" anchor="ctr"/>
+          <a:lstStyle/>
+          <a:p>
+            <a:pPr algn="ctr" indent="0" marL="0">
+              <a:buNone/>
+            </a:pPr>
+            <a:r>
+              <a:rPr lang="en-US" sz="1100" b="1" u="sng" dirty="0">
+                <a:solidFill>
+                  <a:srgbClr val="FFFFFF"/>
+                </a:solidFill>
+                <a:latin typeface="Calibri" pitchFamily="34" charset="0"/>
+                <a:ea typeface="Calibri" pitchFamily="34" charset="-122"/>
+                <a:cs typeface="Calibri" pitchFamily="34" charset="-120"/>
+                <a:hlinkClick r:id="rId6" invalidUrl="" action="" tgtFrame="" tooltip="" history="1" highlightClick="0" endSnd="0">
+                  <a:extLst>
+                    <a:ext uri="{A12FA001-AC4F-418D-AE19-62706E023703}">
+                      <ahyp:hlinkClr xmlns:ahyp="http://schemas.microsoft.com/office/drawing/2018/hyperlinkcolor" val="tx"/>
+                    </a:ext>
+                  </a:extLst>
+                </a:hlinkClick>
+              </a:rPr>
+              <a:t>🔗 Support policy</a:t>
+            </a:r>
+            <a:endParaRPr lang="en-US" sz="1100" dirty="0"/>
+          </a:p>
+        </p:txBody>
+      </p:sp>
+      <p:sp>
+        <p:nvSpPr>
+          <p:cNvPr id="24" name="Shape 22">
+            <a:hlinkClick r:id="rId7" tooltip=""/>
+          </p:cNvPr>
+          <p:cNvSpPr/>
+          <p:nvPr/>
+        </p:nvSpPr>
+        <p:spPr>
+          <a:xfrm>
+            <a:off x="4456786" y="4206240"/>
+            <a:ext cx="1196035" cy="347472"/>
+          </a:xfrm>
+          <a:prstGeom prst="roundRect">
+            <a:avLst>
+              <a:gd name="adj" fmla="val 50000"/>
+            </a:avLst>
+          </a:prstGeom>
+          <a:solidFill>
+            <a:srgbClr val="23155C"/>
+          </a:solidFill>
+          <a:ln w="12700">
+            <a:solidFill>
+              <a:srgbClr val="23155C"/>
+            </a:solidFill>
+            <a:prstDash val="solid"/>
+          </a:ln>
+        </p:spPr>
+      </p:sp>
+      <p:sp>
+        <p:nvSpPr>
+          <p:cNvPr id="25" name="Text 23">
+            <a:hlinkClick r:id="rId8" tooltip=""/>
+          </p:cNvPr>
+          <p:cNvSpPr txBox="1"/>
+          <p:nvPr/>
+        </p:nvSpPr>
+        <p:spPr>
+          <a:xfrm>
+            <a:off x="4456786" y="4206240"/>
+            <a:ext cx="1196035" cy="347472"/>
+          </a:xfrm>
+          <a:prstGeom prst="rect">
+            <a:avLst/>
+          </a:prstGeom>
+          <a:noFill/>
+          <a:ln/>
+        </p:spPr>
+        <p:txBody>
+          <a:bodyPr wrap="square" lIns="0" tIns="0" rIns="0" bIns="0" rtlCol="0" anchor="ctr"/>
+          <a:lstStyle/>
+          <a:p>
+            <a:pPr algn="ctr" indent="0" marL="0">
+              <a:buNone/>
+            </a:pPr>
+            <a:r>
+              <a:rPr lang="en-US" sz="1100" b="1" u="sng" dirty="0">
+                <a:solidFill>
+                  <a:srgbClr val="FFFFFF"/>
+                </a:solidFill>
+                <a:latin typeface="Calibri" pitchFamily="34" charset="0"/>
+                <a:ea typeface="Calibri" pitchFamily="34" charset="-122"/>
+                <a:cs typeface="Calibri" pitchFamily="34" charset="-120"/>
+                <a:hlinkClick r:id="rId8" invalidUrl="" action="" tgtFrame="" tooltip="" history="1" highlightClick="0" endSnd="0">
+                  <a:extLst>
+                    <a:ext uri="{A12FA001-AC4F-418D-AE19-62706E023703}">
+                      <ahyp:hlinkClr xmlns:ahyp="http://schemas.microsoft.com/office/drawing/2018/hyperlinkcolor" val="tx"/>
+                    </a:ext>
+                  </a:extLst>
+                </a:hlinkClick>
+              </a:rPr>
+              <a:t>🔗 Issue forms</a:t>
+            </a:r>
+            <a:endParaRPr lang="en-US" sz="1100" dirty="0"/>
+          </a:p>
+        </p:txBody>
+      </p:sp>
+      <p:sp>
+        <p:nvSpPr>
+          <p:cNvPr id="26" name="Text 24"/>
           <p:cNvSpPr txBox="1"/>
           <p:nvPr/>
         </p:nvSpPr>
@@ -4229,7 +5769,7 @@
         </p:blipFill>
         <p:spPr>
           <a:xfrm>
-            <a:off x="457200" y="1234440"/>
+            <a:off x="457200" y="1097280"/>
             <a:ext cx="5120640" cy="2697480"/>
           </a:xfrm>
           <a:prstGeom prst="rect">
@@ -4245,7 +5785,7 @@
         </p:nvSpPr>
         <p:spPr>
           <a:xfrm>
-            <a:off x="5852160" y="1234440"/>
+            <a:off x="5852160" y="1097280"/>
             <a:ext cx="2834640" cy="2697480"/>
           </a:xfrm>
           <a:prstGeom prst="roundRect">
@@ -4272,7 +5812,7 @@
         </p:nvSpPr>
         <p:spPr>
           <a:xfrm>
-            <a:off x="6035040" y="1463040"/>
+            <a:off x="6035040" y="1325880"/>
             <a:ext cx="2468880" cy="1463040"/>
           </a:xfrm>
           <a:prstGeom prst="rect">
@@ -4311,7 +5851,7 @@
         </p:nvSpPr>
         <p:spPr>
           <a:xfrm>
-            <a:off x="6035040" y="3017520"/>
+            <a:off x="6035040" y="2880360"/>
             <a:ext cx="2468880" cy="731520"/>
           </a:xfrm>
           <a:prstGeom prst="rect">
@@ -4344,14 +5884,45 @@
       </p:sp>
       <p:sp>
         <p:nvSpPr>
-          <p:cNvPr id="7" name="Text 4"/>
-          <p:cNvSpPr txBox="1"/>
-          <p:nvPr/>
-        </p:nvSpPr>
-        <p:spPr>
-          <a:xfrm>
-            <a:off x="457200" y="4114800"/>
-            <a:ext cx="8229600" cy="365760"/>
+          <p:cNvPr id="7" name="Shape 4">
+            <a:hlinkClick r:id="rId2" tooltip=""/>
+          </p:cNvPr>
+          <p:cNvSpPr/>
+          <p:nvPr/>
+        </p:nvSpPr>
+        <p:spPr>
+          <a:xfrm>
+            <a:off x="457200" y="4206240"/>
+            <a:ext cx="2051914" cy="347472"/>
+          </a:xfrm>
+          <a:prstGeom prst="roundRect">
+            <a:avLst>
+              <a:gd name="adj" fmla="val 50000"/>
+            </a:avLst>
+          </a:prstGeom>
+          <a:solidFill>
+            <a:srgbClr val="23155C"/>
+          </a:solidFill>
+          <a:ln w="12700">
+            <a:solidFill>
+              <a:srgbClr val="23155C"/>
+            </a:solidFill>
+            <a:prstDash val="solid"/>
+          </a:ln>
+        </p:spPr>
+      </p:sp>
+      <p:sp>
+        <p:nvSpPr>
+          <p:cNvPr id="8" name="Text 5">
+            <a:hlinkClick r:id="rId3" tooltip=""/>
+          </p:cNvPr>
+          <p:cNvSpPr txBox="1"/>
+          <p:nvPr/>
+        </p:nvSpPr>
+        <p:spPr>
+          <a:xfrm>
+            <a:off x="457200" y="4206240"/>
+            <a:ext cx="2051914" cy="347472"/>
           </a:xfrm>
           <a:prstGeom prst="rect">
             <a:avLst/>
@@ -4367,23 +5938,184 @@
               <a:buNone/>
             </a:pPr>
             <a:r>
-              <a:rPr lang="en-US" sz="1400" dirty="0">
-                <a:solidFill>
-                  <a:srgbClr val="3F3866"/>
-                </a:solidFill>
-                <a:latin typeface="Calibri" pitchFamily="34" charset="0"/>
-                <a:ea typeface="Calibri" pitchFamily="34" charset="-122"/>
-                <a:cs typeface="Calibri" pitchFamily="34" charset="-120"/>
-              </a:rPr>
-              <a:t>WhatsApp · LinkedIn · Reddit · X · Product Hunt</a:t>
-            </a:r>
-            <a:endParaRPr lang="en-US" sz="1400" dirty="0"/>
-          </a:p>
-        </p:txBody>
-      </p:sp>
-      <p:sp>
-        <p:nvSpPr>
-          <p:cNvPr id="8" name="Text 5"/>
+              <a:rPr lang="en-US" sz="1100" b="1" u="sng" dirty="0">
+                <a:solidFill>
+                  <a:srgbClr val="FFFFFF"/>
+                </a:solidFill>
+                <a:latin typeface="Calibri" pitchFamily="34" charset="0"/>
+                <a:ea typeface="Calibri" pitchFamily="34" charset="-122"/>
+                <a:cs typeface="Calibri" pitchFamily="34" charset="-120"/>
+                <a:hlinkClick r:id="rId3" invalidUrl="" action="" tgtFrame="" tooltip="" history="1" highlightClick="0" endSnd="0">
+                  <a:extLst>
+                    <a:ext uri="{A12FA001-AC4F-418D-AE19-62706E023703}">
+                      <ahyp:hlinkClr xmlns:ahyp="http://schemas.microsoft.com/office/drawing/2018/hyperlinkcolor" val="tx"/>
+                    </a:ext>
+                  </a:extLst>
+                </a:hlinkClick>
+              </a:rPr>
+              <a:t>🔗 Preview card (og-image)</a:t>
+            </a:r>
+            <a:endParaRPr lang="en-US" sz="1100" dirty="0"/>
+          </a:p>
+        </p:txBody>
+      </p:sp>
+      <p:sp>
+        <p:nvSpPr>
+          <p:cNvPr id="9" name="Shape 6">
+            <a:hlinkClick r:id="rId4" tooltip=""/>
+          </p:cNvPr>
+          <p:cNvSpPr/>
+          <p:nvPr/>
+        </p:nvSpPr>
+        <p:spPr>
+          <a:xfrm>
+            <a:off x="2646274" y="4206240"/>
+            <a:ext cx="3050438" cy="347472"/>
+          </a:xfrm>
+          <a:prstGeom prst="roundRect">
+            <a:avLst>
+              <a:gd name="adj" fmla="val 50000"/>
+            </a:avLst>
+          </a:prstGeom>
+          <a:solidFill>
+            <a:srgbClr val="23155C"/>
+          </a:solidFill>
+          <a:ln w="12700">
+            <a:solidFill>
+              <a:srgbClr val="23155C"/>
+            </a:solidFill>
+            <a:prstDash val="solid"/>
+          </a:ln>
+        </p:spPr>
+      </p:sp>
+      <p:sp>
+        <p:nvSpPr>
+          <p:cNvPr id="10" name="Text 7">
+            <a:hlinkClick r:id="rId5" tooltip=""/>
+          </p:cNvPr>
+          <p:cNvSpPr txBox="1"/>
+          <p:nvPr/>
+        </p:nvSpPr>
+        <p:spPr>
+          <a:xfrm>
+            <a:off x="2646274" y="4206240"/>
+            <a:ext cx="3050438" cy="347472"/>
+          </a:xfrm>
+          <a:prstGeom prst="rect">
+            <a:avLst/>
+          </a:prstGeom>
+          <a:noFill/>
+          <a:ln/>
+        </p:spPr>
+        <p:txBody>
+          <a:bodyPr wrap="square" lIns="0" tIns="0" rIns="0" bIns="0" rtlCol="0" anchor="ctr"/>
+          <a:lstStyle/>
+          <a:p>
+            <a:pPr algn="ctr" indent="0" marL="0">
+              <a:buNone/>
+            </a:pPr>
+            <a:r>
+              <a:rPr lang="en-US" sz="1100" b="1" u="sng" dirty="0">
+                <a:solidFill>
+                  <a:srgbClr val="FFFFFF"/>
+                </a:solidFill>
+                <a:latin typeface="Calibri" pitchFamily="34" charset="0"/>
+                <a:ea typeface="Calibri" pitchFamily="34" charset="-122"/>
+                <a:cs typeface="Calibri" pitchFamily="34" charset="-120"/>
+                <a:hlinkClick r:id="rId5" invalidUrl="" action="" tgtFrame="" tooltip="" history="1" highlightClick="0" endSnd="0">
+                  <a:extLst>
+                    <a:ext uri="{A12FA001-AC4F-418D-AE19-62706E023703}">
+                      <ahyp:hlinkClr xmlns:ahyp="http://schemas.microsoft.com/office/drawing/2018/hyperlinkcolor" val="tx"/>
+                    </a:ext>
+                  </a:extLst>
+                </a:hlinkClick>
+              </a:rPr>
+              <a:t>🔗 WhatsApp / LinkedIn / Reddit / X copy</a:t>
+            </a:r>
+            <a:endParaRPr lang="en-US" sz="1100" dirty="0"/>
+          </a:p>
+        </p:txBody>
+      </p:sp>
+      <p:sp>
+        <p:nvSpPr>
+          <p:cNvPr id="11" name="Shape 8">
+            <a:hlinkClick r:id="rId6" tooltip=""/>
+          </p:cNvPr>
+          <p:cNvSpPr/>
+          <p:nvPr/>
+        </p:nvSpPr>
+        <p:spPr>
+          <a:xfrm>
+            <a:off x="5833872" y="4206240"/>
+            <a:ext cx="1481328" cy="347472"/>
+          </a:xfrm>
+          <a:prstGeom prst="roundRect">
+            <a:avLst>
+              <a:gd name="adj" fmla="val 50000"/>
+            </a:avLst>
+          </a:prstGeom>
+          <a:solidFill>
+            <a:srgbClr val="23155C"/>
+          </a:solidFill>
+          <a:ln w="12700">
+            <a:solidFill>
+              <a:srgbClr val="23155C"/>
+            </a:solidFill>
+            <a:prstDash val="solid"/>
+          </a:ln>
+        </p:spPr>
+      </p:sp>
+      <p:sp>
+        <p:nvSpPr>
+          <p:cNvPr id="12" name="Text 9">
+            <a:hlinkClick r:id="rId7" tooltip=""/>
+          </p:cNvPr>
+          <p:cNvSpPr txBox="1"/>
+          <p:nvPr/>
+        </p:nvSpPr>
+        <p:spPr>
+          <a:xfrm>
+            <a:off x="5833872" y="4206240"/>
+            <a:ext cx="1481328" cy="347472"/>
+          </a:xfrm>
+          <a:prstGeom prst="rect">
+            <a:avLst/>
+          </a:prstGeom>
+          <a:noFill/>
+          <a:ln/>
+        </p:spPr>
+        <p:txBody>
+          <a:bodyPr wrap="square" lIns="0" tIns="0" rIns="0" bIns="0" rtlCol="0" anchor="ctr"/>
+          <a:lstStyle/>
+          <a:p>
+            <a:pPr algn="ctr" indent="0" marL="0">
+              <a:buNone/>
+            </a:pPr>
+            <a:r>
+              <a:rPr lang="en-US" sz="1100" b="1" u="sng" dirty="0">
+                <a:solidFill>
+                  <a:srgbClr val="FFFFFF"/>
+                </a:solidFill>
+                <a:latin typeface="Calibri" pitchFamily="34" charset="0"/>
+                <a:ea typeface="Calibri" pitchFamily="34" charset="-122"/>
+                <a:cs typeface="Calibri" pitchFamily="34" charset="-120"/>
+                <a:hlinkClick r:id="rId7" invalidUrl="" action="" tgtFrame="" tooltip="" history="1" highlightClick="0" endSnd="0">
+                  <a:extLst>
+                    <a:ext uri="{A12FA001-AC4F-418D-AE19-62706E023703}">
+                      <ahyp:hlinkClr xmlns:ahyp="http://schemas.microsoft.com/office/drawing/2018/hyperlinkcolor" val="tx"/>
+                    </a:ext>
+                  </a:extLst>
+                </a:hlinkClick>
+              </a:rPr>
+              <a:t>🔗 Installable app</a:t>
+            </a:r>
+            <a:endParaRPr lang="en-US" sz="1100" dirty="0"/>
+          </a:p>
+        </p:txBody>
+      </p:sp>
+      <p:sp>
+        <p:nvSpPr>
+          <p:cNvPr id="13" name="Text 10"/>
           <p:cNvSpPr txBox="1"/>
           <p:nvPr/>
         </p:nvSpPr>
@@ -4506,8 +6238,8 @@
         </p:blipFill>
         <p:spPr>
           <a:xfrm>
-            <a:off x="457200" y="1234440"/>
-            <a:ext cx="8229600" cy="3291840"/>
+            <a:off x="457200" y="1097280"/>
+            <a:ext cx="8229600" cy="2926080"/>
           </a:xfrm>
           <a:prstGeom prst="rect">
             <a:avLst/>
@@ -4516,7 +6248,161 @@
       </p:pic>
       <p:sp>
         <p:nvSpPr>
-          <p:cNvPr id="4" name="Text 1"/>
+          <p:cNvPr id="4" name="Shape 1">
+            <a:hlinkClick r:id="rId2" tooltip=""/>
+          </p:cNvPr>
+          <p:cNvSpPr/>
+          <p:nvPr/>
+        </p:nvSpPr>
+        <p:spPr>
+          <a:xfrm>
+            <a:off x="457200" y="4206240"/>
+            <a:ext cx="2051914" cy="347472"/>
+          </a:xfrm>
+          <a:prstGeom prst="roundRect">
+            <a:avLst>
+              <a:gd name="adj" fmla="val 50000"/>
+            </a:avLst>
+          </a:prstGeom>
+          <a:solidFill>
+            <a:srgbClr val="FFD233"/>
+          </a:solidFill>
+          <a:ln w="12700">
+            <a:solidFill>
+              <a:srgbClr val="FFD233"/>
+            </a:solidFill>
+            <a:prstDash val="solid"/>
+          </a:ln>
+        </p:spPr>
+      </p:sp>
+      <p:sp>
+        <p:nvSpPr>
+          <p:cNvPr id="5" name="Text 2">
+            <a:hlinkClick r:id="rId3" tooltip=""/>
+          </p:cNvPr>
+          <p:cNvSpPr txBox="1"/>
+          <p:nvPr/>
+        </p:nvSpPr>
+        <p:spPr>
+          <a:xfrm>
+            <a:off x="457200" y="4206240"/>
+            <a:ext cx="2051914" cy="347472"/>
+          </a:xfrm>
+          <a:prstGeom prst="rect">
+            <a:avLst/>
+          </a:prstGeom>
+          <a:noFill/>
+          <a:ln/>
+        </p:spPr>
+        <p:txBody>
+          <a:bodyPr wrap="square" lIns="0" tIns="0" rIns="0" bIns="0" rtlCol="0" anchor="ctr"/>
+          <a:lstStyle/>
+          <a:p>
+            <a:pPr algn="ctr" indent="0" marL="0">
+              <a:buNone/>
+            </a:pPr>
+            <a:r>
+              <a:rPr lang="en-US" sz="1100" b="1" u="sng" dirty="0">
+                <a:solidFill>
+                  <a:srgbClr val="23155C"/>
+                </a:solidFill>
+                <a:latin typeface="Calibri" pitchFamily="34" charset="0"/>
+                <a:ea typeface="Calibri" pitchFamily="34" charset="-122"/>
+                <a:cs typeface="Calibri" pitchFamily="34" charset="-120"/>
+                <a:hlinkClick r:id="rId3" invalidUrl="" action="" tgtFrame="" tooltip="" history="1" highlightClick="0" endSnd="0">
+                  <a:extLst>
+                    <a:ext uri="{A12FA001-AC4F-418D-AE19-62706E023703}">
+                      <ahyp:hlinkClr xmlns:ahyp="http://schemas.microsoft.com/office/drawing/2018/hyperlinkcolor" val="tx"/>
+                    </a:ext>
+                  </a:extLst>
+                </a:hlinkClick>
+              </a:rPr>
+              <a:t>🔗 ▶ Watch gengo-promo.mp4</a:t>
+            </a:r>
+            <a:endParaRPr lang="en-US" sz="1100" dirty="0"/>
+          </a:p>
+        </p:txBody>
+      </p:sp>
+      <p:sp>
+        <p:nvSpPr>
+          <p:cNvPr id="6" name="Shape 3">
+            <a:hlinkClick r:id="rId4" tooltip=""/>
+          </p:cNvPr>
+          <p:cNvSpPr/>
+          <p:nvPr/>
+        </p:nvSpPr>
+        <p:spPr>
+          <a:xfrm>
+            <a:off x="2646274" y="4206240"/>
+            <a:ext cx="1410005" cy="347472"/>
+          </a:xfrm>
+          <a:prstGeom prst="roundRect">
+            <a:avLst>
+              <a:gd name="adj" fmla="val 50000"/>
+            </a:avLst>
+          </a:prstGeom>
+          <a:solidFill>
+            <a:srgbClr val="FFD233"/>
+          </a:solidFill>
+          <a:ln w="12700">
+            <a:solidFill>
+              <a:srgbClr val="FFD233"/>
+            </a:solidFill>
+            <a:prstDash val="solid"/>
+          </a:ln>
+        </p:spPr>
+      </p:sp>
+      <p:sp>
+        <p:nvSpPr>
+          <p:cNvPr id="7" name="Text 4">
+            <a:hlinkClick r:id="rId5" tooltip=""/>
+          </p:cNvPr>
+          <p:cNvSpPr txBox="1"/>
+          <p:nvPr/>
+        </p:nvSpPr>
+        <p:spPr>
+          <a:xfrm>
+            <a:off x="2646274" y="4206240"/>
+            <a:ext cx="1410005" cy="347472"/>
+          </a:xfrm>
+          <a:prstGeom prst="rect">
+            <a:avLst/>
+          </a:prstGeom>
+          <a:noFill/>
+          <a:ln/>
+        </p:spPr>
+        <p:txBody>
+          <a:bodyPr wrap="square" lIns="0" tIns="0" rIns="0" bIns="0" rtlCol="0" anchor="ctr"/>
+          <a:lstStyle/>
+          <a:p>
+            <a:pPr algn="ctr" indent="0" marL="0">
+              <a:buNone/>
+            </a:pPr>
+            <a:r>
+              <a:rPr lang="en-US" sz="1100" b="1" u="sng" dirty="0">
+                <a:solidFill>
+                  <a:srgbClr val="23155C"/>
+                </a:solidFill>
+                <a:latin typeface="Calibri" pitchFamily="34" charset="0"/>
+                <a:ea typeface="Calibri" pitchFamily="34" charset="-122"/>
+                <a:cs typeface="Calibri" pitchFamily="34" charset="-120"/>
+                <a:hlinkClick r:id="rId5" invalidUrl="" action="" tgtFrame="" tooltip="" history="1" highlightClick="0" endSnd="0">
+                  <a:extLst>
+                    <a:ext uri="{A12FA001-AC4F-418D-AE19-62706E023703}">
+                      <ahyp:hlinkClr xmlns:ahyp="http://schemas.microsoft.com/office/drawing/2018/hyperlinkcolor" val="tx"/>
+                    </a:ext>
+                  </a:extLst>
+                </a:hlinkClick>
+              </a:rPr>
+              <a:t>🔗 File on GitHub</a:t>
+            </a:r>
+            <a:endParaRPr lang="en-US" sz="1100" dirty="0"/>
+          </a:p>
+        </p:txBody>
+      </p:sp>
+      <p:sp>
+        <p:nvSpPr>
+          <p:cNvPr id="8" name="Text 5"/>
           <p:cNvSpPr txBox="1"/>
           <p:nvPr/>
         </p:nvSpPr>
@@ -4678,8 +6564,8 @@
         </p:blipFill>
         <p:spPr>
           <a:xfrm>
-            <a:off x="457200" y="1325880"/>
-            <a:ext cx="8229600" cy="3291840"/>
+            <a:off x="457200" y="1234440"/>
+            <a:ext cx="8229600" cy="2834640"/>
           </a:xfrm>
           <a:prstGeom prst="rect">
             <a:avLst/>
@@ -4688,7 +6574,161 @@
       </p:pic>
       <p:sp>
         <p:nvSpPr>
-          <p:cNvPr id="5" name="Text 2"/>
+          <p:cNvPr id="5" name="Shape 2">
+            <a:hlinkClick r:id="rId2" tooltip=""/>
+          </p:cNvPr>
+          <p:cNvSpPr/>
+          <p:nvPr/>
+        </p:nvSpPr>
+        <p:spPr>
+          <a:xfrm>
+            <a:off x="457200" y="4206240"/>
+            <a:ext cx="1552651" cy="347472"/>
+          </a:xfrm>
+          <a:prstGeom prst="roundRect">
+            <a:avLst>
+              <a:gd name="adj" fmla="val 50000"/>
+            </a:avLst>
+          </a:prstGeom>
+          <a:solidFill>
+            <a:srgbClr val="FFD233"/>
+          </a:solidFill>
+          <a:ln w="12700">
+            <a:solidFill>
+              <a:srgbClr val="FFD233"/>
+            </a:solidFill>
+            <a:prstDash val="solid"/>
+          </a:ln>
+        </p:spPr>
+      </p:sp>
+      <p:sp>
+        <p:nvSpPr>
+          <p:cNvPr id="6" name="Text 3">
+            <a:hlinkClick r:id="rId3" tooltip=""/>
+          </p:cNvPr>
+          <p:cNvSpPr txBox="1"/>
+          <p:nvPr/>
+        </p:nvSpPr>
+        <p:spPr>
+          <a:xfrm>
+            <a:off x="457200" y="4206240"/>
+            <a:ext cx="1552651" cy="347472"/>
+          </a:xfrm>
+          <a:prstGeom prst="rect">
+            <a:avLst/>
+          </a:prstGeom>
+          <a:noFill/>
+          <a:ln/>
+        </p:spPr>
+        <p:txBody>
+          <a:bodyPr wrap="square" lIns="0" tIns="0" rIns="0" bIns="0" rtlCol="0" anchor="ctr"/>
+          <a:lstStyle/>
+          <a:p>
+            <a:pPr algn="ctr" indent="0" marL="0">
+              <a:buNone/>
+            </a:pPr>
+            <a:r>
+              <a:rPr lang="en-US" sz="1100" b="1" u="sng" dirty="0">
+                <a:solidFill>
+                  <a:srgbClr val="23155C"/>
+                </a:solidFill>
+                <a:latin typeface="Calibri" pitchFamily="34" charset="0"/>
+                <a:ea typeface="Calibri" pitchFamily="34" charset="-122"/>
+                <a:cs typeface="Calibri" pitchFamily="34" charset="-120"/>
+                <a:hlinkClick r:id="rId3" invalidUrl="" action="" tgtFrame="" tooltip="" history="1" highlightClick="0" endSnd="0">
+                  <a:extLst>
+                    <a:ext uri="{A12FA001-AC4F-418D-AE19-62706E023703}">
+                      <ahyp:hlinkClr xmlns:ahyp="http://schemas.microsoft.com/office/drawing/2018/hyperlinkcolor" val="tx"/>
+                    </a:ext>
+                  </a:extLst>
+                </a:hlinkClick>
+              </a:rPr>
+              <a:t>🔗 Open the profile</a:t>
+            </a:r>
+            <a:endParaRPr lang="en-US" sz="1100" dirty="0"/>
+          </a:p>
+        </p:txBody>
+      </p:sp>
+      <p:sp>
+        <p:nvSpPr>
+          <p:cNvPr id="7" name="Shape 4">
+            <a:hlinkClick r:id="rId4" tooltip=""/>
+          </p:cNvPr>
+          <p:cNvSpPr/>
+          <p:nvPr/>
+        </p:nvSpPr>
+        <p:spPr>
+          <a:xfrm>
+            <a:off x="2147011" y="4206240"/>
+            <a:ext cx="2194560" cy="347472"/>
+          </a:xfrm>
+          <a:prstGeom prst="roundRect">
+            <a:avLst>
+              <a:gd name="adj" fmla="val 50000"/>
+            </a:avLst>
+          </a:prstGeom>
+          <a:solidFill>
+            <a:srgbClr val="FFD233"/>
+          </a:solidFill>
+          <a:ln w="12700">
+            <a:solidFill>
+              <a:srgbClr val="FFD233"/>
+            </a:solidFill>
+            <a:prstDash val="solid"/>
+          </a:ln>
+        </p:spPr>
+      </p:sp>
+      <p:sp>
+        <p:nvSpPr>
+          <p:cNvPr id="8" name="Text 5">
+            <a:hlinkClick r:id="rId5" tooltip=""/>
+          </p:cNvPr>
+          <p:cNvSpPr txBox="1"/>
+          <p:nvPr/>
+        </p:nvSpPr>
+        <p:spPr>
+          <a:xfrm>
+            <a:off x="2147011" y="4206240"/>
+            <a:ext cx="2194560" cy="347472"/>
+          </a:xfrm>
+          <a:prstGeom prst="rect">
+            <a:avLst/>
+          </a:prstGeom>
+          <a:noFill/>
+          <a:ln/>
+        </p:spPr>
+        <p:txBody>
+          <a:bodyPr wrap="square" lIns="0" tIns="0" rIns="0" bIns="0" rtlCol="0" anchor="ctr"/>
+          <a:lstStyle/>
+          <a:p>
+            <a:pPr algn="ctr" indent="0" marL="0">
+              <a:buNone/>
+            </a:pPr>
+            <a:r>
+              <a:rPr lang="en-US" sz="1100" b="1" u="sng" dirty="0">
+                <a:solidFill>
+                  <a:srgbClr val="23155C"/>
+                </a:solidFill>
+                <a:latin typeface="Calibri" pitchFamily="34" charset="0"/>
+                <a:ea typeface="Calibri" pitchFamily="34" charset="-122"/>
+                <a:cs typeface="Calibri" pitchFamily="34" charset="-120"/>
+                <a:hlinkClick r:id="rId5" invalidUrl="" action="" tgtFrame="" tooltip="" history="1" highlightClick="0" endSnd="0">
+                  <a:extLst>
+                    <a:ext uri="{A12FA001-AC4F-418D-AE19-62706E023703}">
+                      <ahyp:hlinkClr xmlns:ahyp="http://schemas.microsoft.com/office/drawing/2018/hyperlinkcolor" val="tx"/>
+                    </a:ext>
+                  </a:extLst>
+                </a:hlinkClick>
+              </a:rPr>
+              <a:t>🔗 All post files + captions</a:t>
+            </a:r>
+            <a:endParaRPr lang="en-US" sz="1100" dirty="0"/>
+          </a:p>
+        </p:txBody>
+      </p:sp>
+      <p:sp>
+        <p:nvSpPr>
+          <p:cNvPr id="9" name="Text 6"/>
           <p:cNvSpPr txBox="1"/>
           <p:nvPr/>
         </p:nvSpPr>
@@ -4796,48 +6836,9 @@
           </a:p>
         </p:txBody>
       </p:sp>
-      <p:sp>
-        <p:nvSpPr>
-          <p:cNvPr id="3" name="Text 1"/>
-          <p:cNvSpPr txBox="1"/>
-          <p:nvPr/>
-        </p:nvSpPr>
-        <p:spPr>
-          <a:xfrm>
-            <a:off x="457200" y="868680"/>
-            <a:ext cx="8229600" cy="365760"/>
-          </a:xfrm>
-          <a:prstGeom prst="rect">
-            <a:avLst/>
-          </a:prstGeom>
-          <a:noFill/>
-          <a:ln/>
-        </p:spPr>
-        <p:txBody>
-          <a:bodyPr wrap="square" lIns="0" tIns="0" rIns="0" bIns="0" rtlCol="0" anchor="ctr"/>
-          <a:lstStyle/>
-          <a:p>
-            <a:pPr indent="0" marL="0">
-              <a:buNone/>
-            </a:pPr>
-            <a:r>
-              <a:rPr lang="en-US" sz="1400" dirty="0">
-                <a:solidFill>
-                  <a:srgbClr val="3F3866"/>
-                </a:solidFill>
-                <a:latin typeface="Calibri" pitchFamily="34" charset="0"/>
-                <a:ea typeface="Calibri" pitchFamily="34" charset="-122"/>
-                <a:cs typeface="Calibri" pitchFamily="34" charset="-120"/>
-              </a:rPr>
-              <a:t>Word of the day · Listen again, slower · Focus Sprint</a:t>
-            </a:r>
-            <a:endParaRPr lang="en-US" sz="1400" dirty="0"/>
-          </a:p>
-        </p:txBody>
-      </p:sp>
       <p:pic>
         <p:nvPicPr>
-          <p:cNvPr id="4" name="Image 0" descr="/private/tmp/claude-502/-Users-pran-zsbch1641/eb3ff32b-0b81-4709-87ba-996c7757d4a1/scratchpad/deck/../promo/preview/reels2_final.jpg">    </p:cNvPr>
+          <p:cNvPr id="3" name="Image 0" descr="/private/tmp/claude-502/-Users-pran-zsbch1641/eb3ff32b-0b81-4709-87ba-996c7757d4a1/scratchpad/deck/../promo/preview/reels2_final.jpg">    </p:cNvPr>
           <p:cNvPicPr>
             <a:picLocks noChangeAspect="1"/>
           </p:cNvPicPr>
@@ -4850,8 +6851,8 @@
         </p:blipFill>
         <p:spPr>
           <a:xfrm>
-            <a:off x="457200" y="1234440"/>
-            <a:ext cx="8229600" cy="3383280"/>
+            <a:off x="457200" y="960120"/>
+            <a:ext cx="8229600" cy="3108960"/>
           </a:xfrm>
           <a:prstGeom prst="rect">
             <a:avLst/>
@@ -4860,7 +6861,315 @@
       </p:pic>
       <p:sp>
         <p:nvSpPr>
-          <p:cNvPr id="5" name="Text 2"/>
+          <p:cNvPr id="4" name="Shape 1">
+            <a:hlinkClick r:id="rId2" tooltip=""/>
+          </p:cNvPr>
+          <p:cNvSpPr/>
+          <p:nvPr/>
+        </p:nvSpPr>
+        <p:spPr>
+          <a:xfrm>
+            <a:off x="457200" y="4206240"/>
+            <a:ext cx="1196035" cy="347472"/>
+          </a:xfrm>
+          <a:prstGeom prst="roundRect">
+            <a:avLst>
+              <a:gd name="adj" fmla="val 50000"/>
+            </a:avLst>
+          </a:prstGeom>
+          <a:solidFill>
+            <a:srgbClr val="23155C"/>
+          </a:solidFill>
+          <a:ln w="12700">
+            <a:solidFill>
+              <a:srgbClr val="23155C"/>
+            </a:solidFill>
+            <a:prstDash val="solid"/>
+          </a:ln>
+        </p:spPr>
+      </p:sp>
+      <p:sp>
+        <p:nvSpPr>
+          <p:cNvPr id="5" name="Text 2">
+            <a:hlinkClick r:id="rId3" tooltip=""/>
+          </p:cNvPr>
+          <p:cNvSpPr txBox="1"/>
+          <p:nvPr/>
+        </p:nvSpPr>
+        <p:spPr>
+          <a:xfrm>
+            <a:off x="457200" y="4206240"/>
+            <a:ext cx="1196035" cy="347472"/>
+          </a:xfrm>
+          <a:prstGeom prst="rect">
+            <a:avLst/>
+          </a:prstGeom>
+          <a:noFill/>
+          <a:ln/>
+        </p:spPr>
+        <p:txBody>
+          <a:bodyPr wrap="square" lIns="0" tIns="0" rIns="0" bIns="0" rtlCol="0" anchor="ctr"/>
+          <a:lstStyle/>
+          <a:p>
+            <a:pPr algn="ctr" indent="0" marL="0">
+              <a:buNone/>
+            </a:pPr>
+            <a:r>
+              <a:rPr lang="en-US" sz="1100" b="1" u="sng" dirty="0">
+                <a:solidFill>
+                  <a:srgbClr val="FFFFFF"/>
+                </a:solidFill>
+                <a:latin typeface="Calibri" pitchFamily="34" charset="0"/>
+                <a:ea typeface="Calibri" pitchFamily="34" charset="-122"/>
+                <a:cs typeface="Calibri" pitchFamily="34" charset="-120"/>
+                <a:hlinkClick r:id="rId3" invalidUrl="" action="" tgtFrame="" tooltip="" history="1" highlightClick="0" endSnd="0">
+                  <a:extLst>
+                    <a:ext uri="{A12FA001-AC4F-418D-AE19-62706E023703}">
+                      <ahyp:hlinkClr xmlns:ahyp="http://schemas.microsoft.com/office/drawing/2018/hyperlinkcolor" val="tx"/>
+                    </a:ext>
+                  </a:extLst>
+                </a:hlinkClick>
+              </a:rPr>
+              <a:t>🔗 Launch reel</a:t>
+            </a:r>
+            <a:endParaRPr lang="en-US" sz="1100" dirty="0"/>
+          </a:p>
+        </p:txBody>
+      </p:sp>
+      <p:sp>
+        <p:nvSpPr>
+          <p:cNvPr id="6" name="Shape 3">
+            <a:hlinkClick r:id="rId4" tooltip=""/>
+          </p:cNvPr>
+          <p:cNvSpPr/>
+          <p:nvPr/>
+        </p:nvSpPr>
+        <p:spPr>
+          <a:xfrm>
+            <a:off x="1790395" y="4206240"/>
+            <a:ext cx="1481328" cy="347472"/>
+          </a:xfrm>
+          <a:prstGeom prst="roundRect">
+            <a:avLst>
+              <a:gd name="adj" fmla="val 50000"/>
+            </a:avLst>
+          </a:prstGeom>
+          <a:solidFill>
+            <a:srgbClr val="23155C"/>
+          </a:solidFill>
+          <a:ln w="12700">
+            <a:solidFill>
+              <a:srgbClr val="23155C"/>
+            </a:solidFill>
+            <a:prstDash val="solid"/>
+          </a:ln>
+        </p:spPr>
+      </p:sp>
+      <p:sp>
+        <p:nvSpPr>
+          <p:cNvPr id="7" name="Text 4">
+            <a:hlinkClick r:id="rId5" tooltip=""/>
+          </p:cNvPr>
+          <p:cNvSpPr txBox="1"/>
+          <p:nvPr/>
+        </p:nvSpPr>
+        <p:spPr>
+          <a:xfrm>
+            <a:off x="1790395" y="4206240"/>
+            <a:ext cx="1481328" cy="347472"/>
+          </a:xfrm>
+          <a:prstGeom prst="rect">
+            <a:avLst/>
+          </a:prstGeom>
+          <a:noFill/>
+          <a:ln/>
+        </p:spPr>
+        <p:txBody>
+          <a:bodyPr wrap="square" lIns="0" tIns="0" rIns="0" bIns="0" rtlCol="0" anchor="ctr"/>
+          <a:lstStyle/>
+          <a:p>
+            <a:pPr algn="ctr" indent="0" marL="0">
+              <a:buNone/>
+            </a:pPr>
+            <a:r>
+              <a:rPr lang="en-US" sz="1100" b="1" u="sng" dirty="0">
+                <a:solidFill>
+                  <a:srgbClr val="FFFFFF"/>
+                </a:solidFill>
+                <a:latin typeface="Calibri" pitchFamily="34" charset="0"/>
+                <a:ea typeface="Calibri" pitchFamily="34" charset="-122"/>
+                <a:cs typeface="Calibri" pitchFamily="34" charset="-120"/>
+                <a:hlinkClick r:id="rId5" invalidUrl="" action="" tgtFrame="" tooltip="" history="1" highlightClick="0" endSnd="0">
+                  <a:extLst>
+                    <a:ext uri="{A12FA001-AC4F-418D-AE19-62706E023703}">
+                      <ahyp:hlinkClr xmlns:ahyp="http://schemas.microsoft.com/office/drawing/2018/hyperlinkcolor" val="tx"/>
+                    </a:ext>
+                  </a:extLst>
+                </a:hlinkClick>
+              </a:rPr>
+              <a:t>🔗 Word of the day</a:t>
+            </a:r>
+            <a:endParaRPr lang="en-US" sz="1100" dirty="0"/>
+          </a:p>
+        </p:txBody>
+      </p:sp>
+      <p:sp>
+        <p:nvSpPr>
+          <p:cNvPr id="8" name="Shape 5">
+            <a:hlinkClick r:id="rId6" tooltip=""/>
+          </p:cNvPr>
+          <p:cNvSpPr/>
+          <p:nvPr/>
+        </p:nvSpPr>
+        <p:spPr>
+          <a:xfrm>
+            <a:off x="3408883" y="4206240"/>
+            <a:ext cx="1837944" cy="347472"/>
+          </a:xfrm>
+          <a:prstGeom prst="roundRect">
+            <a:avLst>
+              <a:gd name="adj" fmla="val 50000"/>
+            </a:avLst>
+          </a:prstGeom>
+          <a:solidFill>
+            <a:srgbClr val="23155C"/>
+          </a:solidFill>
+          <a:ln w="12700">
+            <a:solidFill>
+              <a:srgbClr val="23155C"/>
+            </a:solidFill>
+            <a:prstDash val="solid"/>
+          </a:ln>
+        </p:spPr>
+      </p:sp>
+      <p:sp>
+        <p:nvSpPr>
+          <p:cNvPr id="9" name="Text 6">
+            <a:hlinkClick r:id="rId7" tooltip=""/>
+          </p:cNvPr>
+          <p:cNvSpPr txBox="1"/>
+          <p:nvPr/>
+        </p:nvSpPr>
+        <p:spPr>
+          <a:xfrm>
+            <a:off x="3408883" y="4206240"/>
+            <a:ext cx="1837944" cy="347472"/>
+          </a:xfrm>
+          <a:prstGeom prst="rect">
+            <a:avLst/>
+          </a:prstGeom>
+          <a:noFill/>
+          <a:ln/>
+        </p:spPr>
+        <p:txBody>
+          <a:bodyPr wrap="square" lIns="0" tIns="0" rIns="0" bIns="0" rtlCol="0" anchor="ctr"/>
+          <a:lstStyle/>
+          <a:p>
+            <a:pPr algn="ctr" indent="0" marL="0">
+              <a:buNone/>
+            </a:pPr>
+            <a:r>
+              <a:rPr lang="en-US" sz="1100" b="1" u="sng" dirty="0">
+                <a:solidFill>
+                  <a:srgbClr val="FFFFFF"/>
+                </a:solidFill>
+                <a:latin typeface="Calibri" pitchFamily="34" charset="0"/>
+                <a:ea typeface="Calibri" pitchFamily="34" charset="-122"/>
+                <a:cs typeface="Calibri" pitchFamily="34" charset="-120"/>
+                <a:hlinkClick r:id="rId7" invalidUrl="" action="" tgtFrame="" tooltip="" history="1" highlightClick="0" endSnd="0">
+                  <a:extLst>
+                    <a:ext uri="{A12FA001-AC4F-418D-AE19-62706E023703}">
+                      <ahyp:hlinkClr xmlns:ahyp="http://schemas.microsoft.com/office/drawing/2018/hyperlinkcolor" val="tx"/>
+                    </a:ext>
+                  </a:extLst>
+                </a:hlinkClick>
+              </a:rPr>
+              <a:t>🔗 Listen again, slower</a:t>
+            </a:r>
+            <a:endParaRPr lang="en-US" sz="1100" dirty="0"/>
+          </a:p>
+        </p:txBody>
+      </p:sp>
+      <p:sp>
+        <p:nvSpPr>
+          <p:cNvPr id="10" name="Shape 7">
+            <a:hlinkClick r:id="rId8" tooltip=""/>
+          </p:cNvPr>
+          <p:cNvSpPr/>
+          <p:nvPr/>
+        </p:nvSpPr>
+        <p:spPr>
+          <a:xfrm>
+            <a:off x="5383987" y="4206240"/>
+            <a:ext cx="1267358" cy="347472"/>
+          </a:xfrm>
+          <a:prstGeom prst="roundRect">
+            <a:avLst>
+              <a:gd name="adj" fmla="val 50000"/>
+            </a:avLst>
+          </a:prstGeom>
+          <a:solidFill>
+            <a:srgbClr val="23155C"/>
+          </a:solidFill>
+          <a:ln w="12700">
+            <a:solidFill>
+              <a:srgbClr val="23155C"/>
+            </a:solidFill>
+            <a:prstDash val="solid"/>
+          </a:ln>
+        </p:spPr>
+      </p:sp>
+      <p:sp>
+        <p:nvSpPr>
+          <p:cNvPr id="11" name="Text 8">
+            <a:hlinkClick r:id="rId9" tooltip=""/>
+          </p:cNvPr>
+          <p:cNvSpPr txBox="1"/>
+          <p:nvPr/>
+        </p:nvSpPr>
+        <p:spPr>
+          <a:xfrm>
+            <a:off x="5383987" y="4206240"/>
+            <a:ext cx="1267358" cy="347472"/>
+          </a:xfrm>
+          <a:prstGeom prst="rect">
+            <a:avLst/>
+          </a:prstGeom>
+          <a:noFill/>
+          <a:ln/>
+        </p:spPr>
+        <p:txBody>
+          <a:bodyPr wrap="square" lIns="0" tIns="0" rIns="0" bIns="0" rtlCol="0" anchor="ctr"/>
+          <a:lstStyle/>
+          <a:p>
+            <a:pPr algn="ctr" indent="0" marL="0">
+              <a:buNone/>
+            </a:pPr>
+            <a:r>
+              <a:rPr lang="en-US" sz="1100" b="1" u="sng" dirty="0">
+                <a:solidFill>
+                  <a:srgbClr val="FFFFFF"/>
+                </a:solidFill>
+                <a:latin typeface="Calibri" pitchFamily="34" charset="0"/>
+                <a:ea typeface="Calibri" pitchFamily="34" charset="-122"/>
+                <a:cs typeface="Calibri" pitchFamily="34" charset="-120"/>
+                <a:hlinkClick r:id="rId9" invalidUrl="" action="" tgtFrame="" tooltip="" history="1" highlightClick="0" endSnd="0">
+                  <a:extLst>
+                    <a:ext uri="{A12FA001-AC4F-418D-AE19-62706E023703}">
+                      <ahyp:hlinkClr xmlns:ahyp="http://schemas.microsoft.com/office/drawing/2018/hyperlinkcolor" val="tx"/>
+                    </a:ext>
+                  </a:extLst>
+                </a:hlinkClick>
+              </a:rPr>
+              <a:t>🔗 Focus Sprint</a:t>
+            </a:r>
+            <a:endParaRPr lang="en-US" sz="1100" dirty="0"/>
+          </a:p>
+        </p:txBody>
+      </p:sp>
+      <p:sp>
+        <p:nvSpPr>
+          <p:cNvPr id="12" name="Text 9"/>
           <p:cNvSpPr txBox="1"/>
           <p:nvPr/>
         </p:nvSpPr>
@@ -4968,48 +7277,9 @@
           </a:p>
         </p:txBody>
       </p:sp>
-      <p:sp>
-        <p:nvSpPr>
-          <p:cNvPr id="3" name="Text 1"/>
-          <p:cNvSpPr txBox="1"/>
-          <p:nvPr/>
-        </p:nvSpPr>
-        <p:spPr>
-          <a:xfrm>
-            <a:off x="457200" y="868680"/>
-            <a:ext cx="8229600" cy="365760"/>
-          </a:xfrm>
-          <a:prstGeom prst="rect">
-            <a:avLst/>
-          </a:prstGeom>
-          <a:noFill/>
-          <a:ln/>
-        </p:spPr>
-        <p:txBody>
-          <a:bodyPr wrap="square" lIns="0" tIns="0" rIns="0" bIns="0" rtlCol="0" anchor="ctr"/>
-          <a:lstStyle/>
-          <a:p>
-            <a:pPr indent="0" marL="0">
-              <a:buNone/>
-            </a:pPr>
-            <a:r>
-              <a:rPr lang="en-US" sz="1400" dirty="0">
-                <a:solidFill>
-                  <a:srgbClr val="3F3866"/>
-                </a:solidFill>
-                <a:latin typeface="Calibri" pitchFamily="34" charset="0"/>
-                <a:ea typeface="Calibri" pitchFamily="34" charset="-122"/>
-                <a:cs typeface="Calibri" pitchFamily="34" charset="-120"/>
-              </a:rPr>
-              <a:t>7 words for an HR round · 5 words you’re saying wrong · Gengo in 4 steps</a:t>
-            </a:r>
-            <a:endParaRPr lang="en-US" sz="1400" dirty="0"/>
-          </a:p>
-        </p:txBody>
-      </p:sp>
       <p:pic>
         <p:nvPicPr>
-          <p:cNvPr id="4" name="Image 0" descr="/private/tmp/claude-502/-Users-pran-zsbch1641/eb3ff32b-0b81-4709-87ba-996c7757d4a1/scratchpad/deck/carousels.png">    </p:cNvPr>
+          <p:cNvPr id="3" name="Image 0" descr="/private/tmp/claude-502/-Users-pran-zsbch1641/eb3ff32b-0b81-4709-87ba-996c7757d4a1/scratchpad/deck/carousels.png">    </p:cNvPr>
           <p:cNvPicPr>
             <a:picLocks noChangeAspect="1"/>
           </p:cNvPicPr>
@@ -5022,8 +7292,8 @@
         </p:blipFill>
         <p:spPr>
           <a:xfrm>
-            <a:off x="457200" y="1234440"/>
-            <a:ext cx="8229600" cy="3383280"/>
+            <a:off x="457200" y="1005840"/>
+            <a:ext cx="8229600" cy="3063240"/>
           </a:xfrm>
           <a:prstGeom prst="rect">
             <a:avLst/>
@@ -5032,7 +7302,238 @@
       </p:pic>
       <p:sp>
         <p:nvSpPr>
-          <p:cNvPr id="5" name="Text 2"/>
+          <p:cNvPr id="4" name="Shape 1">
+            <a:hlinkClick r:id="rId2" tooltip=""/>
+          </p:cNvPr>
+          <p:cNvSpPr/>
+          <p:nvPr/>
+        </p:nvSpPr>
+        <p:spPr>
+          <a:xfrm>
+            <a:off x="457200" y="4206240"/>
+            <a:ext cx="2051914" cy="347472"/>
+          </a:xfrm>
+          <a:prstGeom prst="roundRect">
+            <a:avLst>
+              <a:gd name="adj" fmla="val 50000"/>
+            </a:avLst>
+          </a:prstGeom>
+          <a:solidFill>
+            <a:srgbClr val="23155C"/>
+          </a:solidFill>
+          <a:ln w="12700">
+            <a:solidFill>
+              <a:srgbClr val="23155C"/>
+            </a:solidFill>
+            <a:prstDash val="solid"/>
+          </a:ln>
+        </p:spPr>
+      </p:sp>
+      <p:sp>
+        <p:nvSpPr>
+          <p:cNvPr id="5" name="Text 2">
+            <a:hlinkClick r:id="rId3" tooltip=""/>
+          </p:cNvPr>
+          <p:cNvSpPr txBox="1"/>
+          <p:nvPr/>
+        </p:nvSpPr>
+        <p:spPr>
+          <a:xfrm>
+            <a:off x="457200" y="4206240"/>
+            <a:ext cx="2051914" cy="347472"/>
+          </a:xfrm>
+          <a:prstGeom prst="rect">
+            <a:avLst/>
+          </a:prstGeom>
+          <a:noFill/>
+          <a:ln/>
+        </p:spPr>
+        <p:txBody>
+          <a:bodyPr wrap="square" lIns="0" tIns="0" rIns="0" bIns="0" rtlCol="0" anchor="ctr"/>
+          <a:lstStyle/>
+          <a:p>
+            <a:pPr algn="ctr" indent="0" marL="0">
+              <a:buNone/>
+            </a:pPr>
+            <a:r>
+              <a:rPr lang="en-US" sz="1100" b="1" u="sng" dirty="0">
+                <a:solidFill>
+                  <a:srgbClr val="FFFFFF"/>
+                </a:solidFill>
+                <a:latin typeface="Calibri" pitchFamily="34" charset="0"/>
+                <a:ea typeface="Calibri" pitchFamily="34" charset="-122"/>
+                <a:cs typeface="Calibri" pitchFamily="34" charset="-120"/>
+                <a:hlinkClick r:id="rId3" invalidUrl="" action="" tgtFrame="" tooltip="" history="1" highlightClick="0" endSnd="0">
+                  <a:extLst>
+                    <a:ext uri="{A12FA001-AC4F-418D-AE19-62706E023703}">
+                      <ahyp:hlinkClr xmlns:ahyp="http://schemas.microsoft.com/office/drawing/2018/hyperlinkcolor" val="tx"/>
+                    </a:ext>
+                  </a:extLst>
+                </a:hlinkClick>
+              </a:rPr>
+              <a:t>🔗 7 words for an HR round</a:t>
+            </a:r>
+            <a:endParaRPr lang="en-US" sz="1100" dirty="0"/>
+          </a:p>
+        </p:txBody>
+      </p:sp>
+      <p:sp>
+        <p:nvSpPr>
+          <p:cNvPr id="6" name="Shape 3">
+            <a:hlinkClick r:id="rId4" tooltip=""/>
+          </p:cNvPr>
+          <p:cNvSpPr/>
+          <p:nvPr/>
+        </p:nvSpPr>
+        <p:spPr>
+          <a:xfrm>
+            <a:off x="2646274" y="4206240"/>
+            <a:ext cx="2337206" cy="347472"/>
+          </a:xfrm>
+          <a:prstGeom prst="roundRect">
+            <a:avLst>
+              <a:gd name="adj" fmla="val 50000"/>
+            </a:avLst>
+          </a:prstGeom>
+          <a:solidFill>
+            <a:srgbClr val="23155C"/>
+          </a:solidFill>
+          <a:ln w="12700">
+            <a:solidFill>
+              <a:srgbClr val="23155C"/>
+            </a:solidFill>
+            <a:prstDash val="solid"/>
+          </a:ln>
+        </p:spPr>
+      </p:sp>
+      <p:sp>
+        <p:nvSpPr>
+          <p:cNvPr id="7" name="Text 4">
+            <a:hlinkClick r:id="rId5" tooltip=""/>
+          </p:cNvPr>
+          <p:cNvSpPr txBox="1"/>
+          <p:nvPr/>
+        </p:nvSpPr>
+        <p:spPr>
+          <a:xfrm>
+            <a:off x="2646274" y="4206240"/>
+            <a:ext cx="2337206" cy="347472"/>
+          </a:xfrm>
+          <a:prstGeom prst="rect">
+            <a:avLst/>
+          </a:prstGeom>
+          <a:noFill/>
+          <a:ln/>
+        </p:spPr>
+        <p:txBody>
+          <a:bodyPr wrap="square" lIns="0" tIns="0" rIns="0" bIns="0" rtlCol="0" anchor="ctr"/>
+          <a:lstStyle/>
+          <a:p>
+            <a:pPr algn="ctr" indent="0" marL="0">
+              <a:buNone/>
+            </a:pPr>
+            <a:r>
+              <a:rPr lang="en-US" sz="1100" b="1" u="sng" dirty="0">
+                <a:solidFill>
+                  <a:srgbClr val="FFFFFF"/>
+                </a:solidFill>
+                <a:latin typeface="Calibri" pitchFamily="34" charset="0"/>
+                <a:ea typeface="Calibri" pitchFamily="34" charset="-122"/>
+                <a:cs typeface="Calibri" pitchFamily="34" charset="-120"/>
+                <a:hlinkClick r:id="rId5" invalidUrl="" action="" tgtFrame="" tooltip="" history="1" highlightClick="0" endSnd="0">
+                  <a:extLst>
+                    <a:ext uri="{A12FA001-AC4F-418D-AE19-62706E023703}">
+                      <ahyp:hlinkClr xmlns:ahyp="http://schemas.microsoft.com/office/drawing/2018/hyperlinkcolor" val="tx"/>
+                    </a:ext>
+                  </a:extLst>
+                </a:hlinkClick>
+              </a:rPr>
+              <a:t>🔗 5 words you’re saying wrong</a:t>
+            </a:r>
+            <a:endParaRPr lang="en-US" sz="1100" dirty="0"/>
+          </a:p>
+        </p:txBody>
+      </p:sp>
+      <p:sp>
+        <p:nvSpPr>
+          <p:cNvPr id="8" name="Shape 5">
+            <a:hlinkClick r:id="rId6" tooltip=""/>
+          </p:cNvPr>
+          <p:cNvSpPr/>
+          <p:nvPr/>
+        </p:nvSpPr>
+        <p:spPr>
+          <a:xfrm>
+            <a:off x="5120640" y="4206240"/>
+            <a:ext cx="1552651" cy="347472"/>
+          </a:xfrm>
+          <a:prstGeom prst="roundRect">
+            <a:avLst>
+              <a:gd name="adj" fmla="val 50000"/>
+            </a:avLst>
+          </a:prstGeom>
+          <a:solidFill>
+            <a:srgbClr val="23155C"/>
+          </a:solidFill>
+          <a:ln w="12700">
+            <a:solidFill>
+              <a:srgbClr val="23155C"/>
+            </a:solidFill>
+            <a:prstDash val="solid"/>
+          </a:ln>
+        </p:spPr>
+      </p:sp>
+      <p:sp>
+        <p:nvSpPr>
+          <p:cNvPr id="9" name="Text 6">
+            <a:hlinkClick r:id="rId7" tooltip=""/>
+          </p:cNvPr>
+          <p:cNvSpPr txBox="1"/>
+          <p:nvPr/>
+        </p:nvSpPr>
+        <p:spPr>
+          <a:xfrm>
+            <a:off x="5120640" y="4206240"/>
+            <a:ext cx="1552651" cy="347472"/>
+          </a:xfrm>
+          <a:prstGeom prst="rect">
+            <a:avLst/>
+          </a:prstGeom>
+          <a:noFill/>
+          <a:ln/>
+        </p:spPr>
+        <p:txBody>
+          <a:bodyPr wrap="square" lIns="0" tIns="0" rIns="0" bIns="0" rtlCol="0" anchor="ctr"/>
+          <a:lstStyle/>
+          <a:p>
+            <a:pPr algn="ctr" indent="0" marL="0">
+              <a:buNone/>
+            </a:pPr>
+            <a:r>
+              <a:rPr lang="en-US" sz="1100" b="1" u="sng" dirty="0">
+                <a:solidFill>
+                  <a:srgbClr val="FFFFFF"/>
+                </a:solidFill>
+                <a:latin typeface="Calibri" pitchFamily="34" charset="0"/>
+                <a:ea typeface="Calibri" pitchFamily="34" charset="-122"/>
+                <a:cs typeface="Calibri" pitchFamily="34" charset="-120"/>
+                <a:hlinkClick r:id="rId7" invalidUrl="" action="" tgtFrame="" tooltip="" history="1" highlightClick="0" endSnd="0">
+                  <a:extLst>
+                    <a:ext uri="{A12FA001-AC4F-418D-AE19-62706E023703}">
+                      <ahyp:hlinkClr xmlns:ahyp="http://schemas.microsoft.com/office/drawing/2018/hyperlinkcolor" val="tx"/>
+                    </a:ext>
+                  </a:extLst>
+                </a:hlinkClick>
+              </a:rPr>
+              <a:t>🔗 Gengo in 4 steps</a:t>
+            </a:r>
+            <a:endParaRPr lang="en-US" sz="1100" dirty="0"/>
+          </a:p>
+        </p:txBody>
+      </p:sp>
+      <p:sp>
+        <p:nvSpPr>
+          <p:cNvPr id="10" name="Text 7"/>
           <p:cNvSpPr txBox="1"/>
           <p:nvPr/>
         </p:nvSpPr>

</xml_diff>

<commit_message>
Launch deck: Zoho-safe link chips
</commit_message>
<xml_diff>
--- a/launch/Gengo-Marketing-Glance.pptx
+++ b/launch/Gengo-Marketing-Glance.pptx
@@ -1907,9 +1907,9 @@
                 <a:solidFill>
                   <a:srgbClr val="FFFFFF"/>
                 </a:solidFill>
-                <a:latin typeface="Calibri" pitchFamily="34" charset="0"/>
-                <a:ea typeface="Calibri" pitchFamily="34" charset="-122"/>
-                <a:cs typeface="Calibri" pitchFamily="34" charset="-120"/>
+                <a:latin typeface="Arial" pitchFamily="34" charset="0"/>
+                <a:ea typeface="Arial" pitchFamily="34" charset="-122"/>
+                <a:cs typeface="Arial" pitchFamily="34" charset="-120"/>
               </a:rPr>
               <a:t>Gengo</a:t>
             </a:r>
@@ -1946,9 +1946,9 @@
                 <a:solidFill>
                   <a:srgbClr val="FFD233"/>
                 </a:solidFill>
-                <a:latin typeface="Calibri" pitchFamily="34" charset="0"/>
-                <a:ea typeface="Calibri" pitchFamily="34" charset="-122"/>
-                <a:cs typeface="Calibri" pitchFamily="34" charset="-120"/>
+                <a:latin typeface="Arial" pitchFamily="34" charset="0"/>
+                <a:ea typeface="Arial" pitchFamily="34" charset="-122"/>
+                <a:cs typeface="Arial" pitchFamily="34" charset="-120"/>
               </a:rPr>
               <a:t>Everything we made, with links</a:t>
             </a:r>
@@ -1985,9 +1985,9 @@
                 <a:solidFill>
                   <a:srgbClr val="D6CCFF"/>
                 </a:solidFill>
-                <a:latin typeface="Calibri" pitchFamily="34" charset="0"/>
-                <a:ea typeface="Calibri" pitchFamily="34" charset="-122"/>
-                <a:cs typeface="Calibri" pitchFamily="34" charset="-120"/>
+                <a:latin typeface="Arial" pitchFamily="34" charset="0"/>
+                <a:ea typeface="Arial" pitchFamily="34" charset="-122"/>
+                <a:cs typeface="Arial" pitchFamily="34" charset="-120"/>
               </a:rPr>
               <a:t>Free · no account · budget ₹0</a:t>
             </a:r>
@@ -2006,7 +2006,7 @@
         <p:spPr>
           <a:xfrm>
             <a:off x="457200" y="4114800"/>
-            <a:ext cx="1267358" cy="347472"/>
+            <a:ext cx="1558138" cy="384048"/>
           </a:xfrm>
           <a:prstGeom prst="roundRect">
             <a:avLst>
@@ -2014,11 +2014,11 @@
             </a:avLst>
           </a:prstGeom>
           <a:solidFill>
-            <a:srgbClr val="FFD233"/>
+            <a:srgbClr val="FFFFFF"/>
           </a:solidFill>
           <a:ln w="12700">
             <a:solidFill>
-              <a:srgbClr val="FFD233"/>
+              <a:srgbClr val="FFFFFF"/>
             </a:solidFill>
             <a:prstDash val="solid"/>
           </a:ln>
@@ -2035,7 +2035,7 @@
         <p:spPr>
           <a:xfrm>
             <a:off x="457200" y="4114800"/>
-            <a:ext cx="1267358" cy="347472"/>
+            <a:ext cx="1558138" cy="384048"/>
           </a:xfrm>
           <a:prstGeom prst="rect">
             <a:avLst/>
@@ -2055,9 +2055,9 @@
                 <a:solidFill>
                   <a:srgbClr val="23155C"/>
                 </a:solidFill>
-                <a:latin typeface="Calibri" pitchFamily="34" charset="0"/>
-                <a:ea typeface="Calibri" pitchFamily="34" charset="-122"/>
-                <a:cs typeface="Calibri" pitchFamily="34" charset="-120"/>
+                <a:latin typeface="Arial" pitchFamily="34" charset="0"/>
+                <a:ea typeface="Arial" pitchFamily="34" charset="-122"/>
+                <a:cs typeface="Arial" pitchFamily="34" charset="-120"/>
                 <a:hlinkClick r:id="rId3" invalidUrl="" action="" tgtFrame="" tooltip="" history="1" highlightClick="0" endSnd="0">
                   <a:extLst>
                     <a:ext uri="{A12FA001-AC4F-418D-AE19-62706E023703}">
@@ -2066,7 +2066,7 @@
                   </a:extLst>
                 </a:hlinkClick>
               </a:rPr>
-              <a:t>🔗 Open the app</a:t>
+              <a:t>Open the app</a:t>
             </a:r>
             <a:endParaRPr lang="en-US" sz="1100" dirty="0"/>
           </a:p>
@@ -2082,8 +2082,8 @@
         </p:nvSpPr>
         <p:spPr>
           <a:xfrm>
-            <a:off x="1861718" y="4114800"/>
-            <a:ext cx="1196035" cy="347472"/>
+            <a:off x="2152498" y="4114800"/>
+            <a:ext cx="1474013" cy="384048"/>
           </a:xfrm>
           <a:prstGeom prst="roundRect">
             <a:avLst>
@@ -2091,11 +2091,11 @@
             </a:avLst>
           </a:prstGeom>
           <a:solidFill>
-            <a:srgbClr val="FFD233"/>
+            <a:srgbClr val="FFFFFF"/>
           </a:solidFill>
           <a:ln w="12700">
             <a:solidFill>
-              <a:srgbClr val="FFD233"/>
+              <a:srgbClr val="FFFFFF"/>
             </a:solidFill>
             <a:prstDash val="solid"/>
           </a:ln>
@@ -2111,8 +2111,8 @@
         </p:nvSpPr>
         <p:spPr>
           <a:xfrm>
-            <a:off x="1861718" y="4114800"/>
-            <a:ext cx="1196035" cy="347472"/>
+            <a:off x="2152498" y="4114800"/>
+            <a:ext cx="1474013" cy="384048"/>
           </a:xfrm>
           <a:prstGeom prst="rect">
             <a:avLst/>
@@ -2132,9 +2132,9 @@
                 <a:solidFill>
                   <a:srgbClr val="23155C"/>
                 </a:solidFill>
-                <a:latin typeface="Calibri" pitchFamily="34" charset="0"/>
-                <a:ea typeface="Calibri" pitchFamily="34" charset="-122"/>
-                <a:cs typeface="Calibri" pitchFamily="34" charset="-120"/>
+                <a:latin typeface="Arial" pitchFamily="34" charset="0"/>
+                <a:ea typeface="Arial" pitchFamily="34" charset="-122"/>
+                <a:cs typeface="Arial" pitchFamily="34" charset="-120"/>
                 <a:hlinkClick r:id="rId5" invalidUrl="" action="" tgtFrame="" tooltip="" history="1" highlightClick="0" endSnd="0">
                   <a:extLst>
                     <a:ext uri="{A12FA001-AC4F-418D-AE19-62706E023703}">
@@ -2143,7 +2143,7 @@
                   </a:extLst>
                 </a:hlinkClick>
               </a:rPr>
-              <a:t>🔗 GitHub repo</a:t>
+              <a:t>GitHub repo</a:t>
             </a:r>
             <a:endParaRPr lang="en-US" sz="1100" dirty="0"/>
           </a:p>
@@ -2206,17 +2206,17 @@
               <a:buNone/>
             </a:pPr>
             <a:r>
-              <a:rPr lang="en-US" sz="3400" b="1" dirty="0">
+              <a:rPr lang="en-US" sz="3000" b="1" dirty="0">
                 <a:solidFill>
                   <a:srgbClr val="23155C"/>
                 </a:solidFill>
-                <a:latin typeface="Calibri" pitchFamily="34" charset="0"/>
-                <a:ea typeface="Calibri" pitchFamily="34" charset="-122"/>
-                <a:cs typeface="Calibri" pitchFamily="34" charset="-120"/>
+                <a:latin typeface="Arial" pitchFamily="34" charset="0"/>
+                <a:ea typeface="Arial" pitchFamily="34" charset="-122"/>
+                <a:cs typeface="Arial" pitchFamily="34" charset="-120"/>
               </a:rPr>
               <a:t>Posts &amp; the blog</a:t>
             </a:r>
-            <a:endParaRPr lang="en-US" sz="3400" dirty="0"/>
+            <a:endParaRPr lang="en-US" sz="3000" dirty="0"/>
           </a:p>
         </p:txBody>
       </p:sp>
@@ -2235,7 +2235,7 @@
         </p:blipFill>
         <p:spPr>
           <a:xfrm>
-            <a:off x="457200" y="1051560"/>
+            <a:off x="457200" y="914400"/>
             <a:ext cx="4754880" cy="3017520"/>
           </a:xfrm>
           <a:prstGeom prst="rect">
@@ -2258,7 +2258,7 @@
         </p:blipFill>
         <p:spPr>
           <a:xfrm>
-            <a:off x="5486400" y="1051560"/>
+            <a:off x="5486400" y="914400"/>
             <a:ext cx="3200400" cy="1801368"/>
           </a:xfrm>
           <a:prstGeom prst="rect">
@@ -2274,7 +2274,7 @@
         </p:nvSpPr>
         <p:spPr>
           <a:xfrm>
-            <a:off x="5486400" y="2926080"/>
+            <a:off x="5486400" y="2834640"/>
             <a:ext cx="3200400" cy="1097280"/>
           </a:xfrm>
           <a:prstGeom prst="rect">
@@ -2295,9 +2295,9 @@
                 <a:solidFill>
                   <a:srgbClr val="3F3866"/>
                 </a:solidFill>
-                <a:latin typeface="Calibri" pitchFamily="34" charset="0"/>
-                <a:ea typeface="Calibri" pitchFamily="34" charset="-122"/>
-                <a:cs typeface="Calibri" pitchFamily="34" charset="-120"/>
+                <a:latin typeface="Arial" pitchFamily="34" charset="0"/>
+                <a:ea typeface="Arial" pitchFamily="34" charset="-122"/>
+                <a:cs typeface="Arial" pitchFamily="34" charset="-120"/>
               </a:rPr>
               <a:t>Medium: “Meet Gengo: Turn One New Word Into a Superpower” (draft, publishing next)</a:t>
             </a:r>
@@ -2315,8 +2315,8 @@
         </p:nvSpPr>
         <p:spPr>
           <a:xfrm>
-            <a:off x="457200" y="4206240"/>
-            <a:ext cx="1338682" cy="347472"/>
+            <a:off x="457200" y="4069080"/>
+            <a:ext cx="1642262" cy="384048"/>
           </a:xfrm>
           <a:prstGeom prst="roundRect">
             <a:avLst>
@@ -2324,11 +2324,11 @@
             </a:avLst>
           </a:prstGeom>
           <a:solidFill>
-            <a:srgbClr val="23155C"/>
+            <a:srgbClr val="F6F3FF"/>
           </a:solidFill>
           <a:ln w="12700">
             <a:solidFill>
-              <a:srgbClr val="23155C"/>
+              <a:srgbClr val="D9D0F5"/>
             </a:solidFill>
             <a:prstDash val="solid"/>
           </a:ln>
@@ -2344,8 +2344,8 @@
         </p:nvSpPr>
         <p:spPr>
           <a:xfrm>
-            <a:off x="457200" y="4206240"/>
-            <a:ext cx="1338682" cy="347472"/>
+            <a:off x="457200" y="4069080"/>
+            <a:ext cx="1642262" cy="384048"/>
           </a:xfrm>
           <a:prstGeom prst="rect">
             <a:avLst/>
@@ -2363,11 +2363,11 @@
             <a:r>
               <a:rPr lang="en-US" sz="1100" b="1" u="sng" dirty="0">
                 <a:solidFill>
-                  <a:srgbClr val="FFFFFF"/>
-                </a:solidFill>
-                <a:latin typeface="Calibri" pitchFamily="34" charset="0"/>
-                <a:ea typeface="Calibri" pitchFamily="34" charset="-122"/>
-                <a:cs typeface="Calibri" pitchFamily="34" charset="-120"/>
+                  <a:srgbClr val="23155C"/>
+                </a:solidFill>
+                <a:latin typeface="Arial" pitchFamily="34" charset="0"/>
+                <a:ea typeface="Arial" pitchFamily="34" charset="-122"/>
+                <a:cs typeface="Arial" pitchFamily="34" charset="-120"/>
                 <a:hlinkClick r:id="rId4" invalidUrl="" action="" tgtFrame="" tooltip="" history="1" highlightClick="0" endSnd="0">
                   <a:extLst>
                     <a:ext uri="{A12FA001-AC4F-418D-AE19-62706E023703}">
@@ -2376,7 +2376,7 @@
                   </a:extLst>
                 </a:hlinkClick>
               </a:rPr>
-              <a:t>🔗 Meet Gen post</a:t>
+              <a:t>Meet Gen post</a:t>
             </a:r>
             <a:endParaRPr lang="en-US" sz="1100" dirty="0"/>
           </a:p>
@@ -2392,8 +2392,8 @@
         </p:nvSpPr>
         <p:spPr>
           <a:xfrm>
-            <a:off x="1933042" y="4206240"/>
-            <a:ext cx="1267358" cy="347472"/>
+            <a:off x="2236622" y="4069080"/>
+            <a:ext cx="1558138" cy="384048"/>
           </a:xfrm>
           <a:prstGeom prst="roundRect">
             <a:avLst>
@@ -2401,11 +2401,11 @@
             </a:avLst>
           </a:prstGeom>
           <a:solidFill>
-            <a:srgbClr val="23155C"/>
+            <a:srgbClr val="F6F3FF"/>
           </a:solidFill>
           <a:ln w="12700">
             <a:solidFill>
-              <a:srgbClr val="23155C"/>
+              <a:srgbClr val="D9D0F5"/>
             </a:solidFill>
             <a:prstDash val="solid"/>
           </a:ln>
@@ -2421,8 +2421,8 @@
         </p:nvSpPr>
         <p:spPr>
           <a:xfrm>
-            <a:off x="1933042" y="4206240"/>
-            <a:ext cx="1267358" cy="347472"/>
+            <a:off x="2236622" y="4069080"/>
+            <a:ext cx="1558138" cy="384048"/>
           </a:xfrm>
           <a:prstGeom prst="rect">
             <a:avLst/>
@@ -2440,11 +2440,11 @@
             <a:r>
               <a:rPr lang="en-US" sz="1100" b="1" u="sng" dirty="0">
                 <a:solidFill>
-                  <a:srgbClr val="FFFFFF"/>
-                </a:solidFill>
-                <a:latin typeface="Calibri" pitchFamily="34" charset="0"/>
-                <a:ea typeface="Calibri" pitchFamily="34" charset="-122"/>
-                <a:cs typeface="Calibri" pitchFamily="34" charset="-120"/>
+                  <a:srgbClr val="23155C"/>
+                </a:solidFill>
+                <a:latin typeface="Arial" pitchFamily="34" charset="0"/>
+                <a:ea typeface="Arial" pitchFamily="34" charset="-122"/>
+                <a:cs typeface="Arial" pitchFamily="34" charset="-120"/>
                 <a:hlinkClick r:id="rId6" invalidUrl="" action="" tgtFrame="" tooltip="" history="1" highlightClick="0" endSnd="0">
                   <a:extLst>
                     <a:ext uri="{A12FA001-AC4F-418D-AE19-62706E023703}">
@@ -2453,7 +2453,7 @@
                   </a:extLst>
                 </a:hlinkClick>
               </a:rPr>
-              <a:t>🔗 Medium draft</a:t>
+              <a:t>Medium draft</a:t>
             </a:r>
             <a:endParaRPr lang="en-US" sz="1100" dirty="0"/>
           </a:p>
@@ -2469,8 +2469,8 @@
         </p:nvSpPr>
         <p:spPr>
           <a:xfrm>
-            <a:off x="3337560" y="4206240"/>
-            <a:ext cx="1053389" cy="347472"/>
+            <a:off x="3931920" y="4069080"/>
+            <a:ext cx="1305763" cy="384048"/>
           </a:xfrm>
           <a:prstGeom prst="roundRect">
             <a:avLst>
@@ -2478,11 +2478,11 @@
             </a:avLst>
           </a:prstGeom>
           <a:solidFill>
-            <a:srgbClr val="23155C"/>
+            <a:srgbClr val="F6F3FF"/>
           </a:solidFill>
           <a:ln w="12700">
             <a:solidFill>
-              <a:srgbClr val="23155C"/>
+              <a:srgbClr val="D9D0F5"/>
             </a:solidFill>
             <a:prstDash val="solid"/>
           </a:ln>
@@ -2498,8 +2498,8 @@
         </p:nvSpPr>
         <p:spPr>
           <a:xfrm>
-            <a:off x="3337560" y="4206240"/>
-            <a:ext cx="1053389" cy="347472"/>
+            <a:off x="3931920" y="4069080"/>
+            <a:ext cx="1305763" cy="384048"/>
           </a:xfrm>
           <a:prstGeom prst="rect">
             <a:avLst/>
@@ -2517,11 +2517,11 @@
             <a:r>
               <a:rPr lang="en-US" sz="1100" b="1" u="sng" dirty="0">
                 <a:solidFill>
-                  <a:srgbClr val="FFFFFF"/>
-                </a:solidFill>
-                <a:latin typeface="Calibri" pitchFamily="34" charset="0"/>
-                <a:ea typeface="Calibri" pitchFamily="34" charset="-122"/>
-                <a:cs typeface="Calibri" pitchFamily="34" charset="-120"/>
+                  <a:srgbClr val="23155C"/>
+                </a:solidFill>
+                <a:latin typeface="Arial" pitchFamily="34" charset="0"/>
+                <a:ea typeface="Arial" pitchFamily="34" charset="-122"/>
+                <a:cs typeface="Arial" pitchFamily="34" charset="-120"/>
                 <a:hlinkClick r:id="rId8" invalidUrl="" action="" tgtFrame="" tooltip="" history="1" highlightClick="0" endSnd="0">
                   <a:extLst>
                     <a:ext uri="{A12FA001-AC4F-418D-AE19-62706E023703}">
@@ -2530,7 +2530,7 @@
                   </a:extLst>
                 </a:hlinkClick>
               </a:rPr>
-              <a:t>🔗 Blog text</a:t>
+              <a:t>Blog text</a:t>
             </a:r>
             <a:endParaRPr lang="en-US" sz="1100" dirty="0"/>
           </a:p>
@@ -2546,8 +2546,8 @@
         </p:nvSpPr>
         <p:spPr>
           <a:xfrm>
-            <a:off x="4528109" y="4206240"/>
-            <a:ext cx="1481328" cy="347472"/>
+            <a:off x="5374843" y="4069080"/>
+            <a:ext cx="1810512" cy="384048"/>
           </a:xfrm>
           <a:prstGeom prst="roundRect">
             <a:avLst>
@@ -2555,11 +2555,11 @@
             </a:avLst>
           </a:prstGeom>
           <a:solidFill>
-            <a:srgbClr val="23155C"/>
+            <a:srgbClr val="F6F3FF"/>
           </a:solidFill>
           <a:ln w="12700">
             <a:solidFill>
-              <a:srgbClr val="23155C"/>
+              <a:srgbClr val="D9D0F5"/>
             </a:solidFill>
             <a:prstDash val="solid"/>
           </a:ln>
@@ -2575,8 +2575,8 @@
         </p:nvSpPr>
         <p:spPr>
           <a:xfrm>
-            <a:off x="4528109" y="4206240"/>
-            <a:ext cx="1481328" cy="347472"/>
+            <a:off x="5374843" y="4069080"/>
+            <a:ext cx="1810512" cy="384048"/>
           </a:xfrm>
           <a:prstGeom prst="rect">
             <a:avLst/>
@@ -2594,11 +2594,11 @@
             <a:r>
               <a:rPr lang="en-US" sz="1100" b="1" u="sng" dirty="0">
                 <a:solidFill>
-                  <a:srgbClr val="FFFFFF"/>
-                </a:solidFill>
-                <a:latin typeface="Calibri" pitchFamily="34" charset="0"/>
-                <a:ea typeface="Calibri" pitchFamily="34" charset="-122"/>
-                <a:cs typeface="Calibri" pitchFamily="34" charset="-120"/>
+                  <a:srgbClr val="23155C"/>
+                </a:solidFill>
+                <a:latin typeface="Arial" pitchFamily="34" charset="0"/>
+                <a:ea typeface="Arial" pitchFamily="34" charset="-122"/>
+                <a:cs typeface="Arial" pitchFamily="34" charset="-120"/>
                 <a:hlinkClick r:id="rId10" invalidUrl="" action="" tgtFrame="" tooltip="" history="1" highlightClick="0" endSnd="0">
                   <a:extLst>
                     <a:ext uri="{A12FA001-AC4F-418D-AE19-62706E023703}">
@@ -2607,7 +2607,7 @@
                   </a:extLst>
                 </a:hlinkClick>
               </a:rPr>
-              <a:t>🔗 Campaign images</a:t>
+              <a:t>Campaign images</a:t>
             </a:r>
             <a:endParaRPr lang="en-US" sz="1100" dirty="0"/>
           </a:p>
@@ -2621,7 +2621,7 @@
         </p:nvSpPr>
         <p:spPr>
           <a:xfrm>
-            <a:off x="457200" y="4773168"/>
+            <a:off x="457200" y="4846320"/>
             <a:ext cx="8229600" cy="274320"/>
           </a:xfrm>
           <a:prstGeom prst="rect">
@@ -2642,9 +2642,9 @@
                 <a:solidFill>
                   <a:srgbClr val="8B84AD"/>
                 </a:solidFill>
-                <a:latin typeface="Calibri" pitchFamily="34" charset="0"/>
-                <a:ea typeface="Calibri" pitchFamily="34" charset="-122"/>
-                <a:cs typeface="Calibri" pitchFamily="34" charset="-120"/>
+                <a:latin typeface="Arial" pitchFamily="34" charset="0"/>
+                <a:ea typeface="Arial" pitchFamily="34" charset="-122"/>
+                <a:cs typeface="Arial" pitchFamily="34" charset="-120"/>
               </a:rPr>
               <a:t>@learnwithgenn · praneet-admin.github.io/gengo</a:t>
             </a:r>
@@ -2709,17 +2709,17 @@
               <a:buNone/>
             </a:pPr>
             <a:r>
-              <a:rPr lang="en-US" sz="3400" b="1" dirty="0">
+              <a:rPr lang="en-US" sz="3000" b="1" dirty="0">
                 <a:solidFill>
                   <a:srgbClr val="23155C"/>
                 </a:solidFill>
-                <a:latin typeface="Calibri" pitchFamily="34" charset="0"/>
-                <a:ea typeface="Calibri" pitchFamily="34" charset="-122"/>
-                <a:cs typeface="Calibri" pitchFamily="34" charset="-120"/>
+                <a:latin typeface="Arial" pitchFamily="34" charset="0"/>
+                <a:ea typeface="Arial" pitchFamily="34" charset="-122"/>
+                <a:cs typeface="Arial" pitchFamily="34" charset="-120"/>
               </a:rPr>
               <a:t>The brand</a:t>
             </a:r>
-            <a:endParaRPr lang="en-US" sz="3400" dirty="0"/>
+            <a:endParaRPr lang="en-US" sz="3000" dirty="0"/>
           </a:p>
         </p:txBody>
       </p:sp>
@@ -2915,8 +2915,8 @@
         </p:nvSpPr>
         <p:spPr>
           <a:xfrm>
-            <a:off x="457200" y="4206240"/>
-            <a:ext cx="1766621" cy="347472"/>
+            <a:off x="457200" y="4069080"/>
+            <a:ext cx="2147011" cy="384048"/>
           </a:xfrm>
           <a:prstGeom prst="roundRect">
             <a:avLst>
@@ -2924,11 +2924,11 @@
             </a:avLst>
           </a:prstGeom>
           <a:solidFill>
-            <a:srgbClr val="23155C"/>
+            <a:srgbClr val="F6F3FF"/>
           </a:solidFill>
           <a:ln w="12700">
             <a:solidFill>
-              <a:srgbClr val="23155C"/>
+              <a:srgbClr val="D9D0F5"/>
             </a:solidFill>
             <a:prstDash val="solid"/>
           </a:ln>
@@ -2944,8 +2944,8 @@
         </p:nvSpPr>
         <p:spPr>
           <a:xfrm>
-            <a:off x="457200" y="4206240"/>
-            <a:ext cx="1766621" cy="347472"/>
+            <a:off x="457200" y="4069080"/>
+            <a:ext cx="2147011" cy="384048"/>
           </a:xfrm>
           <a:prstGeom prst="rect">
             <a:avLst/>
@@ -2963,11 +2963,11 @@
             <a:r>
               <a:rPr lang="en-US" sz="1100" b="1" u="sng" dirty="0">
                 <a:solidFill>
-                  <a:srgbClr val="FFFFFF"/>
-                </a:solidFill>
-                <a:latin typeface="Calibri" pitchFamily="34" charset="0"/>
-                <a:ea typeface="Calibri" pitchFamily="34" charset="-122"/>
-                <a:cs typeface="Calibri" pitchFamily="34" charset="-120"/>
+                  <a:srgbClr val="23155C"/>
+                </a:solidFill>
+                <a:latin typeface="Arial" pitchFamily="34" charset="0"/>
+                <a:ea typeface="Arial" pitchFamily="34" charset="-122"/>
+                <a:cs typeface="Arial" pitchFamily="34" charset="-120"/>
                 <a:hlinkClick r:id="rId4" invalidUrl="" action="" tgtFrame="" tooltip="" history="1" highlightClick="0" endSnd="0">
                   <a:extLst>
                     <a:ext uri="{A12FA001-AC4F-418D-AE19-62706E023703}">
@@ -2976,7 +2976,7 @@
                   </a:extLst>
                 </a:hlinkClick>
               </a:rPr>
-              <a:t>🔗 Gen artwork + icons</a:t>
+              <a:t>Gen artwork + icons</a:t>
             </a:r>
             <a:endParaRPr lang="en-US" sz="1100" dirty="0"/>
           </a:p>
@@ -2992,8 +2992,8 @@
         </p:nvSpPr>
         <p:spPr>
           <a:xfrm>
-            <a:off x="2360981" y="4206240"/>
-            <a:ext cx="2907792" cy="347472"/>
+            <a:off x="2741371" y="4069080"/>
+            <a:ext cx="1726387" cy="384048"/>
           </a:xfrm>
           <a:prstGeom prst="roundRect">
             <a:avLst>
@@ -3001,11 +3001,11 @@
             </a:avLst>
           </a:prstGeom>
           <a:solidFill>
-            <a:srgbClr val="23155C"/>
+            <a:srgbClr val="F6F3FF"/>
           </a:solidFill>
           <a:ln w="12700">
             <a:solidFill>
-              <a:srgbClr val="23155C"/>
+              <a:srgbClr val="D9D0F5"/>
             </a:solidFill>
             <a:prstDash val="solid"/>
           </a:ln>
@@ -3021,8 +3021,8 @@
         </p:nvSpPr>
         <p:spPr>
           <a:xfrm>
-            <a:off x="2360981" y="4206240"/>
-            <a:ext cx="2907792" cy="347472"/>
+            <a:off x="2741371" y="4069080"/>
+            <a:ext cx="1726387" cy="384048"/>
           </a:xfrm>
           <a:prstGeom prst="rect">
             <a:avLst/>
@@ -3040,11 +3040,11 @@
             <a:r>
               <a:rPr lang="en-US" sz="1100" b="1" u="sng" dirty="0">
                 <a:solidFill>
-                  <a:srgbClr val="FFFFFF"/>
-                </a:solidFill>
-                <a:latin typeface="Calibri" pitchFamily="34" charset="0"/>
-                <a:ea typeface="Calibri" pitchFamily="34" charset="-122"/>
-                <a:cs typeface="Calibri" pitchFamily="34" charset="-120"/>
+                  <a:srgbClr val="23155C"/>
+                </a:solidFill>
+                <a:latin typeface="Arial" pitchFamily="34" charset="0"/>
+                <a:ea typeface="Arial" pitchFamily="34" charset="-122"/>
+                <a:cs typeface="Arial" pitchFamily="34" charset="-120"/>
                 <a:hlinkClick r:id="rId6" invalidUrl="" action="" tgtFrame="" tooltip="" history="1" highlightClick="0" endSnd="0">
                   <a:extLst>
                     <a:ext uri="{A12FA001-AC4F-418D-AE19-62706E023703}">
@@ -3053,7 +3053,7 @@
                   </a:extLst>
                 </a:hlinkClick>
               </a:rPr>
-              <a:t>🔗 Design assets (logo, flyer, banner)</a:t>
+              <a:t>Campaign notes</a:t>
             </a:r>
             <a:endParaRPr lang="en-US" sz="1100" dirty="0"/>
           </a:p>
@@ -3067,7 +3067,7 @@
         </p:nvSpPr>
         <p:spPr>
           <a:xfrm>
-            <a:off x="457200" y="4773168"/>
+            <a:off x="457200" y="4846320"/>
             <a:ext cx="8229600" cy="274320"/>
           </a:xfrm>
           <a:prstGeom prst="rect">
@@ -3088,9 +3088,9 @@
                 <a:solidFill>
                   <a:srgbClr val="8B84AD"/>
                 </a:solidFill>
-                <a:latin typeface="Calibri" pitchFamily="34" charset="0"/>
-                <a:ea typeface="Calibri" pitchFamily="34" charset="-122"/>
-                <a:cs typeface="Calibri" pitchFamily="34" charset="-120"/>
+                <a:latin typeface="Arial" pitchFamily="34" charset="0"/>
+                <a:ea typeface="Arial" pitchFamily="34" charset="-122"/>
+                <a:cs typeface="Arial" pitchFamily="34" charset="-120"/>
               </a:rPr>
               <a:t>@learnwithgenn · praneet-admin.github.io/gengo</a:t>
             </a:r>
@@ -3155,17 +3155,17 @@
               <a:buNone/>
             </a:pPr>
             <a:r>
-              <a:rPr lang="en-US" sz="3400" b="1" dirty="0">
+              <a:rPr lang="en-US" sz="3000" b="1" dirty="0">
                 <a:solidFill>
                   <a:srgbClr val="FFFFFF"/>
                 </a:solidFill>
-                <a:latin typeface="Calibri" pitchFamily="34" charset="0"/>
-                <a:ea typeface="Calibri" pitchFamily="34" charset="-122"/>
-                <a:cs typeface="Calibri" pitchFamily="34" charset="-120"/>
+                <a:latin typeface="Arial" pitchFamily="34" charset="0"/>
+                <a:ea typeface="Arial" pitchFamily="34" charset="-122"/>
+                <a:cs typeface="Arial" pitchFamily="34" charset="-120"/>
               </a:rPr>
               <a:t>Done in 30 days means</a:t>
             </a:r>
-            <a:endParaRPr lang="en-US" sz="3400" dirty="0"/>
+            <a:endParaRPr lang="en-US" sz="3000" dirty="0"/>
           </a:p>
         </p:txBody>
       </p:sp>
@@ -3225,9 +3225,9 @@
                 <a:solidFill>
                   <a:srgbClr val="FFD233"/>
                 </a:solidFill>
-                <a:latin typeface="Calibri" pitchFamily="34" charset="0"/>
-                <a:ea typeface="Calibri" pitchFamily="34" charset="-122"/>
-                <a:cs typeface="Calibri" pitchFamily="34" charset="-120"/>
+                <a:latin typeface="Arial" pitchFamily="34" charset="0"/>
+                <a:ea typeface="Arial" pitchFamily="34" charset="-122"/>
+                <a:cs typeface="Arial" pitchFamily="34" charset="-120"/>
               </a:rPr>
               <a:t>10</a:t>
             </a:r>
@@ -3264,9 +3264,9 @@
                 <a:solidFill>
                   <a:srgbClr val="FFFFFF"/>
                 </a:solidFill>
-                <a:latin typeface="Calibri" pitchFamily="34" charset="0"/>
-                <a:ea typeface="Calibri" pitchFamily="34" charset="-122"/>
-                <a:cs typeface="Calibri" pitchFamily="34" charset="-120"/>
+                <a:latin typeface="Arial" pitchFamily="34" charset="0"/>
+                <a:ea typeface="Arial" pitchFamily="34" charset="-122"/>
+                <a:cs typeface="Arial" pitchFamily="34" charset="-120"/>
               </a:rPr>
               <a:t>WhatsApp shares</a:t>
             </a:r>
@@ -3330,9 +3330,9 @@
                 <a:solidFill>
                   <a:srgbClr val="FFD233"/>
                 </a:solidFill>
-                <a:latin typeface="Calibri" pitchFamily="34" charset="0"/>
-                <a:ea typeface="Calibri" pitchFamily="34" charset="-122"/>
-                <a:cs typeface="Calibri" pitchFamily="34" charset="-120"/>
+                <a:latin typeface="Arial" pitchFamily="34" charset="0"/>
+                <a:ea typeface="Arial" pitchFamily="34" charset="-122"/>
+                <a:cs typeface="Arial" pitchFamily="34" charset="-120"/>
               </a:rPr>
               <a:t>5</a:t>
             </a:r>
@@ -3369,9 +3369,9 @@
                 <a:solidFill>
                   <a:srgbClr val="FFFFFF"/>
                 </a:solidFill>
-                <a:latin typeface="Calibri" pitchFamily="34" charset="0"/>
-                <a:ea typeface="Calibri" pitchFamily="34" charset="-122"/>
-                <a:cs typeface="Calibri" pitchFamily="34" charset="-120"/>
+                <a:latin typeface="Arial" pitchFamily="34" charset="0"/>
+                <a:ea typeface="Arial" pitchFamily="34" charset="-122"/>
+                <a:cs typeface="Arial" pitchFamily="34" charset="-120"/>
               </a:rPr>
               <a:t>GitHub issues</a:t>
             </a:r>
@@ -3435,9 +3435,9 @@
                 <a:solidFill>
                   <a:srgbClr val="FFD233"/>
                 </a:solidFill>
-                <a:latin typeface="Calibri" pitchFamily="34" charset="0"/>
-                <a:ea typeface="Calibri" pitchFamily="34" charset="-122"/>
-                <a:cs typeface="Calibri" pitchFamily="34" charset="-120"/>
+                <a:latin typeface="Arial" pitchFamily="34" charset="0"/>
+                <a:ea typeface="Arial" pitchFamily="34" charset="-122"/>
+                <a:cs typeface="Arial" pitchFamily="34" charset="-120"/>
               </a:rPr>
               <a:t>1</a:t>
             </a:r>
@@ -3474,9 +3474,9 @@
                 <a:solidFill>
                   <a:srgbClr val="FFFFFF"/>
                 </a:solidFill>
-                <a:latin typeface="Calibri" pitchFamily="34" charset="0"/>
-                <a:ea typeface="Calibri" pitchFamily="34" charset="-122"/>
-                <a:cs typeface="Calibri" pitchFamily="34" charset="-120"/>
+                <a:latin typeface="Arial" pitchFamily="34" charset="0"/>
+                <a:ea typeface="Arial" pitchFamily="34" charset="-122"/>
+                <a:cs typeface="Arial" pitchFamily="34" charset="-120"/>
               </a:rPr>
               <a:t>faculty reply</a:t>
             </a:r>
@@ -3513,9 +3513,9 @@
                 <a:solidFill>
                   <a:srgbClr val="D6CCFF"/>
                 </a:solidFill>
-                <a:latin typeface="Calibri" pitchFamily="34" charset="0"/>
-                <a:ea typeface="Calibri" pitchFamily="34" charset="-122"/>
-                <a:cs typeface="Calibri" pitchFamily="34" charset="-120"/>
+                <a:latin typeface="Arial" pitchFamily="34" charset="0"/>
+                <a:ea typeface="Arial" pitchFamily="34" charset="-122"/>
+                <a:cs typeface="Arial" pitchFamily="34" charset="-120"/>
               </a:rPr>
               <a:t>Next: link in bio · publish Medium · one Reel a day</a:t>
             </a:r>
@@ -3533,8 +3533,8 @@
         </p:nvSpPr>
         <p:spPr>
           <a:xfrm>
-            <a:off x="457200" y="4206240"/>
-            <a:ext cx="1267358" cy="347472"/>
+            <a:off x="457200" y="4069080"/>
+            <a:ext cx="1558138" cy="384048"/>
           </a:xfrm>
           <a:prstGeom prst="roundRect">
             <a:avLst>
@@ -3542,11 +3542,11 @@
             </a:avLst>
           </a:prstGeom>
           <a:solidFill>
-            <a:srgbClr val="FFD233"/>
+            <a:srgbClr val="FFFFFF"/>
           </a:solidFill>
           <a:ln w="12700">
             <a:solidFill>
-              <a:srgbClr val="FFD233"/>
+              <a:srgbClr val="FFFFFF"/>
             </a:solidFill>
             <a:prstDash val="solid"/>
           </a:ln>
@@ -3562,8 +3562,8 @@
         </p:nvSpPr>
         <p:spPr>
           <a:xfrm>
-            <a:off x="457200" y="4206240"/>
-            <a:ext cx="1267358" cy="347472"/>
+            <a:off x="457200" y="4069080"/>
+            <a:ext cx="1558138" cy="384048"/>
           </a:xfrm>
           <a:prstGeom prst="rect">
             <a:avLst/>
@@ -3583,9 +3583,9 @@
                 <a:solidFill>
                   <a:srgbClr val="23155C"/>
                 </a:solidFill>
-                <a:latin typeface="Calibri" pitchFamily="34" charset="0"/>
-                <a:ea typeface="Calibri" pitchFamily="34" charset="-122"/>
-                <a:cs typeface="Calibri" pitchFamily="34" charset="-120"/>
+                <a:latin typeface="Arial" pitchFamily="34" charset="0"/>
+                <a:ea typeface="Arial" pitchFamily="34" charset="-122"/>
+                <a:cs typeface="Arial" pitchFamily="34" charset="-120"/>
                 <a:hlinkClick r:id="rId2" invalidUrl="" action="" tgtFrame="" tooltip="" history="1" highlightClick="0" endSnd="0">
                   <a:extLst>
                     <a:ext uri="{A12FA001-AC4F-418D-AE19-62706E023703}">
@@ -3594,7 +3594,7 @@
                   </a:extLst>
                 </a:hlinkClick>
               </a:rPr>
-              <a:t>🔗 Open the app</a:t>
+              <a:t>Open the app</a:t>
             </a:r>
             <a:endParaRPr lang="en-US" sz="1100" dirty="0"/>
           </a:p>
@@ -3610,8 +3610,8 @@
         </p:nvSpPr>
         <p:spPr>
           <a:xfrm>
-            <a:off x="1861718" y="4206240"/>
-            <a:ext cx="1053389" cy="347472"/>
+            <a:off x="2152498" y="4069080"/>
+            <a:ext cx="1305763" cy="384048"/>
           </a:xfrm>
           <a:prstGeom prst="roundRect">
             <a:avLst>
@@ -3619,11 +3619,11 @@
             </a:avLst>
           </a:prstGeom>
           <a:solidFill>
-            <a:srgbClr val="FFD233"/>
+            <a:srgbClr val="FFFFFF"/>
           </a:solidFill>
           <a:ln w="12700">
             <a:solidFill>
-              <a:srgbClr val="FFD233"/>
+              <a:srgbClr val="FFFFFF"/>
             </a:solidFill>
             <a:prstDash val="solid"/>
           </a:ln>
@@ -3639,8 +3639,8 @@
         </p:nvSpPr>
         <p:spPr>
           <a:xfrm>
-            <a:off x="1861718" y="4206240"/>
-            <a:ext cx="1053389" cy="347472"/>
+            <a:off x="2152498" y="4069080"/>
+            <a:ext cx="1305763" cy="384048"/>
           </a:xfrm>
           <a:prstGeom prst="rect">
             <a:avLst/>
@@ -3660,9 +3660,9 @@
                 <a:solidFill>
                   <a:srgbClr val="23155C"/>
                 </a:solidFill>
-                <a:latin typeface="Calibri" pitchFamily="34" charset="0"/>
-                <a:ea typeface="Calibri" pitchFamily="34" charset="-122"/>
-                <a:cs typeface="Calibri" pitchFamily="34" charset="-120"/>
+                <a:latin typeface="Arial" pitchFamily="34" charset="0"/>
+                <a:ea typeface="Arial" pitchFamily="34" charset="-122"/>
+                <a:cs typeface="Arial" pitchFamily="34" charset="-120"/>
                 <a:hlinkClick r:id="rId4" invalidUrl="" action="" tgtFrame="" tooltip="" history="1" highlightClick="0" endSnd="0">
                   <a:extLst>
                     <a:ext uri="{A12FA001-AC4F-418D-AE19-62706E023703}">
@@ -3671,7 +3671,7 @@
                   </a:extLst>
                 </a:hlinkClick>
               </a:rPr>
-              <a:t>🔗 Instagram</a:t>
+              <a:t>Instagram</a:t>
             </a:r>
             <a:endParaRPr lang="en-US" sz="1100" dirty="0"/>
           </a:p>
@@ -3687,8 +3687,8 @@
         </p:nvSpPr>
         <p:spPr>
           <a:xfrm>
-            <a:off x="3052267" y="4206240"/>
-            <a:ext cx="839419" cy="347472"/>
+            <a:off x="3595421" y="4069080"/>
+            <a:ext cx="1053389" cy="384048"/>
           </a:xfrm>
           <a:prstGeom prst="roundRect">
             <a:avLst>
@@ -3696,11 +3696,11 @@
             </a:avLst>
           </a:prstGeom>
           <a:solidFill>
-            <a:srgbClr val="FFD233"/>
+            <a:srgbClr val="FFFFFF"/>
           </a:solidFill>
           <a:ln w="12700">
             <a:solidFill>
-              <a:srgbClr val="FFD233"/>
+              <a:srgbClr val="FFFFFF"/>
             </a:solidFill>
             <a:prstDash val="solid"/>
           </a:ln>
@@ -3716,8 +3716,8 @@
         </p:nvSpPr>
         <p:spPr>
           <a:xfrm>
-            <a:off x="3052267" y="4206240"/>
-            <a:ext cx="839419" cy="347472"/>
+            <a:off x="3595421" y="4069080"/>
+            <a:ext cx="1053389" cy="384048"/>
           </a:xfrm>
           <a:prstGeom prst="rect">
             <a:avLst/>
@@ -3737,9 +3737,9 @@
                 <a:solidFill>
                   <a:srgbClr val="23155C"/>
                 </a:solidFill>
-                <a:latin typeface="Calibri" pitchFamily="34" charset="0"/>
-                <a:ea typeface="Calibri" pitchFamily="34" charset="-122"/>
-                <a:cs typeface="Calibri" pitchFamily="34" charset="-120"/>
+                <a:latin typeface="Arial" pitchFamily="34" charset="0"/>
+                <a:ea typeface="Arial" pitchFamily="34" charset="-122"/>
+                <a:cs typeface="Arial" pitchFamily="34" charset="-120"/>
                 <a:hlinkClick r:id="rId6" invalidUrl="" action="" tgtFrame="" tooltip="" history="1" highlightClick="0" endSnd="0">
                   <a:extLst>
                     <a:ext uri="{A12FA001-AC4F-418D-AE19-62706E023703}">
@@ -3748,7 +3748,7 @@
                   </a:extLst>
                 </a:hlinkClick>
               </a:rPr>
-              <a:t>🔗 GitHub</a:t>
+              <a:t>GitHub</a:t>
             </a:r>
             <a:endParaRPr lang="en-US" sz="1100" dirty="0"/>
           </a:p>
@@ -3762,7 +3762,7 @@
         </p:nvSpPr>
         <p:spPr>
           <a:xfrm>
-            <a:off x="457200" y="4773168"/>
+            <a:off x="457200" y="4846320"/>
             <a:ext cx="8229600" cy="274320"/>
           </a:xfrm>
           <a:prstGeom prst="rect">
@@ -3783,9 +3783,9 @@
                 <a:solidFill>
                   <a:srgbClr val="A99BE0"/>
                 </a:solidFill>
-                <a:latin typeface="Calibri" pitchFamily="34" charset="0"/>
-                <a:ea typeface="Calibri" pitchFamily="34" charset="-122"/>
-                <a:cs typeface="Calibri" pitchFamily="34" charset="-120"/>
+                <a:latin typeface="Arial" pitchFamily="34" charset="0"/>
+                <a:ea typeface="Arial" pitchFamily="34" charset="-122"/>
+                <a:cs typeface="Arial" pitchFamily="34" charset="-120"/>
               </a:rPr>
               <a:t>@learnwithgenn · praneet-admin.github.io/gengo</a:t>
             </a:r>
@@ -3854,9 +3854,9 @@
                 <a:solidFill>
                   <a:srgbClr val="FFFFFF"/>
                 </a:solidFill>
-                <a:latin typeface="Calibri" pitchFamily="34" charset="0"/>
-                <a:ea typeface="Calibri" pitchFamily="34" charset="-122"/>
-                <a:cs typeface="Calibri" pitchFamily="34" charset="-120"/>
+                <a:latin typeface="Arial" pitchFamily="34" charset="0"/>
+                <a:ea typeface="Arial" pitchFamily="34" charset="-122"/>
+                <a:cs typeface="Arial" pitchFamily="34" charset="-120"/>
               </a:rPr>
               <a:t>You look up a word.</a:t>
             </a:r>
@@ -3871,9 +3871,9 @@
                 <a:solidFill>
                   <a:srgbClr val="FFFFFF"/>
                 </a:solidFill>
-                <a:latin typeface="Calibri" pitchFamily="34" charset="0"/>
-                <a:ea typeface="Calibri" pitchFamily="34" charset="-122"/>
-                <a:cs typeface="Calibri" pitchFamily="34" charset="-120"/>
+                <a:latin typeface="Arial" pitchFamily="34" charset="0"/>
+                <a:ea typeface="Arial" pitchFamily="34" charset="-122"/>
+                <a:cs typeface="Arial" pitchFamily="34" charset="-120"/>
               </a:rPr>
               <a:t>You nod.</a:t>
             </a:r>
@@ -3888,9 +3888,9 @@
                 <a:solidFill>
                   <a:srgbClr val="FFFFFF"/>
                 </a:solidFill>
-                <a:latin typeface="Calibri" pitchFamily="34" charset="0"/>
-                <a:ea typeface="Calibri" pitchFamily="34" charset="-122"/>
-                <a:cs typeface="Calibri" pitchFamily="34" charset="-120"/>
+                <a:latin typeface="Arial" pitchFamily="34" charset="0"/>
+                <a:ea typeface="Arial" pitchFamily="34" charset="-122"/>
+                <a:cs typeface="Arial" pitchFamily="34" charset="-120"/>
               </a:rPr>
               <a:t>By Friday, it’s gone.</a:t>
             </a:r>
@@ -3927,9 +3927,9 @@
                 <a:solidFill>
                   <a:srgbClr val="FFD233"/>
                 </a:solidFill>
-                <a:latin typeface="Calibri" pitchFamily="34" charset="0"/>
-                <a:ea typeface="Calibri" pitchFamily="34" charset="-122"/>
-                <a:cs typeface="Calibri" pitchFamily="34" charset="-120"/>
+                <a:latin typeface="Arial" pitchFamily="34" charset="0"/>
+                <a:ea typeface="Arial" pitchFamily="34" charset="-122"/>
+                <a:cs typeface="Arial" pitchFamily="34" charset="-120"/>
               </a:rPr>
               <a:t>Gengo fixes that.</a:t>
             </a:r>
@@ -3966,9 +3966,9 @@
                 <a:solidFill>
                   <a:srgbClr val="D6CCFF"/>
                 </a:solidFill>
-                <a:latin typeface="Calibri" pitchFamily="34" charset="0"/>
-                <a:ea typeface="Calibri" pitchFamily="34" charset="-122"/>
-                <a:cs typeface="Calibri" pitchFamily="34" charset="-120"/>
+                <a:latin typeface="Arial" pitchFamily="34" charset="0"/>
+                <a:ea typeface="Arial" pitchFamily="34" charset="-122"/>
+                <a:cs typeface="Arial" pitchFamily="34" charset="-120"/>
               </a:rPr>
               <a:t>For final-year students prepping for placements</a:t>
             </a:r>
@@ -3986,8 +3986,8 @@
         </p:nvSpPr>
         <p:spPr>
           <a:xfrm>
-            <a:off x="457200" y="4206240"/>
-            <a:ext cx="2265883" cy="347472"/>
+            <a:off x="457200" y="4069080"/>
+            <a:ext cx="2735885" cy="384048"/>
           </a:xfrm>
           <a:prstGeom prst="roundRect">
             <a:avLst>
@@ -3995,11 +3995,11 @@
             </a:avLst>
           </a:prstGeom>
           <a:solidFill>
-            <a:srgbClr val="FFD233"/>
+            <a:srgbClr val="FFFFFF"/>
           </a:solidFill>
           <a:ln w="12700">
             <a:solidFill>
-              <a:srgbClr val="FFD233"/>
+              <a:srgbClr val="FFFFFF"/>
             </a:solidFill>
             <a:prstDash val="solid"/>
           </a:ln>
@@ -4015,8 +4015,8 @@
         </p:nvSpPr>
         <p:spPr>
           <a:xfrm>
-            <a:off x="457200" y="4206240"/>
-            <a:ext cx="2265883" cy="347472"/>
+            <a:off x="457200" y="4069080"/>
+            <a:ext cx="2735885" cy="384048"/>
           </a:xfrm>
           <a:prstGeom prst="rect">
             <a:avLst/>
@@ -4036,9 +4036,9 @@
                 <a:solidFill>
                   <a:srgbClr val="23155C"/>
                 </a:solidFill>
-                <a:latin typeface="Calibri" pitchFamily="34" charset="0"/>
-                <a:ea typeface="Calibri" pitchFamily="34" charset="-122"/>
-                <a:cs typeface="Calibri" pitchFamily="34" charset="-120"/>
+                <a:latin typeface="Arial" pitchFamily="34" charset="0"/>
+                <a:ea typeface="Arial" pitchFamily="34" charset="-122"/>
+                <a:cs typeface="Arial" pitchFamily="34" charset="-120"/>
                 <a:hlinkClick r:id="rId2" invalidUrl="" action="" tgtFrame="" tooltip="" history="1" highlightClick="0" endSnd="0">
                   <a:extLst>
                     <a:ext uri="{A12FA001-AC4F-418D-AE19-62706E023703}">
@@ -4047,7 +4047,7 @@
                   </a:extLst>
                 </a:hlinkClick>
               </a:rPr>
-              <a:t>🔗 Launch note: who it is for</a:t>
+              <a:t>Launch note: who it is for</a:t>
             </a:r>
             <a:endParaRPr lang="en-US" sz="1100" dirty="0"/>
           </a:p>
@@ -4061,7 +4061,7 @@
         </p:nvSpPr>
         <p:spPr>
           <a:xfrm>
-            <a:off x="457200" y="4773168"/>
+            <a:off x="457200" y="4846320"/>
             <a:ext cx="8229600" cy="274320"/>
           </a:xfrm>
           <a:prstGeom prst="rect">
@@ -4082,9 +4082,9 @@
                 <a:solidFill>
                   <a:srgbClr val="A99BE0"/>
                 </a:solidFill>
-                <a:latin typeface="Calibri" pitchFamily="34" charset="0"/>
-                <a:ea typeface="Calibri" pitchFamily="34" charset="-122"/>
-                <a:cs typeface="Calibri" pitchFamily="34" charset="-120"/>
+                <a:latin typeface="Arial" pitchFamily="34" charset="0"/>
+                <a:ea typeface="Arial" pitchFamily="34" charset="-122"/>
+                <a:cs typeface="Arial" pitchFamily="34" charset="-120"/>
               </a:rPr>
               <a:t>@learnwithgenn · praneet-admin.github.io/gengo</a:t>
             </a:r>
@@ -4149,17 +4149,17 @@
               <a:buNone/>
             </a:pPr>
             <a:r>
-              <a:rPr lang="en-US" sz="3400" b="1" dirty="0">
+              <a:rPr lang="en-US" sz="3000" b="1" dirty="0">
                 <a:solidFill>
                   <a:srgbClr val="23155C"/>
                 </a:solidFill>
-                <a:latin typeface="Calibri" pitchFamily="34" charset="0"/>
-                <a:ea typeface="Calibri" pitchFamily="34" charset="-122"/>
-                <a:cs typeface="Calibri" pitchFamily="34" charset="-120"/>
+                <a:latin typeface="Arial" pitchFamily="34" charset="0"/>
+                <a:ea typeface="Arial" pitchFamily="34" charset="-122"/>
+                <a:cs typeface="Arial" pitchFamily="34" charset="-120"/>
               </a:rPr>
               <a:t>The app</a:t>
             </a:r>
-            <a:endParaRPr lang="en-US" sz="3400" dirty="0"/>
+            <a:endParaRPr lang="en-US" sz="3000" dirty="0"/>
           </a:p>
         </p:txBody>
       </p:sp>
@@ -4178,8 +4178,8 @@
         </p:blipFill>
         <p:spPr>
           <a:xfrm>
-            <a:off x="777240" y="1051560"/>
-            <a:ext cx="1371600" cy="2468880"/>
+            <a:off x="777240" y="1005840"/>
+            <a:ext cx="1371600" cy="2377440"/>
           </a:xfrm>
           <a:prstGeom prst="rect">
             <a:avLst/>
@@ -4194,7 +4194,7 @@
         </p:nvSpPr>
         <p:spPr>
           <a:xfrm>
-            <a:off x="457200" y="3566160"/>
+            <a:off x="457200" y="3474720"/>
             <a:ext cx="2011680" cy="365760"/>
           </a:xfrm>
           <a:prstGeom prst="rect">
@@ -4215,9 +4215,9 @@
                 <a:solidFill>
                   <a:srgbClr val="23155C"/>
                 </a:solidFill>
-                <a:latin typeface="Calibri" pitchFamily="34" charset="0"/>
-                <a:ea typeface="Calibri" pitchFamily="34" charset="-122"/>
-                <a:cs typeface="Calibri" pitchFamily="34" charset="-120"/>
+                <a:latin typeface="Arial" pitchFamily="34" charset="0"/>
+                <a:ea typeface="Arial" pitchFamily="34" charset="-122"/>
+                <a:cs typeface="Arial" pitchFamily="34" charset="-120"/>
               </a:rPr>
               <a:t>Look it up</a:t>
             </a:r>
@@ -4240,8 +4240,8 @@
         </p:blipFill>
         <p:spPr>
           <a:xfrm>
-            <a:off x="2880360" y="1051560"/>
-            <a:ext cx="1371600" cy="2468880"/>
+            <a:off x="2880360" y="1005840"/>
+            <a:ext cx="1371600" cy="2377440"/>
           </a:xfrm>
           <a:prstGeom prst="rect">
             <a:avLst/>
@@ -4256,7 +4256,7 @@
         </p:nvSpPr>
         <p:spPr>
           <a:xfrm>
-            <a:off x="2560320" y="3566160"/>
+            <a:off x="2560320" y="3474720"/>
             <a:ext cx="2011680" cy="365760"/>
           </a:xfrm>
           <a:prstGeom prst="rect">
@@ -4277,9 +4277,9 @@
                 <a:solidFill>
                   <a:srgbClr val="23155C"/>
                 </a:solidFill>
-                <a:latin typeface="Calibri" pitchFamily="34" charset="0"/>
-                <a:ea typeface="Calibri" pitchFamily="34" charset="-122"/>
-                <a:cs typeface="Calibri" pitchFamily="34" charset="-120"/>
+                <a:latin typeface="Arial" pitchFamily="34" charset="0"/>
+                <a:ea typeface="Arial" pitchFamily="34" charset="-122"/>
+                <a:cs typeface="Arial" pitchFamily="34" charset="-120"/>
               </a:rPr>
               <a:t>Get quizzed</a:t>
             </a:r>
@@ -4302,8 +4302,8 @@
         </p:blipFill>
         <p:spPr>
           <a:xfrm>
-            <a:off x="4983480" y="1051560"/>
-            <a:ext cx="1371600" cy="2468880"/>
+            <a:off x="4983480" y="1005840"/>
+            <a:ext cx="1371600" cy="2377440"/>
           </a:xfrm>
           <a:prstGeom prst="rect">
             <a:avLst/>
@@ -4318,7 +4318,7 @@
         </p:nvSpPr>
         <p:spPr>
           <a:xfrm>
-            <a:off x="4663440" y="3566160"/>
+            <a:off x="4663440" y="3474720"/>
             <a:ext cx="2011680" cy="365760"/>
           </a:xfrm>
           <a:prstGeom prst="rect">
@@ -4339,9 +4339,9 @@
                 <a:solidFill>
                   <a:srgbClr val="23155C"/>
                 </a:solidFill>
-                <a:latin typeface="Calibri" pitchFamily="34" charset="0"/>
-                <a:ea typeface="Calibri" pitchFamily="34" charset="-122"/>
-                <a:cs typeface="Calibri" pitchFamily="34" charset="-120"/>
+                <a:latin typeface="Arial" pitchFamily="34" charset="0"/>
+                <a:ea typeface="Arial" pitchFamily="34" charset="-122"/>
+                <a:cs typeface="Arial" pitchFamily="34" charset="-120"/>
               </a:rPr>
               <a:t>Focus Sprint</a:t>
             </a:r>
@@ -4364,8 +4364,8 @@
         </p:blipFill>
         <p:spPr>
           <a:xfrm>
-            <a:off x="7086600" y="1051560"/>
-            <a:ext cx="1371600" cy="2468880"/>
+            <a:off x="7086600" y="1005840"/>
+            <a:ext cx="1371600" cy="2377440"/>
           </a:xfrm>
           <a:prstGeom prst="rect">
             <a:avLst/>
@@ -4380,7 +4380,7 @@
         </p:nvSpPr>
         <p:spPr>
           <a:xfrm>
-            <a:off x="6766560" y="3566160"/>
+            <a:off x="6766560" y="3474720"/>
             <a:ext cx="2011680" cy="365760"/>
           </a:xfrm>
           <a:prstGeom prst="rect">
@@ -4401,9 +4401,9 @@
                 <a:solidFill>
                   <a:srgbClr val="23155C"/>
                 </a:solidFill>
-                <a:latin typeface="Calibri" pitchFamily="34" charset="0"/>
-                <a:ea typeface="Calibri" pitchFamily="34" charset="-122"/>
-                <a:cs typeface="Calibri" pitchFamily="34" charset="-120"/>
+                <a:latin typeface="Arial" pitchFamily="34" charset="0"/>
+                <a:ea typeface="Arial" pitchFamily="34" charset="-122"/>
+                <a:cs typeface="Arial" pitchFamily="34" charset="-120"/>
               </a:rPr>
               <a:t>Keep the streak</a:t>
             </a:r>
@@ -4421,8 +4421,8 @@
         </p:nvSpPr>
         <p:spPr>
           <a:xfrm>
-            <a:off x="457200" y="4206240"/>
-            <a:ext cx="839419" cy="347472"/>
+            <a:off x="457200" y="4069080"/>
+            <a:ext cx="1053389" cy="384048"/>
           </a:xfrm>
           <a:prstGeom prst="roundRect">
             <a:avLst>
@@ -4430,11 +4430,11 @@
             </a:avLst>
           </a:prstGeom>
           <a:solidFill>
-            <a:srgbClr val="23155C"/>
+            <a:srgbClr val="F6F3FF"/>
           </a:solidFill>
           <a:ln w="12700">
             <a:solidFill>
-              <a:srgbClr val="23155C"/>
+              <a:srgbClr val="D9D0F5"/>
             </a:solidFill>
             <a:prstDash val="solid"/>
           </a:ln>
@@ -4450,8 +4450,8 @@
         </p:nvSpPr>
         <p:spPr>
           <a:xfrm>
-            <a:off x="457200" y="4206240"/>
-            <a:ext cx="839419" cy="347472"/>
+            <a:off x="457200" y="4069080"/>
+            <a:ext cx="1053389" cy="384048"/>
           </a:xfrm>
           <a:prstGeom prst="rect">
             <a:avLst/>
@@ -4469,11 +4469,11 @@
             <a:r>
               <a:rPr lang="en-US" sz="1100" b="1" u="sng" dirty="0">
                 <a:solidFill>
-                  <a:srgbClr val="FFFFFF"/>
-                </a:solidFill>
-                <a:latin typeface="Calibri" pitchFamily="34" charset="0"/>
-                <a:ea typeface="Calibri" pitchFamily="34" charset="-122"/>
-                <a:cs typeface="Calibri" pitchFamily="34" charset="-120"/>
+                  <a:srgbClr val="23155C"/>
+                </a:solidFill>
+                <a:latin typeface="Arial" pitchFamily="34" charset="0"/>
+                <a:ea typeface="Arial" pitchFamily="34" charset="-122"/>
+                <a:cs typeface="Arial" pitchFamily="34" charset="-120"/>
                 <a:hlinkClick r:id="rId6" invalidUrl="" action="" tgtFrame="" tooltip="" history="1" highlightClick="0" endSnd="0">
                   <a:extLst>
                     <a:ext uri="{A12FA001-AC4F-418D-AE19-62706E023703}">
@@ -4482,7 +4482,7 @@
                   </a:extLst>
                 </a:hlinkClick>
               </a:rPr>
-              <a:t>🔗 Try it</a:t>
+              <a:t>Try it</a:t>
             </a:r>
             <a:endParaRPr lang="en-US" sz="1100" dirty="0"/>
           </a:p>
@@ -4498,8 +4498,8 @@
         </p:nvSpPr>
         <p:spPr>
           <a:xfrm>
-            <a:off x="1433779" y="4206240"/>
-            <a:ext cx="1124712" cy="347472"/>
+            <a:off x="1647749" y="4069080"/>
+            <a:ext cx="1389888" cy="384048"/>
           </a:xfrm>
           <a:prstGeom prst="roundRect">
             <a:avLst>
@@ -4507,11 +4507,11 @@
             </a:avLst>
           </a:prstGeom>
           <a:solidFill>
-            <a:srgbClr val="23155C"/>
+            <a:srgbClr val="F6F3FF"/>
           </a:solidFill>
           <a:ln w="12700">
             <a:solidFill>
-              <a:srgbClr val="23155C"/>
+              <a:srgbClr val="D9D0F5"/>
             </a:solidFill>
             <a:prstDash val="solid"/>
           </a:ln>
@@ -4527,8 +4527,8 @@
         </p:nvSpPr>
         <p:spPr>
           <a:xfrm>
-            <a:off x="1433779" y="4206240"/>
-            <a:ext cx="1124712" cy="347472"/>
+            <a:off x="1647749" y="4069080"/>
+            <a:ext cx="1389888" cy="384048"/>
           </a:xfrm>
           <a:prstGeom prst="rect">
             <a:avLst/>
@@ -4546,11 +4546,11 @@
             <a:r>
               <a:rPr lang="en-US" sz="1100" b="1" u="sng" dirty="0">
                 <a:solidFill>
-                  <a:srgbClr val="FFFFFF"/>
-                </a:solidFill>
-                <a:latin typeface="Calibri" pitchFamily="34" charset="0"/>
-                <a:ea typeface="Calibri" pitchFamily="34" charset="-122"/>
-                <a:cs typeface="Calibri" pitchFamily="34" charset="-120"/>
+                  <a:srgbClr val="23155C"/>
+                </a:solidFill>
+                <a:latin typeface="Arial" pitchFamily="34" charset="0"/>
+                <a:ea typeface="Arial" pitchFamily="34" charset="-122"/>
+                <a:cs typeface="Arial" pitchFamily="34" charset="-120"/>
                 <a:hlinkClick r:id="rId8" invalidUrl="" action="" tgtFrame="" tooltip="" history="1" highlightClick="0" endSnd="0">
                   <a:extLst>
                     <a:ext uri="{A12FA001-AC4F-418D-AE19-62706E023703}">
@@ -4559,7 +4559,7 @@
                   </a:extLst>
                 </a:hlinkClick>
               </a:rPr>
-              <a:t>🔗 User guide</a:t>
+              <a:t>User guide</a:t>
             </a:r>
             <a:endParaRPr lang="en-US" sz="1100" dirty="0"/>
           </a:p>
@@ -4575,8 +4575,8 @@
         </p:nvSpPr>
         <p:spPr>
           <a:xfrm>
-            <a:off x="2695651" y="4206240"/>
-            <a:ext cx="1623974" cy="347472"/>
+            <a:off x="3174797" y="4069080"/>
+            <a:ext cx="1978762" cy="384048"/>
           </a:xfrm>
           <a:prstGeom prst="roundRect">
             <a:avLst>
@@ -4584,11 +4584,11 @@
             </a:avLst>
           </a:prstGeom>
           <a:solidFill>
-            <a:srgbClr val="23155C"/>
+            <a:srgbClr val="F6F3FF"/>
           </a:solidFill>
           <a:ln w="12700">
             <a:solidFill>
-              <a:srgbClr val="23155C"/>
+              <a:srgbClr val="D9D0F5"/>
             </a:solidFill>
             <a:prstDash val="solid"/>
           </a:ln>
@@ -4604,8 +4604,8 @@
         </p:nvSpPr>
         <p:spPr>
           <a:xfrm>
-            <a:off x="2695651" y="4206240"/>
-            <a:ext cx="1623974" cy="347472"/>
+            <a:off x="3174797" y="4069080"/>
+            <a:ext cx="1978762" cy="384048"/>
           </a:xfrm>
           <a:prstGeom prst="rect">
             <a:avLst/>
@@ -4623,11 +4623,11 @@
             <a:r>
               <a:rPr lang="en-US" sz="1100" b="1" u="sng" dirty="0">
                 <a:solidFill>
-                  <a:srgbClr val="FFFFFF"/>
-                </a:solidFill>
-                <a:latin typeface="Calibri" pitchFamily="34" charset="0"/>
-                <a:ea typeface="Calibri" pitchFamily="34" charset="-122"/>
-                <a:cs typeface="Calibri" pitchFamily="34" charset="-120"/>
+                  <a:srgbClr val="23155C"/>
+                </a:solidFill>
+                <a:latin typeface="Arial" pitchFamily="34" charset="0"/>
+                <a:ea typeface="Arial" pitchFamily="34" charset="-122"/>
+                <a:cs typeface="Arial" pitchFamily="34" charset="-120"/>
                 <a:hlinkClick r:id="rId10" invalidUrl="" action="" tgtFrame="" tooltip="" history="1" highlightClick="0" endSnd="0">
                   <a:extLst>
                     <a:ext uri="{A12FA001-AC4F-418D-AE19-62706E023703}">
@@ -4636,7 +4636,7 @@
                   </a:extLst>
                 </a:hlinkClick>
               </a:rPr>
-              <a:t>🔗 UI/UX walkthrough</a:t>
+              <a:t>UI/UX walkthrough</a:t>
             </a:r>
             <a:endParaRPr lang="en-US" sz="1100" dirty="0"/>
           </a:p>
@@ -4652,8 +4652,8 @@
         </p:nvSpPr>
         <p:spPr>
           <a:xfrm>
-            <a:off x="4456786" y="4206240"/>
-            <a:ext cx="839419" cy="347472"/>
+            <a:off x="5290718" y="4069080"/>
+            <a:ext cx="1053389" cy="384048"/>
           </a:xfrm>
           <a:prstGeom prst="roundRect">
             <a:avLst>
@@ -4661,11 +4661,11 @@
             </a:avLst>
           </a:prstGeom>
           <a:solidFill>
-            <a:srgbClr val="23155C"/>
+            <a:srgbClr val="F6F3FF"/>
           </a:solidFill>
           <a:ln w="12700">
             <a:solidFill>
-              <a:srgbClr val="23155C"/>
+              <a:srgbClr val="D9D0F5"/>
             </a:solidFill>
             <a:prstDash val="solid"/>
           </a:ln>
@@ -4681,8 +4681,8 @@
         </p:nvSpPr>
         <p:spPr>
           <a:xfrm>
-            <a:off x="4456786" y="4206240"/>
-            <a:ext cx="839419" cy="347472"/>
+            <a:off x="5290718" y="4069080"/>
+            <a:ext cx="1053389" cy="384048"/>
           </a:xfrm>
           <a:prstGeom prst="rect">
             <a:avLst/>
@@ -4700,11 +4700,11 @@
             <a:r>
               <a:rPr lang="en-US" sz="1100" b="1" u="sng" dirty="0">
                 <a:solidFill>
-                  <a:srgbClr val="FFFFFF"/>
-                </a:solidFill>
-                <a:latin typeface="Calibri" pitchFamily="34" charset="0"/>
-                <a:ea typeface="Calibri" pitchFamily="34" charset="-122"/>
-                <a:cs typeface="Calibri" pitchFamily="34" charset="-120"/>
+                  <a:srgbClr val="23155C"/>
+                </a:solidFill>
+                <a:latin typeface="Arial" pitchFamily="34" charset="0"/>
+                <a:ea typeface="Arial" pitchFamily="34" charset="-122"/>
+                <a:cs typeface="Arial" pitchFamily="34" charset="-120"/>
                 <a:hlinkClick r:id="rId12" invalidUrl="" action="" tgtFrame="" tooltip="" history="1" highlightClick="0" endSnd="0">
                   <a:extLst>
                     <a:ext uri="{A12FA001-AC4F-418D-AE19-62706E023703}">
@@ -4713,7 +4713,7 @@
                   </a:extLst>
                 </a:hlinkClick>
               </a:rPr>
-              <a:t>🔗 README</a:t>
+              <a:t>README</a:t>
             </a:r>
             <a:endParaRPr lang="en-US" sz="1100" dirty="0"/>
           </a:p>
@@ -4727,7 +4727,7 @@
         </p:nvSpPr>
         <p:spPr>
           <a:xfrm>
-            <a:off x="457200" y="4773168"/>
+            <a:off x="457200" y="4846320"/>
             <a:ext cx="8229600" cy="274320"/>
           </a:xfrm>
           <a:prstGeom prst="rect">
@@ -4748,9 +4748,9 @@
                 <a:solidFill>
                   <a:srgbClr val="8B84AD"/>
                 </a:solidFill>
-                <a:latin typeface="Calibri" pitchFamily="34" charset="0"/>
-                <a:ea typeface="Calibri" pitchFamily="34" charset="-122"/>
-                <a:cs typeface="Calibri" pitchFamily="34" charset="-120"/>
+                <a:latin typeface="Arial" pitchFamily="34" charset="0"/>
+                <a:ea typeface="Arial" pitchFamily="34" charset="-122"/>
+                <a:cs typeface="Arial" pitchFamily="34" charset="-120"/>
               </a:rPr>
               <a:t>@learnwithgenn · praneet-admin.github.io/gengo</a:t>
             </a:r>
@@ -4815,17 +4815,17 @@
               <a:buNone/>
             </a:pPr>
             <a:r>
-              <a:rPr lang="en-US" sz="3400" b="1" dirty="0">
+              <a:rPr lang="en-US" sz="3000" b="1" dirty="0">
                 <a:solidFill>
                   <a:srgbClr val="23155C"/>
                 </a:solidFill>
-                <a:latin typeface="Calibri" pitchFamily="34" charset="0"/>
-                <a:ea typeface="Calibri" pitchFamily="34" charset="-122"/>
-                <a:cs typeface="Calibri" pitchFamily="34" charset="-120"/>
+                <a:latin typeface="Arial" pitchFamily="34" charset="0"/>
+                <a:ea typeface="Arial" pitchFamily="34" charset="-122"/>
+                <a:cs typeface="Arial" pitchFamily="34" charset="-120"/>
               </a:rPr>
               <a:t>Three launch jobs</a:t>
             </a:r>
-            <a:endParaRPr lang="en-US" sz="3400" dirty="0"/>
+            <a:endParaRPr lang="en-US" sz="3000" dirty="0"/>
           </a:p>
         </p:txBody>
       </p:sp>
@@ -4910,9 +4910,9 @@
                 <a:solidFill>
                   <a:srgbClr val="23155C"/>
                 </a:solidFill>
-                <a:latin typeface="Calibri" pitchFamily="34" charset="0"/>
-                <a:ea typeface="Calibri" pitchFamily="34" charset="-122"/>
-                <a:cs typeface="Calibri" pitchFamily="34" charset="-120"/>
+                <a:latin typeface="Arial" pitchFamily="34" charset="0"/>
+                <a:ea typeface="Arial" pitchFamily="34" charset="-122"/>
+                <a:cs typeface="Arial" pitchFamily="34" charset="-120"/>
               </a:rPr>
               <a:t>1</a:t>
             </a:r>
@@ -4949,9 +4949,9 @@
                 <a:solidFill>
                   <a:srgbClr val="23155C"/>
                 </a:solidFill>
-                <a:latin typeface="Calibri" pitchFamily="34" charset="0"/>
-                <a:ea typeface="Calibri" pitchFamily="34" charset="-122"/>
-                <a:cs typeface="Calibri" pitchFamily="34" charset="-120"/>
+                <a:latin typeface="Arial" pitchFamily="34" charset="0"/>
+                <a:ea typeface="Arial" pitchFamily="34" charset="-122"/>
+                <a:cs typeface="Arial" pitchFamily="34" charset="-120"/>
               </a:rPr>
               <a:t>Marketing</a:t>
             </a:r>
@@ -4988,9 +4988,9 @@
                 <a:solidFill>
                   <a:srgbClr val="5330D6"/>
                 </a:solidFill>
-                <a:latin typeface="Calibri" pitchFamily="34" charset="0"/>
-                <a:ea typeface="Calibri" pitchFamily="34" charset="-122"/>
-                <a:cs typeface="Calibri" pitchFamily="34" charset="-120"/>
+                <a:latin typeface="Arial" pitchFamily="34" charset="0"/>
+                <a:ea typeface="Arial" pitchFamily="34" charset="-122"/>
+                <a:cs typeface="Arial" pitchFamily="34" charset="-120"/>
               </a:rPr>
               <a:t>Get heard</a:t>
             </a:r>
@@ -5079,9 +5079,9 @@
                 <a:solidFill>
                   <a:srgbClr val="23155C"/>
                 </a:solidFill>
-                <a:latin typeface="Calibri" pitchFamily="34" charset="0"/>
-                <a:ea typeface="Calibri" pitchFamily="34" charset="-122"/>
-                <a:cs typeface="Calibri" pitchFamily="34" charset="-120"/>
+                <a:latin typeface="Arial" pitchFamily="34" charset="0"/>
+                <a:ea typeface="Arial" pitchFamily="34" charset="-122"/>
+                <a:cs typeface="Arial" pitchFamily="34" charset="-120"/>
               </a:rPr>
               <a:t>2</a:t>
             </a:r>
@@ -5118,9 +5118,9 @@
                 <a:solidFill>
                   <a:srgbClr val="23155C"/>
                 </a:solidFill>
-                <a:latin typeface="Calibri" pitchFamily="34" charset="0"/>
-                <a:ea typeface="Calibri" pitchFamily="34" charset="-122"/>
-                <a:cs typeface="Calibri" pitchFamily="34" charset="-120"/>
+                <a:latin typeface="Arial" pitchFamily="34" charset="0"/>
+                <a:ea typeface="Arial" pitchFamily="34" charset="-122"/>
+                <a:cs typeface="Arial" pitchFamily="34" charset="-120"/>
               </a:rPr>
               <a:t>Support</a:t>
             </a:r>
@@ -5157,9 +5157,9 @@
                 <a:solidFill>
                   <a:srgbClr val="5330D6"/>
                 </a:solidFill>
-                <a:latin typeface="Calibri" pitchFamily="34" charset="0"/>
-                <a:ea typeface="Calibri" pitchFamily="34" charset="-122"/>
-                <a:cs typeface="Calibri" pitchFamily="34" charset="-120"/>
+                <a:latin typeface="Arial" pitchFamily="34" charset="0"/>
+                <a:ea typeface="Arial" pitchFamily="34" charset="-122"/>
+                <a:cs typeface="Arial" pitchFamily="34" charset="-120"/>
               </a:rPr>
               <a:t>Help fast</a:t>
             </a:r>
@@ -5248,9 +5248,9 @@
                 <a:solidFill>
                   <a:srgbClr val="23155C"/>
                 </a:solidFill>
-                <a:latin typeface="Calibri" pitchFamily="34" charset="0"/>
-                <a:ea typeface="Calibri" pitchFamily="34" charset="-122"/>
-                <a:cs typeface="Calibri" pitchFamily="34" charset="-120"/>
+                <a:latin typeface="Arial" pitchFamily="34" charset="0"/>
+                <a:ea typeface="Arial" pitchFamily="34" charset="-122"/>
+                <a:cs typeface="Arial" pitchFamily="34" charset="-120"/>
               </a:rPr>
               <a:t>3</a:t>
             </a:r>
@@ -5287,9 +5287,9 @@
                 <a:solidFill>
                   <a:srgbClr val="23155C"/>
                 </a:solidFill>
-                <a:latin typeface="Calibri" pitchFamily="34" charset="0"/>
-                <a:ea typeface="Calibri" pitchFamily="34" charset="-122"/>
-                <a:cs typeface="Calibri" pitchFamily="34" charset="-120"/>
+                <a:latin typeface="Arial" pitchFamily="34" charset="0"/>
+                <a:ea typeface="Arial" pitchFamily="34" charset="-122"/>
+                <a:cs typeface="Arial" pitchFamily="34" charset="-120"/>
               </a:rPr>
               <a:t>Pricing</a:t>
             </a:r>
@@ -5326,9 +5326,9 @@
                 <a:solidFill>
                   <a:srgbClr val="5330D6"/>
                 </a:solidFill>
-                <a:latin typeface="Calibri" pitchFamily="34" charset="0"/>
-                <a:ea typeface="Calibri" pitchFamily="34" charset="-122"/>
-                <a:cs typeface="Calibri" pitchFamily="34" charset="-120"/>
+                <a:latin typeface="Arial" pitchFamily="34" charset="0"/>
+                <a:ea typeface="Arial" pitchFamily="34" charset="-122"/>
+                <a:cs typeface="Arial" pitchFamily="34" charset="-120"/>
               </a:rPr>
               <a:t>₹0, forever</a:t>
             </a:r>
@@ -5346,8 +5346,8 @@
         </p:nvSpPr>
         <p:spPr>
           <a:xfrm>
-            <a:off x="457200" y="4206240"/>
-            <a:ext cx="1196035" cy="347472"/>
+            <a:off x="457200" y="4069080"/>
+            <a:ext cx="1474013" cy="384048"/>
           </a:xfrm>
           <a:prstGeom prst="roundRect">
             <a:avLst>
@@ -5355,11 +5355,11 @@
             </a:avLst>
           </a:prstGeom>
           <a:solidFill>
-            <a:srgbClr val="23155C"/>
+            <a:srgbClr val="F6F3FF"/>
           </a:solidFill>
           <a:ln w="12700">
             <a:solidFill>
-              <a:srgbClr val="23155C"/>
+              <a:srgbClr val="D9D0F5"/>
             </a:solidFill>
             <a:prstDash val="solid"/>
           </a:ln>
@@ -5375,8 +5375,8 @@
         </p:nvSpPr>
         <p:spPr>
           <a:xfrm>
-            <a:off x="457200" y="4206240"/>
-            <a:ext cx="1196035" cy="347472"/>
+            <a:off x="457200" y="4069080"/>
+            <a:ext cx="1474013" cy="384048"/>
           </a:xfrm>
           <a:prstGeom prst="rect">
             <a:avLst/>
@@ -5394,11 +5394,11 @@
             <a:r>
               <a:rPr lang="en-US" sz="1100" b="1" u="sng" dirty="0">
                 <a:solidFill>
-                  <a:srgbClr val="FFFFFF"/>
-                </a:solidFill>
-                <a:latin typeface="Calibri" pitchFamily="34" charset="0"/>
-                <a:ea typeface="Calibri" pitchFamily="34" charset="-122"/>
-                <a:cs typeface="Calibri" pitchFamily="34" charset="-120"/>
+                  <a:srgbClr val="23155C"/>
+                </a:solidFill>
+                <a:latin typeface="Arial" pitchFamily="34" charset="0"/>
+                <a:ea typeface="Arial" pitchFamily="34" charset="-122"/>
+                <a:cs typeface="Arial" pitchFamily="34" charset="-120"/>
                 <a:hlinkClick r:id="rId2" invalidUrl="" action="" tgtFrame="" tooltip="" history="1" highlightClick="0" endSnd="0">
                   <a:extLst>
                     <a:ext uri="{A12FA001-AC4F-418D-AE19-62706E023703}">
@@ -5407,7 +5407,7 @@
                   </a:extLst>
                 </a:hlinkClick>
               </a:rPr>
-              <a:t>🔗 Launch note</a:t>
+              <a:t>Launch note</a:t>
             </a:r>
             <a:endParaRPr lang="en-US" sz="1100" dirty="0"/>
           </a:p>
@@ -5423,8 +5423,8 @@
         </p:nvSpPr>
         <p:spPr>
           <a:xfrm>
-            <a:off x="1790395" y="4206240"/>
-            <a:ext cx="982066" cy="347472"/>
+            <a:off x="2068373" y="4069080"/>
+            <a:ext cx="1221638" cy="384048"/>
           </a:xfrm>
           <a:prstGeom prst="roundRect">
             <a:avLst>
@@ -5432,11 +5432,11 @@
             </a:avLst>
           </a:prstGeom>
           <a:solidFill>
-            <a:srgbClr val="23155C"/>
+            <a:srgbClr val="F6F3FF"/>
           </a:solidFill>
           <a:ln w="12700">
             <a:solidFill>
-              <a:srgbClr val="23155C"/>
+              <a:srgbClr val="D9D0F5"/>
             </a:solidFill>
             <a:prstDash val="solid"/>
           </a:ln>
@@ -5452,8 +5452,8 @@
         </p:nvSpPr>
         <p:spPr>
           <a:xfrm>
-            <a:off x="1790395" y="4206240"/>
-            <a:ext cx="982066" cy="347472"/>
+            <a:off x="2068373" y="4069080"/>
+            <a:ext cx="1221638" cy="384048"/>
           </a:xfrm>
           <a:prstGeom prst="rect">
             <a:avLst/>
@@ -5471,11 +5471,11 @@
             <a:r>
               <a:rPr lang="en-US" sz="1100" b="1" u="sng" dirty="0">
                 <a:solidFill>
-                  <a:srgbClr val="FFFFFF"/>
-                </a:solidFill>
-                <a:latin typeface="Calibri" pitchFamily="34" charset="0"/>
-                <a:ea typeface="Calibri" pitchFamily="34" charset="-122"/>
-                <a:cs typeface="Calibri" pitchFamily="34" charset="-120"/>
+                  <a:srgbClr val="23155C"/>
+                </a:solidFill>
+                <a:latin typeface="Arial" pitchFamily="34" charset="0"/>
+                <a:ea typeface="Arial" pitchFamily="34" charset="-122"/>
+                <a:cs typeface="Arial" pitchFamily="34" charset="-120"/>
                 <a:hlinkClick r:id="rId4" invalidUrl="" action="" tgtFrame="" tooltip="" history="1" highlightClick="0" endSnd="0">
                   <a:extLst>
                     <a:ext uri="{A12FA001-AC4F-418D-AE19-62706E023703}">
@@ -5484,7 +5484,7 @@
                   </a:extLst>
                 </a:hlinkClick>
               </a:rPr>
-              <a:t>🔗 Post kit</a:t>
+              <a:t>Post kit</a:t>
             </a:r>
             <a:endParaRPr lang="en-US" sz="1100" dirty="0"/>
           </a:p>
@@ -5500,8 +5500,8 @@
         </p:nvSpPr>
         <p:spPr>
           <a:xfrm>
-            <a:off x="2909621" y="4206240"/>
-            <a:ext cx="1410005" cy="347472"/>
+            <a:off x="3427171" y="4069080"/>
+            <a:ext cx="1726387" cy="384048"/>
           </a:xfrm>
           <a:prstGeom prst="roundRect">
             <a:avLst>
@@ -5509,11 +5509,11 @@
             </a:avLst>
           </a:prstGeom>
           <a:solidFill>
-            <a:srgbClr val="23155C"/>
+            <a:srgbClr val="F6F3FF"/>
           </a:solidFill>
           <a:ln w="12700">
             <a:solidFill>
-              <a:srgbClr val="23155C"/>
+              <a:srgbClr val="D9D0F5"/>
             </a:solidFill>
             <a:prstDash val="solid"/>
           </a:ln>
@@ -5529,8 +5529,8 @@
         </p:nvSpPr>
         <p:spPr>
           <a:xfrm>
-            <a:off x="2909621" y="4206240"/>
-            <a:ext cx="1410005" cy="347472"/>
+            <a:off x="3427171" y="4069080"/>
+            <a:ext cx="1726387" cy="384048"/>
           </a:xfrm>
           <a:prstGeom prst="rect">
             <a:avLst/>
@@ -5548,11 +5548,11 @@
             <a:r>
               <a:rPr lang="en-US" sz="1100" b="1" u="sng" dirty="0">
                 <a:solidFill>
-                  <a:srgbClr val="FFFFFF"/>
-                </a:solidFill>
-                <a:latin typeface="Calibri" pitchFamily="34" charset="0"/>
-                <a:ea typeface="Calibri" pitchFamily="34" charset="-122"/>
-                <a:cs typeface="Calibri" pitchFamily="34" charset="-120"/>
+                  <a:srgbClr val="23155C"/>
+                </a:solidFill>
+                <a:latin typeface="Arial" pitchFamily="34" charset="0"/>
+                <a:ea typeface="Arial" pitchFamily="34" charset="-122"/>
+                <a:cs typeface="Arial" pitchFamily="34" charset="-120"/>
                 <a:hlinkClick r:id="rId6" invalidUrl="" action="" tgtFrame="" tooltip="" history="1" highlightClick="0" endSnd="0">
                   <a:extLst>
                     <a:ext uri="{A12FA001-AC4F-418D-AE19-62706E023703}">
@@ -5561,7 +5561,7 @@
                   </a:extLst>
                 </a:hlinkClick>
               </a:rPr>
-              <a:t>🔗 Support policy</a:t>
+              <a:t>Support policy</a:t>
             </a:r>
             <a:endParaRPr lang="en-US" sz="1100" dirty="0"/>
           </a:p>
@@ -5577,8 +5577,8 @@
         </p:nvSpPr>
         <p:spPr>
           <a:xfrm>
-            <a:off x="4456786" y="4206240"/>
-            <a:ext cx="1196035" cy="347472"/>
+            <a:off x="5290718" y="4069080"/>
+            <a:ext cx="1474013" cy="384048"/>
           </a:xfrm>
           <a:prstGeom prst="roundRect">
             <a:avLst>
@@ -5586,11 +5586,11 @@
             </a:avLst>
           </a:prstGeom>
           <a:solidFill>
-            <a:srgbClr val="23155C"/>
+            <a:srgbClr val="F6F3FF"/>
           </a:solidFill>
           <a:ln w="12700">
             <a:solidFill>
-              <a:srgbClr val="23155C"/>
+              <a:srgbClr val="D9D0F5"/>
             </a:solidFill>
             <a:prstDash val="solid"/>
           </a:ln>
@@ -5606,8 +5606,8 @@
         </p:nvSpPr>
         <p:spPr>
           <a:xfrm>
-            <a:off x="4456786" y="4206240"/>
-            <a:ext cx="1196035" cy="347472"/>
+            <a:off x="5290718" y="4069080"/>
+            <a:ext cx="1474013" cy="384048"/>
           </a:xfrm>
           <a:prstGeom prst="rect">
             <a:avLst/>
@@ -5625,11 +5625,11 @@
             <a:r>
               <a:rPr lang="en-US" sz="1100" b="1" u="sng" dirty="0">
                 <a:solidFill>
-                  <a:srgbClr val="FFFFFF"/>
-                </a:solidFill>
-                <a:latin typeface="Calibri" pitchFamily="34" charset="0"/>
-                <a:ea typeface="Calibri" pitchFamily="34" charset="-122"/>
-                <a:cs typeface="Calibri" pitchFamily="34" charset="-120"/>
+                  <a:srgbClr val="23155C"/>
+                </a:solidFill>
+                <a:latin typeface="Arial" pitchFamily="34" charset="0"/>
+                <a:ea typeface="Arial" pitchFamily="34" charset="-122"/>
+                <a:cs typeface="Arial" pitchFamily="34" charset="-120"/>
                 <a:hlinkClick r:id="rId8" invalidUrl="" action="" tgtFrame="" tooltip="" history="1" highlightClick="0" endSnd="0">
                   <a:extLst>
                     <a:ext uri="{A12FA001-AC4F-418D-AE19-62706E023703}">
@@ -5638,7 +5638,7 @@
                   </a:extLst>
                 </a:hlinkClick>
               </a:rPr>
-              <a:t>🔗 Issue forms</a:t>
+              <a:t>Issue forms</a:t>
             </a:r>
             <a:endParaRPr lang="en-US" sz="1100" dirty="0"/>
           </a:p>
@@ -5652,7 +5652,7 @@
         </p:nvSpPr>
         <p:spPr>
           <a:xfrm>
-            <a:off x="457200" y="4773168"/>
+            <a:off x="457200" y="4846320"/>
             <a:ext cx="8229600" cy="274320"/>
           </a:xfrm>
           <a:prstGeom prst="rect">
@@ -5673,9 +5673,9 @@
                 <a:solidFill>
                   <a:srgbClr val="8B84AD"/>
                 </a:solidFill>
-                <a:latin typeface="Calibri" pitchFamily="34" charset="0"/>
-                <a:ea typeface="Calibri" pitchFamily="34" charset="-122"/>
-                <a:cs typeface="Calibri" pitchFamily="34" charset="-120"/>
+                <a:latin typeface="Arial" pitchFamily="34" charset="0"/>
+                <a:ea typeface="Arial" pitchFamily="34" charset="-122"/>
+                <a:cs typeface="Arial" pitchFamily="34" charset="-120"/>
               </a:rPr>
               <a:t>@learnwithgenn · praneet-admin.github.io/gengo</a:t>
             </a:r>
@@ -5740,17 +5740,17 @@
               <a:buNone/>
             </a:pPr>
             <a:r>
-              <a:rPr lang="en-US" sz="3400" b="1" dirty="0">
+              <a:rPr lang="en-US" sz="3000" b="1" dirty="0">
                 <a:solidFill>
                   <a:srgbClr val="23155C"/>
                 </a:solidFill>
-                <a:latin typeface="Calibri" pitchFamily="34" charset="0"/>
-                <a:ea typeface="Calibri" pitchFamily="34" charset="-122"/>
-                <a:cs typeface="Calibri" pitchFamily="34" charset="-120"/>
+                <a:latin typeface="Arial" pitchFamily="34" charset="0"/>
+                <a:ea typeface="Arial" pitchFamily="34" charset="-122"/>
+                <a:cs typeface="Arial" pitchFamily="34" charset="-120"/>
               </a:rPr>
               <a:t>Every share unfurls into this</a:t>
             </a:r>
-            <a:endParaRPr lang="en-US" sz="3400" dirty="0"/>
+            <a:endParaRPr lang="en-US" sz="3000" dirty="0"/>
           </a:p>
         </p:txBody>
       </p:sp>
@@ -5833,9 +5833,9 @@
                 <a:solidFill>
                   <a:srgbClr val="FFFFFF"/>
                 </a:solidFill>
-                <a:latin typeface="Calibri" pitchFamily="34" charset="0"/>
-                <a:ea typeface="Calibri" pitchFamily="34" charset="-122"/>
-                <a:cs typeface="Calibri" pitchFamily="34" charset="-120"/>
+                <a:latin typeface="Arial" pitchFamily="34" charset="0"/>
+                <a:ea typeface="Arial" pitchFamily="34" charset="-122"/>
+                <a:cs typeface="Arial" pitchFamily="34" charset="-120"/>
               </a:rPr>
               <a:t>“I’m on a 5-day streak learning English words with Gengo 🐰”</a:t>
             </a:r>
@@ -5872,9 +5872,9 @@
                 <a:solidFill>
                   <a:srgbClr val="FFD233"/>
                 </a:solidFill>
-                <a:latin typeface="Calibri" pitchFamily="34" charset="0"/>
-                <a:ea typeface="Calibri" pitchFamily="34" charset="-122"/>
-                <a:cs typeface="Calibri" pitchFamily="34" charset="-120"/>
+                <a:latin typeface="Arial" pitchFamily="34" charset="0"/>
+                <a:ea typeface="Arial" pitchFamily="34" charset="-122"/>
+                <a:cs typeface="Arial" pitchFamily="34" charset="-120"/>
               </a:rPr>
               <a:t>One-tap Share. The learner is the ad.</a:t>
             </a:r>
@@ -5892,8 +5892,8 @@
         </p:nvSpPr>
         <p:spPr>
           <a:xfrm>
-            <a:off x="457200" y="4206240"/>
-            <a:ext cx="2051914" cy="347472"/>
+            <a:off x="457200" y="4069080"/>
+            <a:ext cx="2483510" cy="384048"/>
           </a:xfrm>
           <a:prstGeom prst="roundRect">
             <a:avLst>
@@ -5901,11 +5901,11 @@
             </a:avLst>
           </a:prstGeom>
           <a:solidFill>
-            <a:srgbClr val="23155C"/>
+            <a:srgbClr val="F6F3FF"/>
           </a:solidFill>
           <a:ln w="12700">
             <a:solidFill>
-              <a:srgbClr val="23155C"/>
+              <a:srgbClr val="D9D0F5"/>
             </a:solidFill>
             <a:prstDash val="solid"/>
           </a:ln>
@@ -5921,8 +5921,8 @@
         </p:nvSpPr>
         <p:spPr>
           <a:xfrm>
-            <a:off x="457200" y="4206240"/>
-            <a:ext cx="2051914" cy="347472"/>
+            <a:off x="457200" y="4069080"/>
+            <a:ext cx="2483510" cy="384048"/>
           </a:xfrm>
           <a:prstGeom prst="rect">
             <a:avLst/>
@@ -5940,11 +5940,11 @@
             <a:r>
               <a:rPr lang="en-US" sz="1100" b="1" u="sng" dirty="0">
                 <a:solidFill>
-                  <a:srgbClr val="FFFFFF"/>
-                </a:solidFill>
-                <a:latin typeface="Calibri" pitchFamily="34" charset="0"/>
-                <a:ea typeface="Calibri" pitchFamily="34" charset="-122"/>
-                <a:cs typeface="Calibri" pitchFamily="34" charset="-120"/>
+                  <a:srgbClr val="23155C"/>
+                </a:solidFill>
+                <a:latin typeface="Arial" pitchFamily="34" charset="0"/>
+                <a:ea typeface="Arial" pitchFamily="34" charset="-122"/>
+                <a:cs typeface="Arial" pitchFamily="34" charset="-120"/>
                 <a:hlinkClick r:id="rId3" invalidUrl="" action="" tgtFrame="" tooltip="" history="1" highlightClick="0" endSnd="0">
                   <a:extLst>
                     <a:ext uri="{A12FA001-AC4F-418D-AE19-62706E023703}">
@@ -5953,7 +5953,7 @@
                   </a:extLst>
                 </a:hlinkClick>
               </a:rPr>
-              <a:t>🔗 Preview card (og-image)</a:t>
+              <a:t>Preview card (og-image)</a:t>
             </a:r>
             <a:endParaRPr lang="en-US" sz="1100" dirty="0"/>
           </a:p>
@@ -5969,8 +5969,8 @@
         </p:nvSpPr>
         <p:spPr>
           <a:xfrm>
-            <a:off x="2646274" y="4206240"/>
-            <a:ext cx="3050438" cy="347472"/>
+            <a:off x="3077870" y="4069080"/>
+            <a:ext cx="3840480" cy="384048"/>
           </a:xfrm>
           <a:prstGeom prst="roundRect">
             <a:avLst>
@@ -5978,11 +5978,11 @@
             </a:avLst>
           </a:prstGeom>
           <a:solidFill>
-            <a:srgbClr val="23155C"/>
+            <a:srgbClr val="F6F3FF"/>
           </a:solidFill>
           <a:ln w="12700">
             <a:solidFill>
-              <a:srgbClr val="23155C"/>
+              <a:srgbClr val="D9D0F5"/>
             </a:solidFill>
             <a:prstDash val="solid"/>
           </a:ln>
@@ -5998,8 +5998,8 @@
         </p:nvSpPr>
         <p:spPr>
           <a:xfrm>
-            <a:off x="2646274" y="4206240"/>
-            <a:ext cx="3050438" cy="347472"/>
+            <a:off x="3077870" y="4069080"/>
+            <a:ext cx="3840480" cy="384048"/>
           </a:xfrm>
           <a:prstGeom prst="rect">
             <a:avLst/>
@@ -6017,11 +6017,11 @@
             <a:r>
               <a:rPr lang="en-US" sz="1100" b="1" u="sng" dirty="0">
                 <a:solidFill>
-                  <a:srgbClr val="FFFFFF"/>
-                </a:solidFill>
-                <a:latin typeface="Calibri" pitchFamily="34" charset="0"/>
-                <a:ea typeface="Calibri" pitchFamily="34" charset="-122"/>
-                <a:cs typeface="Calibri" pitchFamily="34" charset="-120"/>
+                  <a:srgbClr val="23155C"/>
+                </a:solidFill>
+                <a:latin typeface="Arial" pitchFamily="34" charset="0"/>
+                <a:ea typeface="Arial" pitchFamily="34" charset="-122"/>
+                <a:cs typeface="Arial" pitchFamily="34" charset="-120"/>
                 <a:hlinkClick r:id="rId5" invalidUrl="" action="" tgtFrame="" tooltip="" history="1" highlightClick="0" endSnd="0">
                   <a:extLst>
                     <a:ext uri="{A12FA001-AC4F-418D-AE19-62706E023703}">
@@ -6030,7 +6030,7 @@
                   </a:extLst>
                 </a:hlinkClick>
               </a:rPr>
-              <a:t>🔗 WhatsApp / LinkedIn / Reddit / X copy</a:t>
+              <a:t>Post copy (WhatsApp, LinkedIn, Reddit, X)</a:t>
             </a:r>
             <a:endParaRPr lang="en-US" sz="1100" dirty="0"/>
           </a:p>
@@ -6046,8 +6046,8 @@
         </p:nvSpPr>
         <p:spPr>
           <a:xfrm>
-            <a:off x="5833872" y="4206240"/>
-            <a:ext cx="1481328" cy="347472"/>
+            <a:off x="457200" y="4562856"/>
+            <a:ext cx="1810512" cy="384048"/>
           </a:xfrm>
           <a:prstGeom prst="roundRect">
             <a:avLst>
@@ -6055,11 +6055,11 @@
             </a:avLst>
           </a:prstGeom>
           <a:solidFill>
-            <a:srgbClr val="23155C"/>
+            <a:srgbClr val="F6F3FF"/>
           </a:solidFill>
           <a:ln w="12700">
             <a:solidFill>
-              <a:srgbClr val="23155C"/>
+              <a:srgbClr val="D9D0F5"/>
             </a:solidFill>
             <a:prstDash val="solid"/>
           </a:ln>
@@ -6075,8 +6075,8 @@
         </p:nvSpPr>
         <p:spPr>
           <a:xfrm>
-            <a:off x="5833872" y="4206240"/>
-            <a:ext cx="1481328" cy="347472"/>
+            <a:off x="457200" y="4562856"/>
+            <a:ext cx="1810512" cy="384048"/>
           </a:xfrm>
           <a:prstGeom prst="rect">
             <a:avLst/>
@@ -6094,11 +6094,11 @@
             <a:r>
               <a:rPr lang="en-US" sz="1100" b="1" u="sng" dirty="0">
                 <a:solidFill>
-                  <a:srgbClr val="FFFFFF"/>
-                </a:solidFill>
-                <a:latin typeface="Calibri" pitchFamily="34" charset="0"/>
-                <a:ea typeface="Calibri" pitchFamily="34" charset="-122"/>
-                <a:cs typeface="Calibri" pitchFamily="34" charset="-120"/>
+                  <a:srgbClr val="23155C"/>
+                </a:solidFill>
+                <a:latin typeface="Arial" pitchFamily="34" charset="0"/>
+                <a:ea typeface="Arial" pitchFamily="34" charset="-122"/>
+                <a:cs typeface="Arial" pitchFamily="34" charset="-120"/>
                 <a:hlinkClick r:id="rId7" invalidUrl="" action="" tgtFrame="" tooltip="" history="1" highlightClick="0" endSnd="0">
                   <a:extLst>
                     <a:ext uri="{A12FA001-AC4F-418D-AE19-62706E023703}">
@@ -6107,7 +6107,7 @@
                   </a:extLst>
                 </a:hlinkClick>
               </a:rPr>
-              <a:t>🔗 Installable app</a:t>
+              <a:t>Installable app</a:t>
             </a:r>
             <a:endParaRPr lang="en-US" sz="1100" dirty="0"/>
           </a:p>
@@ -6121,7 +6121,7 @@
         </p:nvSpPr>
         <p:spPr>
           <a:xfrm>
-            <a:off x="457200" y="4773168"/>
+            <a:off x="457200" y="4846320"/>
             <a:ext cx="8229600" cy="274320"/>
           </a:xfrm>
           <a:prstGeom prst="rect">
@@ -6142,9 +6142,9 @@
                 <a:solidFill>
                   <a:srgbClr val="8B84AD"/>
                 </a:solidFill>
-                <a:latin typeface="Calibri" pitchFamily="34" charset="0"/>
-                <a:ea typeface="Calibri" pitchFamily="34" charset="-122"/>
-                <a:cs typeface="Calibri" pitchFamily="34" charset="-120"/>
+                <a:latin typeface="Arial" pitchFamily="34" charset="0"/>
+                <a:ea typeface="Arial" pitchFamily="34" charset="-122"/>
+                <a:cs typeface="Arial" pitchFamily="34" charset="-120"/>
               </a:rPr>
               <a:t>@learnwithgenn · praneet-admin.github.io/gengo</a:t>
             </a:r>
@@ -6209,17 +6209,17 @@
               <a:buNone/>
             </a:pPr>
             <a:r>
-              <a:rPr lang="en-US" sz="3400" b="1" dirty="0">
+              <a:rPr lang="en-US" sz="3000" b="1" dirty="0">
                 <a:solidFill>
                   <a:srgbClr val="FFFFFF"/>
                 </a:solidFill>
-                <a:latin typeface="Calibri" pitchFamily="34" charset="0"/>
-                <a:ea typeface="Calibri" pitchFamily="34" charset="-122"/>
-                <a:cs typeface="Calibri" pitchFamily="34" charset="-120"/>
+                <a:latin typeface="Arial" pitchFamily="34" charset="0"/>
+                <a:ea typeface="Arial" pitchFamily="34" charset="-122"/>
+                <a:cs typeface="Arial" pitchFamily="34" charset="-120"/>
               </a:rPr>
               <a:t>Promo video · 57 s · real footage</a:t>
             </a:r>
-            <a:endParaRPr lang="en-US" sz="3400" dirty="0"/>
+            <a:endParaRPr lang="en-US" sz="3000" dirty="0"/>
           </a:p>
         </p:txBody>
       </p:sp>
@@ -6256,8 +6256,8 @@
         </p:nvSpPr>
         <p:spPr>
           <a:xfrm>
-            <a:off x="457200" y="4206240"/>
-            <a:ext cx="2051914" cy="347472"/>
+            <a:off x="457200" y="4069080"/>
+            <a:ext cx="1810512" cy="384048"/>
           </a:xfrm>
           <a:prstGeom prst="roundRect">
             <a:avLst>
@@ -6265,11 +6265,11 @@
             </a:avLst>
           </a:prstGeom>
           <a:solidFill>
-            <a:srgbClr val="FFD233"/>
+            <a:srgbClr val="FFFFFF"/>
           </a:solidFill>
           <a:ln w="12700">
             <a:solidFill>
-              <a:srgbClr val="FFD233"/>
+              <a:srgbClr val="FFFFFF"/>
             </a:solidFill>
             <a:prstDash val="solid"/>
           </a:ln>
@@ -6285,8 +6285,8 @@
         </p:nvSpPr>
         <p:spPr>
           <a:xfrm>
-            <a:off x="457200" y="4206240"/>
-            <a:ext cx="2051914" cy="347472"/>
+            <a:off x="457200" y="4069080"/>
+            <a:ext cx="1810512" cy="384048"/>
           </a:xfrm>
           <a:prstGeom prst="rect">
             <a:avLst/>
@@ -6306,9 +6306,9 @@
                 <a:solidFill>
                   <a:srgbClr val="23155C"/>
                 </a:solidFill>
-                <a:latin typeface="Calibri" pitchFamily="34" charset="0"/>
-                <a:ea typeface="Calibri" pitchFamily="34" charset="-122"/>
-                <a:cs typeface="Calibri" pitchFamily="34" charset="-120"/>
+                <a:latin typeface="Arial" pitchFamily="34" charset="0"/>
+                <a:ea typeface="Arial" pitchFamily="34" charset="-122"/>
+                <a:cs typeface="Arial" pitchFamily="34" charset="-120"/>
                 <a:hlinkClick r:id="rId3" invalidUrl="" action="" tgtFrame="" tooltip="" history="1" highlightClick="0" endSnd="0">
                   <a:extLst>
                     <a:ext uri="{A12FA001-AC4F-418D-AE19-62706E023703}">
@@ -6317,7 +6317,7 @@
                   </a:extLst>
                 </a:hlinkClick>
               </a:rPr>
-              <a:t>🔗 ▶ Watch gengo-promo.mp4</a:t>
+              <a:t>Watch the video</a:t>
             </a:r>
             <a:endParaRPr lang="en-US" sz="1100" dirty="0"/>
           </a:p>
@@ -6333,8 +6333,8 @@
         </p:nvSpPr>
         <p:spPr>
           <a:xfrm>
-            <a:off x="2646274" y="4206240"/>
-            <a:ext cx="1410005" cy="347472"/>
+            <a:off x="2404872" y="4069080"/>
+            <a:ext cx="1726387" cy="384048"/>
           </a:xfrm>
           <a:prstGeom prst="roundRect">
             <a:avLst>
@@ -6342,11 +6342,11 @@
             </a:avLst>
           </a:prstGeom>
           <a:solidFill>
-            <a:srgbClr val="FFD233"/>
+            <a:srgbClr val="FFFFFF"/>
           </a:solidFill>
           <a:ln w="12700">
             <a:solidFill>
-              <a:srgbClr val="FFD233"/>
+              <a:srgbClr val="FFFFFF"/>
             </a:solidFill>
             <a:prstDash val="solid"/>
           </a:ln>
@@ -6362,8 +6362,8 @@
         </p:nvSpPr>
         <p:spPr>
           <a:xfrm>
-            <a:off x="2646274" y="4206240"/>
-            <a:ext cx="1410005" cy="347472"/>
+            <a:off x="2404872" y="4069080"/>
+            <a:ext cx="1726387" cy="384048"/>
           </a:xfrm>
           <a:prstGeom prst="rect">
             <a:avLst/>
@@ -6383,9 +6383,9 @@
                 <a:solidFill>
                   <a:srgbClr val="23155C"/>
                 </a:solidFill>
-                <a:latin typeface="Calibri" pitchFamily="34" charset="0"/>
-                <a:ea typeface="Calibri" pitchFamily="34" charset="-122"/>
-                <a:cs typeface="Calibri" pitchFamily="34" charset="-120"/>
+                <a:latin typeface="Arial" pitchFamily="34" charset="0"/>
+                <a:ea typeface="Arial" pitchFamily="34" charset="-122"/>
+                <a:cs typeface="Arial" pitchFamily="34" charset="-120"/>
                 <a:hlinkClick r:id="rId5" invalidUrl="" action="" tgtFrame="" tooltip="" history="1" highlightClick="0" endSnd="0">
                   <a:extLst>
                     <a:ext uri="{A12FA001-AC4F-418D-AE19-62706E023703}">
@@ -6394,7 +6394,7 @@
                   </a:extLst>
                 </a:hlinkClick>
               </a:rPr>
-              <a:t>🔗 File on GitHub</a:t>
+              <a:t>File on GitHub</a:t>
             </a:r>
             <a:endParaRPr lang="en-US" sz="1100" dirty="0"/>
           </a:p>
@@ -6408,7 +6408,7 @@
         </p:nvSpPr>
         <p:spPr>
           <a:xfrm>
-            <a:off x="457200" y="4773168"/>
+            <a:off x="457200" y="4846320"/>
             <a:ext cx="8229600" cy="274320"/>
           </a:xfrm>
           <a:prstGeom prst="rect">
@@ -6429,9 +6429,9 @@
                 <a:solidFill>
                   <a:srgbClr val="A99BE0"/>
                 </a:solidFill>
-                <a:latin typeface="Calibri" pitchFamily="34" charset="0"/>
-                <a:ea typeface="Calibri" pitchFamily="34" charset="-122"/>
-                <a:cs typeface="Calibri" pitchFamily="34" charset="-120"/>
+                <a:latin typeface="Arial" pitchFamily="34" charset="0"/>
+                <a:ea typeface="Arial" pitchFamily="34" charset="-122"/>
+                <a:cs typeface="Arial" pitchFamily="34" charset="-120"/>
               </a:rPr>
               <a:t>@learnwithgenn · praneet-admin.github.io/gengo</a:t>
             </a:r>
@@ -6496,17 +6496,17 @@
               <a:buNone/>
             </a:pPr>
             <a:r>
-              <a:rPr lang="en-US" sz="3400" b="1" dirty="0">
+              <a:rPr lang="en-US" sz="3000" b="1" dirty="0">
                 <a:solidFill>
                   <a:srgbClr val="FFFFFF"/>
                 </a:solidFill>
-                <a:latin typeface="Calibri" pitchFamily="34" charset="0"/>
-                <a:ea typeface="Calibri" pitchFamily="34" charset="-122"/>
-                <a:cs typeface="Calibri" pitchFamily="34" charset="-120"/>
+                <a:latin typeface="Arial" pitchFamily="34" charset="0"/>
+                <a:ea typeface="Arial" pitchFamily="34" charset="-122"/>
+                <a:cs typeface="Arial" pitchFamily="34" charset="-120"/>
               </a:rPr>
               <a:t>Instagram · @learnwithgenn</a:t>
             </a:r>
-            <a:endParaRPr lang="en-US" sz="3400" dirty="0"/>
+            <a:endParaRPr lang="en-US" sz="3000" dirty="0"/>
           </a:p>
         </p:txBody>
       </p:sp>
@@ -6539,9 +6539,9 @@
                 <a:solidFill>
                   <a:srgbClr val="D6CCFF"/>
                 </a:solidFill>
-                <a:latin typeface="Calibri" pitchFamily="34" charset="0"/>
-                <a:ea typeface="Calibri" pitchFamily="34" charset="-122"/>
-                <a:cs typeface="Calibri" pitchFamily="34" charset="-120"/>
+                <a:latin typeface="Arial" pitchFamily="34" charset="0"/>
+                <a:ea typeface="Arial" pitchFamily="34" charset="-122"/>
+                <a:cs typeface="Arial" pitchFamily="34" charset="-120"/>
               </a:rPr>
               <a:t>8 posts on day one</a:t>
             </a:r>
@@ -6582,8 +6582,8 @@
         </p:nvSpPr>
         <p:spPr>
           <a:xfrm>
-            <a:off x="457200" y="4206240"/>
-            <a:ext cx="1552651" cy="347472"/>
+            <a:off x="457200" y="4069080"/>
+            <a:ext cx="1894637" cy="384048"/>
           </a:xfrm>
           <a:prstGeom prst="roundRect">
             <a:avLst>
@@ -6591,11 +6591,11 @@
             </a:avLst>
           </a:prstGeom>
           <a:solidFill>
-            <a:srgbClr val="FFD233"/>
+            <a:srgbClr val="FFFFFF"/>
           </a:solidFill>
           <a:ln w="12700">
             <a:solidFill>
-              <a:srgbClr val="FFD233"/>
+              <a:srgbClr val="FFFFFF"/>
             </a:solidFill>
             <a:prstDash val="solid"/>
           </a:ln>
@@ -6611,8 +6611,8 @@
         </p:nvSpPr>
         <p:spPr>
           <a:xfrm>
-            <a:off x="457200" y="4206240"/>
-            <a:ext cx="1552651" cy="347472"/>
+            <a:off x="457200" y="4069080"/>
+            <a:ext cx="1894637" cy="384048"/>
           </a:xfrm>
           <a:prstGeom prst="rect">
             <a:avLst/>
@@ -6632,9 +6632,9 @@
                 <a:solidFill>
                   <a:srgbClr val="23155C"/>
                 </a:solidFill>
-                <a:latin typeface="Calibri" pitchFamily="34" charset="0"/>
-                <a:ea typeface="Calibri" pitchFamily="34" charset="-122"/>
-                <a:cs typeface="Calibri" pitchFamily="34" charset="-120"/>
+                <a:latin typeface="Arial" pitchFamily="34" charset="0"/>
+                <a:ea typeface="Arial" pitchFamily="34" charset="-122"/>
+                <a:cs typeface="Arial" pitchFamily="34" charset="-120"/>
                 <a:hlinkClick r:id="rId3" invalidUrl="" action="" tgtFrame="" tooltip="" history="1" highlightClick="0" endSnd="0">
                   <a:extLst>
                     <a:ext uri="{A12FA001-AC4F-418D-AE19-62706E023703}">
@@ -6643,7 +6643,7 @@
                   </a:extLst>
                 </a:hlinkClick>
               </a:rPr>
-              <a:t>🔗 Open the profile</a:t>
+              <a:t>Open the profile</a:t>
             </a:r>
             <a:endParaRPr lang="en-US" sz="1100" dirty="0"/>
           </a:p>
@@ -6659,8 +6659,8 @@
         </p:nvSpPr>
         <p:spPr>
           <a:xfrm>
-            <a:off x="2147011" y="4206240"/>
-            <a:ext cx="2194560" cy="347472"/>
+            <a:off x="2488997" y="4069080"/>
+            <a:ext cx="2483510" cy="384048"/>
           </a:xfrm>
           <a:prstGeom prst="roundRect">
             <a:avLst>
@@ -6668,11 +6668,11 @@
             </a:avLst>
           </a:prstGeom>
           <a:solidFill>
-            <a:srgbClr val="FFD233"/>
+            <a:srgbClr val="FFFFFF"/>
           </a:solidFill>
           <a:ln w="12700">
             <a:solidFill>
-              <a:srgbClr val="FFD233"/>
+              <a:srgbClr val="FFFFFF"/>
             </a:solidFill>
             <a:prstDash val="solid"/>
           </a:ln>
@@ -6688,8 +6688,8 @@
         </p:nvSpPr>
         <p:spPr>
           <a:xfrm>
-            <a:off x="2147011" y="4206240"/>
-            <a:ext cx="2194560" cy="347472"/>
+            <a:off x="2488997" y="4069080"/>
+            <a:ext cx="2483510" cy="384048"/>
           </a:xfrm>
           <a:prstGeom prst="rect">
             <a:avLst/>
@@ -6709,9 +6709,9 @@
                 <a:solidFill>
                   <a:srgbClr val="23155C"/>
                 </a:solidFill>
-                <a:latin typeface="Calibri" pitchFamily="34" charset="0"/>
-                <a:ea typeface="Calibri" pitchFamily="34" charset="-122"/>
-                <a:cs typeface="Calibri" pitchFamily="34" charset="-120"/>
+                <a:latin typeface="Arial" pitchFamily="34" charset="0"/>
+                <a:ea typeface="Arial" pitchFamily="34" charset="-122"/>
+                <a:cs typeface="Arial" pitchFamily="34" charset="-120"/>
                 <a:hlinkClick r:id="rId5" invalidUrl="" action="" tgtFrame="" tooltip="" history="1" highlightClick="0" endSnd="0">
                   <a:extLst>
                     <a:ext uri="{A12FA001-AC4F-418D-AE19-62706E023703}">
@@ -6720,7 +6720,7 @@
                   </a:extLst>
                 </a:hlinkClick>
               </a:rPr>
-              <a:t>🔗 All post files + captions</a:t>
+              <a:t>Post files and captions</a:t>
             </a:r>
             <a:endParaRPr lang="en-US" sz="1100" dirty="0"/>
           </a:p>
@@ -6734,7 +6734,7 @@
         </p:nvSpPr>
         <p:spPr>
           <a:xfrm>
-            <a:off x="457200" y="4773168"/>
+            <a:off x="457200" y="4846320"/>
             <a:ext cx="8229600" cy="274320"/>
           </a:xfrm>
           <a:prstGeom prst="rect">
@@ -6755,9 +6755,9 @@
                 <a:solidFill>
                   <a:srgbClr val="A99BE0"/>
                 </a:solidFill>
-                <a:latin typeface="Calibri" pitchFamily="34" charset="0"/>
-                <a:ea typeface="Calibri" pitchFamily="34" charset="-122"/>
-                <a:cs typeface="Calibri" pitchFamily="34" charset="-120"/>
+                <a:latin typeface="Arial" pitchFamily="34" charset="0"/>
+                <a:ea typeface="Arial" pitchFamily="34" charset="-122"/>
+                <a:cs typeface="Arial" pitchFamily="34" charset="-120"/>
               </a:rPr>
               <a:t>@learnwithgenn · praneet-admin.github.io/gengo</a:t>
             </a:r>
@@ -6822,17 +6822,17 @@
               <a:buNone/>
             </a:pPr>
             <a:r>
-              <a:rPr lang="en-US" sz="3400" b="1" dirty="0">
+              <a:rPr lang="en-US" sz="3000" b="1" dirty="0">
                 <a:solidFill>
                   <a:srgbClr val="23155C"/>
                 </a:solidFill>
-                <a:latin typeface="Calibri" pitchFamily="34" charset="0"/>
-                <a:ea typeface="Calibri" pitchFamily="34" charset="-122"/>
-                <a:cs typeface="Calibri" pitchFamily="34" charset="-120"/>
+                <a:latin typeface="Arial" pitchFamily="34" charset="0"/>
+                <a:ea typeface="Arial" pitchFamily="34" charset="-122"/>
+                <a:cs typeface="Arial" pitchFamily="34" charset="-120"/>
               </a:rPr>
               <a:t>Reels</a:t>
             </a:r>
-            <a:endParaRPr lang="en-US" sz="3400" dirty="0"/>
+            <a:endParaRPr lang="en-US" sz="3000" dirty="0"/>
           </a:p>
         </p:txBody>
       </p:sp>
@@ -6851,8 +6851,8 @@
         </p:blipFill>
         <p:spPr>
           <a:xfrm>
-            <a:off x="457200" y="960120"/>
-            <a:ext cx="8229600" cy="3108960"/>
+            <a:off x="457200" y="914400"/>
+            <a:ext cx="8229600" cy="3017520"/>
           </a:xfrm>
           <a:prstGeom prst="rect">
             <a:avLst/>
@@ -6869,8 +6869,8 @@
         </p:nvSpPr>
         <p:spPr>
           <a:xfrm>
-            <a:off x="457200" y="4206240"/>
-            <a:ext cx="1196035" cy="347472"/>
+            <a:off x="457200" y="4069080"/>
+            <a:ext cx="1474013" cy="384048"/>
           </a:xfrm>
           <a:prstGeom prst="roundRect">
             <a:avLst>
@@ -6878,11 +6878,11 @@
             </a:avLst>
           </a:prstGeom>
           <a:solidFill>
-            <a:srgbClr val="23155C"/>
+            <a:srgbClr val="F6F3FF"/>
           </a:solidFill>
           <a:ln w="12700">
             <a:solidFill>
-              <a:srgbClr val="23155C"/>
+              <a:srgbClr val="D9D0F5"/>
             </a:solidFill>
             <a:prstDash val="solid"/>
           </a:ln>
@@ -6898,8 +6898,8 @@
         </p:nvSpPr>
         <p:spPr>
           <a:xfrm>
-            <a:off x="457200" y="4206240"/>
-            <a:ext cx="1196035" cy="347472"/>
+            <a:off x="457200" y="4069080"/>
+            <a:ext cx="1474013" cy="384048"/>
           </a:xfrm>
           <a:prstGeom prst="rect">
             <a:avLst/>
@@ -6917,11 +6917,11 @@
             <a:r>
               <a:rPr lang="en-US" sz="1100" b="1" u="sng" dirty="0">
                 <a:solidFill>
-                  <a:srgbClr val="FFFFFF"/>
-                </a:solidFill>
-                <a:latin typeface="Calibri" pitchFamily="34" charset="0"/>
-                <a:ea typeface="Calibri" pitchFamily="34" charset="-122"/>
-                <a:cs typeface="Calibri" pitchFamily="34" charset="-120"/>
+                  <a:srgbClr val="23155C"/>
+                </a:solidFill>
+                <a:latin typeface="Arial" pitchFamily="34" charset="0"/>
+                <a:ea typeface="Arial" pitchFamily="34" charset="-122"/>
+                <a:cs typeface="Arial" pitchFamily="34" charset="-120"/>
                 <a:hlinkClick r:id="rId3" invalidUrl="" action="" tgtFrame="" tooltip="" history="1" highlightClick="0" endSnd="0">
                   <a:extLst>
                     <a:ext uri="{A12FA001-AC4F-418D-AE19-62706E023703}">
@@ -6930,7 +6930,7 @@
                   </a:extLst>
                 </a:hlinkClick>
               </a:rPr>
-              <a:t>🔗 Launch reel</a:t>
+              <a:t>Launch reel</a:t>
             </a:r>
             <a:endParaRPr lang="en-US" sz="1100" dirty="0"/>
           </a:p>
@@ -6946,8 +6946,8 @@
         </p:nvSpPr>
         <p:spPr>
           <a:xfrm>
-            <a:off x="1790395" y="4206240"/>
-            <a:ext cx="1481328" cy="347472"/>
+            <a:off x="2068373" y="4069080"/>
+            <a:ext cx="1810512" cy="384048"/>
           </a:xfrm>
           <a:prstGeom prst="roundRect">
             <a:avLst>
@@ -6955,11 +6955,11 @@
             </a:avLst>
           </a:prstGeom>
           <a:solidFill>
-            <a:srgbClr val="23155C"/>
+            <a:srgbClr val="F6F3FF"/>
           </a:solidFill>
           <a:ln w="12700">
             <a:solidFill>
-              <a:srgbClr val="23155C"/>
+              <a:srgbClr val="D9D0F5"/>
             </a:solidFill>
             <a:prstDash val="solid"/>
           </a:ln>
@@ -6975,8 +6975,8 @@
         </p:nvSpPr>
         <p:spPr>
           <a:xfrm>
-            <a:off x="1790395" y="4206240"/>
-            <a:ext cx="1481328" cy="347472"/>
+            <a:off x="2068373" y="4069080"/>
+            <a:ext cx="1810512" cy="384048"/>
           </a:xfrm>
           <a:prstGeom prst="rect">
             <a:avLst/>
@@ -6994,11 +6994,11 @@
             <a:r>
               <a:rPr lang="en-US" sz="1100" b="1" u="sng" dirty="0">
                 <a:solidFill>
-                  <a:srgbClr val="FFFFFF"/>
-                </a:solidFill>
-                <a:latin typeface="Calibri" pitchFamily="34" charset="0"/>
-                <a:ea typeface="Calibri" pitchFamily="34" charset="-122"/>
-                <a:cs typeface="Calibri" pitchFamily="34" charset="-120"/>
+                  <a:srgbClr val="23155C"/>
+                </a:solidFill>
+                <a:latin typeface="Arial" pitchFamily="34" charset="0"/>
+                <a:ea typeface="Arial" pitchFamily="34" charset="-122"/>
+                <a:cs typeface="Arial" pitchFamily="34" charset="-120"/>
                 <a:hlinkClick r:id="rId5" invalidUrl="" action="" tgtFrame="" tooltip="" history="1" highlightClick="0" endSnd="0">
                   <a:extLst>
                     <a:ext uri="{A12FA001-AC4F-418D-AE19-62706E023703}">
@@ -7007,7 +7007,7 @@
                   </a:extLst>
                 </a:hlinkClick>
               </a:rPr>
-              <a:t>🔗 Word of the day</a:t>
+              <a:t>Word of the day</a:t>
             </a:r>
             <a:endParaRPr lang="en-US" sz="1100" dirty="0"/>
           </a:p>
@@ -7023,8 +7023,8 @@
         </p:nvSpPr>
         <p:spPr>
           <a:xfrm>
-            <a:off x="3408883" y="4206240"/>
-            <a:ext cx="1837944" cy="347472"/>
+            <a:off x="4016045" y="4069080"/>
+            <a:ext cx="2231136" cy="384048"/>
           </a:xfrm>
           <a:prstGeom prst="roundRect">
             <a:avLst>
@@ -7032,11 +7032,11 @@
             </a:avLst>
           </a:prstGeom>
           <a:solidFill>
-            <a:srgbClr val="23155C"/>
+            <a:srgbClr val="F6F3FF"/>
           </a:solidFill>
           <a:ln w="12700">
             <a:solidFill>
-              <a:srgbClr val="23155C"/>
+              <a:srgbClr val="D9D0F5"/>
             </a:solidFill>
             <a:prstDash val="solid"/>
           </a:ln>
@@ -7052,8 +7052,8 @@
         </p:nvSpPr>
         <p:spPr>
           <a:xfrm>
-            <a:off x="3408883" y="4206240"/>
-            <a:ext cx="1837944" cy="347472"/>
+            <a:off x="4016045" y="4069080"/>
+            <a:ext cx="2231136" cy="384048"/>
           </a:xfrm>
           <a:prstGeom prst="rect">
             <a:avLst/>
@@ -7071,11 +7071,11 @@
             <a:r>
               <a:rPr lang="en-US" sz="1100" b="1" u="sng" dirty="0">
                 <a:solidFill>
-                  <a:srgbClr val="FFFFFF"/>
-                </a:solidFill>
-                <a:latin typeface="Calibri" pitchFamily="34" charset="0"/>
-                <a:ea typeface="Calibri" pitchFamily="34" charset="-122"/>
-                <a:cs typeface="Calibri" pitchFamily="34" charset="-120"/>
+                  <a:srgbClr val="23155C"/>
+                </a:solidFill>
+                <a:latin typeface="Arial" pitchFamily="34" charset="0"/>
+                <a:ea typeface="Arial" pitchFamily="34" charset="-122"/>
+                <a:cs typeface="Arial" pitchFamily="34" charset="-120"/>
                 <a:hlinkClick r:id="rId7" invalidUrl="" action="" tgtFrame="" tooltip="" history="1" highlightClick="0" endSnd="0">
                   <a:extLst>
                     <a:ext uri="{A12FA001-AC4F-418D-AE19-62706E023703}">
@@ -7084,7 +7084,7 @@
                   </a:extLst>
                 </a:hlinkClick>
               </a:rPr>
-              <a:t>🔗 Listen again, slower</a:t>
+              <a:t>Listen again, slower</a:t>
             </a:r>
             <a:endParaRPr lang="en-US" sz="1100" dirty="0"/>
           </a:p>
@@ -7100,8 +7100,8 @@
         </p:nvSpPr>
         <p:spPr>
           <a:xfrm>
-            <a:off x="5383987" y="4206240"/>
-            <a:ext cx="1267358" cy="347472"/>
+            <a:off x="6384341" y="4069080"/>
+            <a:ext cx="1558138" cy="384048"/>
           </a:xfrm>
           <a:prstGeom prst="roundRect">
             <a:avLst>
@@ -7109,11 +7109,11 @@
             </a:avLst>
           </a:prstGeom>
           <a:solidFill>
-            <a:srgbClr val="23155C"/>
+            <a:srgbClr val="F6F3FF"/>
           </a:solidFill>
           <a:ln w="12700">
             <a:solidFill>
-              <a:srgbClr val="23155C"/>
+              <a:srgbClr val="D9D0F5"/>
             </a:solidFill>
             <a:prstDash val="solid"/>
           </a:ln>
@@ -7129,8 +7129,8 @@
         </p:nvSpPr>
         <p:spPr>
           <a:xfrm>
-            <a:off x="5383987" y="4206240"/>
-            <a:ext cx="1267358" cy="347472"/>
+            <a:off x="6384341" y="4069080"/>
+            <a:ext cx="1558138" cy="384048"/>
           </a:xfrm>
           <a:prstGeom prst="rect">
             <a:avLst/>
@@ -7148,11 +7148,11 @@
             <a:r>
               <a:rPr lang="en-US" sz="1100" b="1" u="sng" dirty="0">
                 <a:solidFill>
-                  <a:srgbClr val="FFFFFF"/>
-                </a:solidFill>
-                <a:latin typeface="Calibri" pitchFamily="34" charset="0"/>
-                <a:ea typeface="Calibri" pitchFamily="34" charset="-122"/>
-                <a:cs typeface="Calibri" pitchFamily="34" charset="-120"/>
+                  <a:srgbClr val="23155C"/>
+                </a:solidFill>
+                <a:latin typeface="Arial" pitchFamily="34" charset="0"/>
+                <a:ea typeface="Arial" pitchFamily="34" charset="-122"/>
+                <a:cs typeface="Arial" pitchFamily="34" charset="-120"/>
                 <a:hlinkClick r:id="rId9" invalidUrl="" action="" tgtFrame="" tooltip="" history="1" highlightClick="0" endSnd="0">
                   <a:extLst>
                     <a:ext uri="{A12FA001-AC4F-418D-AE19-62706E023703}">
@@ -7161,7 +7161,7 @@
                   </a:extLst>
                 </a:hlinkClick>
               </a:rPr>
-              <a:t>🔗 Focus Sprint</a:t>
+              <a:t>Focus Sprint</a:t>
             </a:r>
             <a:endParaRPr lang="en-US" sz="1100" dirty="0"/>
           </a:p>
@@ -7175,7 +7175,7 @@
         </p:nvSpPr>
         <p:spPr>
           <a:xfrm>
-            <a:off x="457200" y="4773168"/>
+            <a:off x="457200" y="4846320"/>
             <a:ext cx="8229600" cy="274320"/>
           </a:xfrm>
           <a:prstGeom prst="rect">
@@ -7196,9 +7196,9 @@
                 <a:solidFill>
                   <a:srgbClr val="8B84AD"/>
                 </a:solidFill>
-                <a:latin typeface="Calibri" pitchFamily="34" charset="0"/>
-                <a:ea typeface="Calibri" pitchFamily="34" charset="-122"/>
-                <a:cs typeface="Calibri" pitchFamily="34" charset="-120"/>
+                <a:latin typeface="Arial" pitchFamily="34" charset="0"/>
+                <a:ea typeface="Arial" pitchFamily="34" charset="-122"/>
+                <a:cs typeface="Arial" pitchFamily="34" charset="-120"/>
               </a:rPr>
               <a:t>@learnwithgenn · praneet-admin.github.io/gengo</a:t>
             </a:r>
@@ -7263,17 +7263,17 @@
               <a:buNone/>
             </a:pPr>
             <a:r>
-              <a:rPr lang="en-US" sz="3400" b="1" dirty="0">
+              <a:rPr lang="en-US" sz="3000" b="1" dirty="0">
                 <a:solidFill>
                   <a:srgbClr val="23155C"/>
                 </a:solidFill>
-                <a:latin typeface="Calibri" pitchFamily="34" charset="0"/>
-                <a:ea typeface="Calibri" pitchFamily="34" charset="-122"/>
-                <a:cs typeface="Calibri" pitchFamily="34" charset="-120"/>
+                <a:latin typeface="Arial" pitchFamily="34" charset="0"/>
+                <a:ea typeface="Arial" pitchFamily="34" charset="-122"/>
+                <a:cs typeface="Arial" pitchFamily="34" charset="-120"/>
               </a:rPr>
               <a:t>Carousels</a:t>
             </a:r>
-            <a:endParaRPr lang="en-US" sz="3400" dirty="0"/>
+            <a:endParaRPr lang="en-US" sz="3000" dirty="0"/>
           </a:p>
         </p:txBody>
       </p:sp>
@@ -7292,8 +7292,8 @@
         </p:blipFill>
         <p:spPr>
           <a:xfrm>
-            <a:off x="457200" y="1005840"/>
-            <a:ext cx="8229600" cy="3063240"/>
+            <a:off x="457200" y="914400"/>
+            <a:ext cx="8229600" cy="3017520"/>
           </a:xfrm>
           <a:prstGeom prst="rect">
             <a:avLst/>
@@ -7310,8 +7310,8 @@
         </p:nvSpPr>
         <p:spPr>
           <a:xfrm>
-            <a:off x="457200" y="4206240"/>
-            <a:ext cx="2051914" cy="347472"/>
+            <a:off x="457200" y="4069080"/>
+            <a:ext cx="2483510" cy="384048"/>
           </a:xfrm>
           <a:prstGeom prst="roundRect">
             <a:avLst>
@@ -7319,11 +7319,11 @@
             </a:avLst>
           </a:prstGeom>
           <a:solidFill>
-            <a:srgbClr val="23155C"/>
+            <a:srgbClr val="F6F3FF"/>
           </a:solidFill>
           <a:ln w="12700">
             <a:solidFill>
-              <a:srgbClr val="23155C"/>
+              <a:srgbClr val="D9D0F5"/>
             </a:solidFill>
             <a:prstDash val="solid"/>
           </a:ln>
@@ -7339,8 +7339,8 @@
         </p:nvSpPr>
         <p:spPr>
           <a:xfrm>
-            <a:off x="457200" y="4206240"/>
-            <a:ext cx="2051914" cy="347472"/>
+            <a:off x="457200" y="4069080"/>
+            <a:ext cx="2483510" cy="384048"/>
           </a:xfrm>
           <a:prstGeom prst="rect">
             <a:avLst/>
@@ -7358,11 +7358,11 @@
             <a:r>
               <a:rPr lang="en-US" sz="1100" b="1" u="sng" dirty="0">
                 <a:solidFill>
-                  <a:srgbClr val="FFFFFF"/>
-                </a:solidFill>
-                <a:latin typeface="Calibri" pitchFamily="34" charset="0"/>
-                <a:ea typeface="Calibri" pitchFamily="34" charset="-122"/>
-                <a:cs typeface="Calibri" pitchFamily="34" charset="-120"/>
+                  <a:srgbClr val="23155C"/>
+                </a:solidFill>
+                <a:latin typeface="Arial" pitchFamily="34" charset="0"/>
+                <a:ea typeface="Arial" pitchFamily="34" charset="-122"/>
+                <a:cs typeface="Arial" pitchFamily="34" charset="-120"/>
                 <a:hlinkClick r:id="rId3" invalidUrl="" action="" tgtFrame="" tooltip="" history="1" highlightClick="0" endSnd="0">
                   <a:extLst>
                     <a:ext uri="{A12FA001-AC4F-418D-AE19-62706E023703}">
@@ -7371,7 +7371,7 @@
                   </a:extLst>
                 </a:hlinkClick>
               </a:rPr>
-              <a:t>🔗 7 words for an HR round</a:t>
+              <a:t>7 words for an HR round</a:t>
             </a:r>
             <a:endParaRPr lang="en-US" sz="1100" dirty="0"/>
           </a:p>
@@ -7387,8 +7387,8 @@
         </p:nvSpPr>
         <p:spPr>
           <a:xfrm>
-            <a:off x="2646274" y="4206240"/>
-            <a:ext cx="2337206" cy="347472"/>
+            <a:off x="3077870" y="4069080"/>
+            <a:ext cx="2820010" cy="384048"/>
           </a:xfrm>
           <a:prstGeom prst="roundRect">
             <a:avLst>
@@ -7396,11 +7396,11 @@
             </a:avLst>
           </a:prstGeom>
           <a:solidFill>
-            <a:srgbClr val="23155C"/>
+            <a:srgbClr val="F6F3FF"/>
           </a:solidFill>
           <a:ln w="12700">
             <a:solidFill>
-              <a:srgbClr val="23155C"/>
+              <a:srgbClr val="D9D0F5"/>
             </a:solidFill>
             <a:prstDash val="solid"/>
           </a:ln>
@@ -7416,8 +7416,8 @@
         </p:nvSpPr>
         <p:spPr>
           <a:xfrm>
-            <a:off x="2646274" y="4206240"/>
-            <a:ext cx="2337206" cy="347472"/>
+            <a:off x="3077870" y="4069080"/>
+            <a:ext cx="2820010" cy="384048"/>
           </a:xfrm>
           <a:prstGeom prst="rect">
             <a:avLst/>
@@ -7435,11 +7435,11 @@
             <a:r>
               <a:rPr lang="en-US" sz="1100" b="1" u="sng" dirty="0">
                 <a:solidFill>
-                  <a:srgbClr val="FFFFFF"/>
-                </a:solidFill>
-                <a:latin typeface="Calibri" pitchFamily="34" charset="0"/>
-                <a:ea typeface="Calibri" pitchFamily="34" charset="-122"/>
-                <a:cs typeface="Calibri" pitchFamily="34" charset="-120"/>
+                  <a:srgbClr val="23155C"/>
+                </a:solidFill>
+                <a:latin typeface="Arial" pitchFamily="34" charset="0"/>
+                <a:ea typeface="Arial" pitchFamily="34" charset="-122"/>
+                <a:cs typeface="Arial" pitchFamily="34" charset="-120"/>
                 <a:hlinkClick r:id="rId5" invalidUrl="" action="" tgtFrame="" tooltip="" history="1" highlightClick="0" endSnd="0">
                   <a:extLst>
                     <a:ext uri="{A12FA001-AC4F-418D-AE19-62706E023703}">
@@ -7448,7 +7448,7 @@
                   </a:extLst>
                 </a:hlinkClick>
               </a:rPr>
-              <a:t>🔗 5 words you’re saying wrong</a:t>
+              <a:t>5 words you’re saying wrong</a:t>
             </a:r>
             <a:endParaRPr lang="en-US" sz="1100" dirty="0"/>
           </a:p>
@@ -7464,8 +7464,8 @@
         </p:nvSpPr>
         <p:spPr>
           <a:xfrm>
-            <a:off x="5120640" y="4206240"/>
-            <a:ext cx="1552651" cy="347472"/>
+            <a:off x="6035040" y="4069080"/>
+            <a:ext cx="1894637" cy="384048"/>
           </a:xfrm>
           <a:prstGeom prst="roundRect">
             <a:avLst>
@@ -7473,11 +7473,11 @@
             </a:avLst>
           </a:prstGeom>
           <a:solidFill>
-            <a:srgbClr val="23155C"/>
+            <a:srgbClr val="F6F3FF"/>
           </a:solidFill>
           <a:ln w="12700">
             <a:solidFill>
-              <a:srgbClr val="23155C"/>
+              <a:srgbClr val="D9D0F5"/>
             </a:solidFill>
             <a:prstDash val="solid"/>
           </a:ln>
@@ -7493,8 +7493,8 @@
         </p:nvSpPr>
         <p:spPr>
           <a:xfrm>
-            <a:off x="5120640" y="4206240"/>
-            <a:ext cx="1552651" cy="347472"/>
+            <a:off x="6035040" y="4069080"/>
+            <a:ext cx="1894637" cy="384048"/>
           </a:xfrm>
           <a:prstGeom prst="rect">
             <a:avLst/>
@@ -7512,11 +7512,11 @@
             <a:r>
               <a:rPr lang="en-US" sz="1100" b="1" u="sng" dirty="0">
                 <a:solidFill>
-                  <a:srgbClr val="FFFFFF"/>
-                </a:solidFill>
-                <a:latin typeface="Calibri" pitchFamily="34" charset="0"/>
-                <a:ea typeface="Calibri" pitchFamily="34" charset="-122"/>
-                <a:cs typeface="Calibri" pitchFamily="34" charset="-120"/>
+                  <a:srgbClr val="23155C"/>
+                </a:solidFill>
+                <a:latin typeface="Arial" pitchFamily="34" charset="0"/>
+                <a:ea typeface="Arial" pitchFamily="34" charset="-122"/>
+                <a:cs typeface="Arial" pitchFamily="34" charset="-120"/>
                 <a:hlinkClick r:id="rId7" invalidUrl="" action="" tgtFrame="" tooltip="" history="1" highlightClick="0" endSnd="0">
                   <a:extLst>
                     <a:ext uri="{A12FA001-AC4F-418D-AE19-62706E023703}">
@@ -7525,7 +7525,7 @@
                   </a:extLst>
                 </a:hlinkClick>
               </a:rPr>
-              <a:t>🔗 Gengo in 4 steps</a:t>
+              <a:t>Gengo in 4 steps</a:t>
             </a:r>
             <a:endParaRPr lang="en-US" sz="1100" dirty="0"/>
           </a:p>
@@ -7539,7 +7539,7 @@
         </p:nvSpPr>
         <p:spPr>
           <a:xfrm>
-            <a:off x="457200" y="4773168"/>
+            <a:off x="457200" y="4846320"/>
             <a:ext cx="8229600" cy="274320"/>
           </a:xfrm>
           <a:prstGeom prst="rect">
@@ -7560,9 +7560,9 @@
                 <a:solidFill>
                   <a:srgbClr val="8B84AD"/>
                 </a:solidFill>
-                <a:latin typeface="Calibri" pitchFamily="34" charset="0"/>
-                <a:ea typeface="Calibri" pitchFamily="34" charset="-122"/>
-                <a:cs typeface="Calibri" pitchFamily="34" charset="-120"/>
+                <a:latin typeface="Arial" pitchFamily="34" charset="0"/>
+                <a:ea typeface="Arial" pitchFamily="34" charset="-122"/>
+                <a:cs typeface="Arial" pitchFamily="34" charset="-120"/>
               </a:rPr>
               <a:t>@learnwithgenn · praneet-admin.github.io/gengo</a:t>
             </a:r>

</xml_diff>